<commit_message>
Arduino Lesson Prepare #2
</commit_message>
<xml_diff>
--- a/material/Arduino/02_아두이노 활용하기 1.pptx
+++ b/material/Arduino/02_아두이노 활용하기 1.pptx
@@ -5,7 +5,7 @@
     <p:sldMasterId id="2147483661" r:id="rId1"/>
   </p:sldMasterIdLst>
   <p:notesMasterIdLst>
-    <p:notesMasterId r:id="rId57"/>
+    <p:notesMasterId r:id="rId58"/>
   </p:notesMasterIdLst>
   <p:sldIdLst>
     <p:sldId id="1004" r:id="rId2"/>
@@ -37,32 +37,33 @@
     <p:sldId id="1060" r:id="rId28"/>
     <p:sldId id="1061" r:id="rId29"/>
     <p:sldId id="1062" r:id="rId30"/>
-    <p:sldId id="1063" r:id="rId31"/>
-    <p:sldId id="1065" r:id="rId32"/>
-    <p:sldId id="1066" r:id="rId33"/>
-    <p:sldId id="1051" r:id="rId34"/>
-    <p:sldId id="1067" r:id="rId35"/>
-    <p:sldId id="1068" r:id="rId36"/>
-    <p:sldId id="1069" r:id="rId37"/>
-    <p:sldId id="1070" r:id="rId38"/>
-    <p:sldId id="1071" r:id="rId39"/>
-    <p:sldId id="1072" r:id="rId40"/>
-    <p:sldId id="1073" r:id="rId41"/>
-    <p:sldId id="1064" r:id="rId42"/>
-    <p:sldId id="1074" r:id="rId43"/>
-    <p:sldId id="1075" r:id="rId44"/>
-    <p:sldId id="1076" r:id="rId45"/>
-    <p:sldId id="1077" r:id="rId46"/>
-    <p:sldId id="1079" r:id="rId47"/>
-    <p:sldId id="1080" r:id="rId48"/>
-    <p:sldId id="1081" r:id="rId49"/>
-    <p:sldId id="1082" r:id="rId50"/>
-    <p:sldId id="1083" r:id="rId51"/>
-    <p:sldId id="1084" r:id="rId52"/>
-    <p:sldId id="1085" r:id="rId53"/>
-    <p:sldId id="1089" r:id="rId54"/>
-    <p:sldId id="1086" r:id="rId55"/>
-    <p:sldId id="1087" r:id="rId56"/>
+    <p:sldId id="1090" r:id="rId31"/>
+    <p:sldId id="1063" r:id="rId32"/>
+    <p:sldId id="1065" r:id="rId33"/>
+    <p:sldId id="1066" r:id="rId34"/>
+    <p:sldId id="1051" r:id="rId35"/>
+    <p:sldId id="1067" r:id="rId36"/>
+    <p:sldId id="1068" r:id="rId37"/>
+    <p:sldId id="1069" r:id="rId38"/>
+    <p:sldId id="1070" r:id="rId39"/>
+    <p:sldId id="1071" r:id="rId40"/>
+    <p:sldId id="1072" r:id="rId41"/>
+    <p:sldId id="1073" r:id="rId42"/>
+    <p:sldId id="1064" r:id="rId43"/>
+    <p:sldId id="1074" r:id="rId44"/>
+    <p:sldId id="1075" r:id="rId45"/>
+    <p:sldId id="1076" r:id="rId46"/>
+    <p:sldId id="1077" r:id="rId47"/>
+    <p:sldId id="1079" r:id="rId48"/>
+    <p:sldId id="1080" r:id="rId49"/>
+    <p:sldId id="1081" r:id="rId50"/>
+    <p:sldId id="1082" r:id="rId51"/>
+    <p:sldId id="1083" r:id="rId52"/>
+    <p:sldId id="1084" r:id="rId53"/>
+    <p:sldId id="1085" r:id="rId54"/>
+    <p:sldId id="1089" r:id="rId55"/>
+    <p:sldId id="1086" r:id="rId56"/>
+    <p:sldId id="1087" r:id="rId57"/>
   </p:sldIdLst>
   <p:sldSz cx="12192000" cy="6858000"/>
   <p:notesSz cx="6858000" cy="9144000"/>
@@ -254,7 +255,7 @@
           <a:p>
             <a:fld id="{31A4D7BB-9D09-4DB4-979A-1857C46342D6}" type="datetimeFigureOut">
               <a:rPr lang="ko-KR" altLang="en-US" smtClean="0"/>
-              <a:t>2025-10-23</a:t>
+              <a:t>2025-10-24</a:t>
             </a:fld>
             <a:endParaRPr lang="ko-KR" altLang="en-US"/>
           </a:p>
@@ -5326,7 +5327,7 @@
         <p:cNvPr id="1" name="">
           <a:extLst>
             <a:ext uri="{FF2B5EF4-FFF2-40B4-BE49-F238E27FC236}">
-              <a16:creationId xmlns:a16="http://schemas.microsoft.com/office/drawing/2014/main" id="{CD6F6FFF-2B4D-BFD3-2C52-45F560E22CE5}"/>
+              <a16:creationId xmlns:a16="http://schemas.microsoft.com/office/drawing/2014/main" id="{046341CE-227F-DC9F-4F1D-C6C2AB2B91CB}"/>
             </a:ext>
           </a:extLst>
         </p:cNvPr>
@@ -5346,7 +5347,7 @@
           <p:cNvPr id="2" name="슬라이드 이미지 개체 틀 1">
             <a:extLst>
               <a:ext uri="{FF2B5EF4-FFF2-40B4-BE49-F238E27FC236}">
-                <a16:creationId xmlns:a16="http://schemas.microsoft.com/office/drawing/2014/main" id="{0981FCA4-D1D6-E0DE-4471-AF9543FF6150}"/>
+                <a16:creationId xmlns:a16="http://schemas.microsoft.com/office/drawing/2014/main" id="{6EA6DAEC-7362-D5C8-22B0-399F6DC497ED}"/>
               </a:ext>
             </a:extLst>
           </p:cNvPr>
@@ -5364,7 +5365,7 @@
           <p:cNvPr id="3" name="슬라이드 노트 개체 틀 2">
             <a:extLst>
               <a:ext uri="{FF2B5EF4-FFF2-40B4-BE49-F238E27FC236}">
-                <a16:creationId xmlns:a16="http://schemas.microsoft.com/office/drawing/2014/main" id="{30E26F88-8C69-9F0C-3EFE-F65CD4AAD433}"/>
+                <a16:creationId xmlns:a16="http://schemas.microsoft.com/office/drawing/2014/main" id="{03D0A6F8-4723-C42E-5254-BF2375F1BC5C}"/>
               </a:ext>
             </a:extLst>
           </p:cNvPr>
@@ -5413,7 +5414,7 @@
           <p:cNvPr id="4" name="슬라이드 번호 개체 틀 3">
             <a:extLst>
               <a:ext uri="{FF2B5EF4-FFF2-40B4-BE49-F238E27FC236}">
-                <a16:creationId xmlns:a16="http://schemas.microsoft.com/office/drawing/2014/main" id="{A1C69550-261A-BD0B-5E29-D4BC0CF3F9DA}"/>
+                <a16:creationId xmlns:a16="http://schemas.microsoft.com/office/drawing/2014/main" id="{DA113E97-F2CC-719A-FACA-57DAA83F03F3}"/>
               </a:ext>
             </a:extLst>
           </p:cNvPr>
@@ -5440,7 +5441,7 @@
     </p:spTree>
     <p:extLst>
       <p:ext uri="{BB962C8B-B14F-4D97-AF65-F5344CB8AC3E}">
-        <p14:creationId xmlns:p14="http://schemas.microsoft.com/office/powerpoint/2010/main" val="3681486706"/>
+        <p14:creationId xmlns:p14="http://schemas.microsoft.com/office/powerpoint/2010/main" val="2746328501"/>
       </p:ext>
     </p:extLst>
   </p:cSld>
@@ -5458,7 +5459,7 @@
         <p:cNvPr id="1" name="">
           <a:extLst>
             <a:ext uri="{FF2B5EF4-FFF2-40B4-BE49-F238E27FC236}">
-              <a16:creationId xmlns:a16="http://schemas.microsoft.com/office/drawing/2014/main" id="{9D410B09-EE6F-DE88-7E51-B6E5E1214017}"/>
+              <a16:creationId xmlns:a16="http://schemas.microsoft.com/office/drawing/2014/main" id="{CD6F6FFF-2B4D-BFD3-2C52-45F560E22CE5}"/>
             </a:ext>
           </a:extLst>
         </p:cNvPr>
@@ -5478,7 +5479,7 @@
           <p:cNvPr id="2" name="슬라이드 이미지 개체 틀 1">
             <a:extLst>
               <a:ext uri="{FF2B5EF4-FFF2-40B4-BE49-F238E27FC236}">
-                <a16:creationId xmlns:a16="http://schemas.microsoft.com/office/drawing/2014/main" id="{26ABAC7D-C9B7-6869-C258-22467E8D5B7A}"/>
+                <a16:creationId xmlns:a16="http://schemas.microsoft.com/office/drawing/2014/main" id="{0981FCA4-D1D6-E0DE-4471-AF9543FF6150}"/>
               </a:ext>
             </a:extLst>
           </p:cNvPr>
@@ -5496,7 +5497,7 @@
           <p:cNvPr id="3" name="슬라이드 노트 개체 틀 2">
             <a:extLst>
               <a:ext uri="{FF2B5EF4-FFF2-40B4-BE49-F238E27FC236}">
-                <a16:creationId xmlns:a16="http://schemas.microsoft.com/office/drawing/2014/main" id="{51B81823-299A-3762-5FCA-72C478AC9198}"/>
+                <a16:creationId xmlns:a16="http://schemas.microsoft.com/office/drawing/2014/main" id="{30E26F88-8C69-9F0C-3EFE-F65CD4AAD433}"/>
               </a:ext>
             </a:extLst>
           </p:cNvPr>
@@ -5545,7 +5546,7 @@
           <p:cNvPr id="4" name="슬라이드 번호 개체 틀 3">
             <a:extLst>
               <a:ext uri="{FF2B5EF4-FFF2-40B4-BE49-F238E27FC236}">
-                <a16:creationId xmlns:a16="http://schemas.microsoft.com/office/drawing/2014/main" id="{50D8DF1B-E07C-7532-8564-0D4EBD95EB0D}"/>
+                <a16:creationId xmlns:a16="http://schemas.microsoft.com/office/drawing/2014/main" id="{A1C69550-261A-BD0B-5E29-D4BC0CF3F9DA}"/>
               </a:ext>
             </a:extLst>
           </p:cNvPr>
@@ -5572,7 +5573,7 @@
     </p:spTree>
     <p:extLst>
       <p:ext uri="{BB962C8B-B14F-4D97-AF65-F5344CB8AC3E}">
-        <p14:creationId xmlns:p14="http://schemas.microsoft.com/office/powerpoint/2010/main" val="4106349905"/>
+        <p14:creationId xmlns:p14="http://schemas.microsoft.com/office/powerpoint/2010/main" val="3681486706"/>
       </p:ext>
     </p:extLst>
   </p:cSld>
@@ -5590,7 +5591,7 @@
         <p:cNvPr id="1" name="">
           <a:extLst>
             <a:ext uri="{FF2B5EF4-FFF2-40B4-BE49-F238E27FC236}">
-              <a16:creationId xmlns:a16="http://schemas.microsoft.com/office/drawing/2014/main" id="{7D95DD06-F08A-77F7-9BE7-310EFB57AFB1}"/>
+              <a16:creationId xmlns:a16="http://schemas.microsoft.com/office/drawing/2014/main" id="{9D410B09-EE6F-DE88-7E51-B6E5E1214017}"/>
             </a:ext>
           </a:extLst>
         </p:cNvPr>
@@ -5610,7 +5611,7 @@
           <p:cNvPr id="2" name="슬라이드 이미지 개체 틀 1">
             <a:extLst>
               <a:ext uri="{FF2B5EF4-FFF2-40B4-BE49-F238E27FC236}">
-                <a16:creationId xmlns:a16="http://schemas.microsoft.com/office/drawing/2014/main" id="{FC34E616-8665-337F-C6C5-D1BCB5B257AA}"/>
+                <a16:creationId xmlns:a16="http://schemas.microsoft.com/office/drawing/2014/main" id="{26ABAC7D-C9B7-6869-C258-22467E8D5B7A}"/>
               </a:ext>
             </a:extLst>
           </p:cNvPr>
@@ -5628,7 +5629,7 @@
           <p:cNvPr id="3" name="슬라이드 노트 개체 틀 2">
             <a:extLst>
               <a:ext uri="{FF2B5EF4-FFF2-40B4-BE49-F238E27FC236}">
-                <a16:creationId xmlns:a16="http://schemas.microsoft.com/office/drawing/2014/main" id="{651E566A-FF91-B8EA-BE9C-364EB1569BE6}"/>
+                <a16:creationId xmlns:a16="http://schemas.microsoft.com/office/drawing/2014/main" id="{51B81823-299A-3762-5FCA-72C478AC9198}"/>
               </a:ext>
             </a:extLst>
           </p:cNvPr>
@@ -5677,7 +5678,7 @@
           <p:cNvPr id="4" name="슬라이드 번호 개체 틀 3">
             <a:extLst>
               <a:ext uri="{FF2B5EF4-FFF2-40B4-BE49-F238E27FC236}">
-                <a16:creationId xmlns:a16="http://schemas.microsoft.com/office/drawing/2014/main" id="{A2EE1A85-1AEE-4B8D-77C4-ED114B4D2548}"/>
+                <a16:creationId xmlns:a16="http://schemas.microsoft.com/office/drawing/2014/main" id="{50D8DF1B-E07C-7532-8564-0D4EBD95EB0D}"/>
               </a:ext>
             </a:extLst>
           </p:cNvPr>
@@ -5704,7 +5705,7 @@
     </p:spTree>
     <p:extLst>
       <p:ext uri="{BB962C8B-B14F-4D97-AF65-F5344CB8AC3E}">
-        <p14:creationId xmlns:p14="http://schemas.microsoft.com/office/powerpoint/2010/main" val="3063466307"/>
+        <p14:creationId xmlns:p14="http://schemas.microsoft.com/office/powerpoint/2010/main" val="4106349905"/>
       </p:ext>
     </p:extLst>
   </p:cSld>
@@ -5722,7 +5723,7 @@
         <p:cNvPr id="1" name="">
           <a:extLst>
             <a:ext uri="{FF2B5EF4-FFF2-40B4-BE49-F238E27FC236}">
-              <a16:creationId xmlns:a16="http://schemas.microsoft.com/office/drawing/2014/main" id="{C620A808-063F-DB54-33D7-5E772234325E}"/>
+              <a16:creationId xmlns:a16="http://schemas.microsoft.com/office/drawing/2014/main" id="{7D95DD06-F08A-77F7-9BE7-310EFB57AFB1}"/>
             </a:ext>
           </a:extLst>
         </p:cNvPr>
@@ -5742,7 +5743,7 @@
           <p:cNvPr id="2" name="슬라이드 이미지 개체 틀 1">
             <a:extLst>
               <a:ext uri="{FF2B5EF4-FFF2-40B4-BE49-F238E27FC236}">
-                <a16:creationId xmlns:a16="http://schemas.microsoft.com/office/drawing/2014/main" id="{CFF4FEF9-6C7C-8C98-1A4E-EB0A88BA0633}"/>
+                <a16:creationId xmlns:a16="http://schemas.microsoft.com/office/drawing/2014/main" id="{FC34E616-8665-337F-C6C5-D1BCB5B257AA}"/>
               </a:ext>
             </a:extLst>
           </p:cNvPr>
@@ -5760,562 +5761,7 @@
           <p:cNvPr id="3" name="슬라이드 노트 개체 틀 2">
             <a:extLst>
               <a:ext uri="{FF2B5EF4-FFF2-40B4-BE49-F238E27FC236}">
-                <a16:creationId xmlns:a16="http://schemas.microsoft.com/office/drawing/2014/main" id="{14C5842B-61C3-F015-8668-DFF806E30055}"/>
-              </a:ext>
-            </a:extLst>
-          </p:cNvPr>
-          <p:cNvSpPr>
-            <a:spLocks noGrp="1"/>
-          </p:cNvSpPr>
-          <p:nvPr>
-            <p:ph type="body" idx="1"/>
-          </p:nvPr>
-        </p:nvSpPr>
-        <p:spPr/>
-        <p:txBody>
-          <a:bodyPr/>
-          <a:lstStyle/>
-          <a:p>
-            <a:r>
-              <a:rPr lang="ko-KR" altLang="en-US" dirty="0"/>
-              <a:t>프로그래밍</a:t>
-            </a:r>
-          </a:p>
-        </p:txBody>
-      </p:sp>
-      <p:sp>
-        <p:nvSpPr>
-          <p:cNvPr id="4" name="슬라이드 번호 개체 틀 3">
-            <a:extLst>
-              <a:ext uri="{FF2B5EF4-FFF2-40B4-BE49-F238E27FC236}">
-                <a16:creationId xmlns:a16="http://schemas.microsoft.com/office/drawing/2014/main" id="{A1F6FAF8-14D7-CB3D-C7F2-64383532AF55}"/>
-              </a:ext>
-            </a:extLst>
-          </p:cNvPr>
-          <p:cNvSpPr>
-            <a:spLocks noGrp="1"/>
-          </p:cNvSpPr>
-          <p:nvPr>
-            <p:ph type="sldNum" sz="quarter" idx="5"/>
-          </p:nvPr>
-        </p:nvSpPr>
-        <p:spPr/>
-        <p:txBody>
-          <a:bodyPr/>
-          <a:lstStyle/>
-          <a:p>
-            <a:fld id="{3599D024-DE68-44ED-822F-D827F84FBD4A}" type="slidenum">
-              <a:rPr lang="ko-KR" altLang="en-US" smtClean="0"/>
-              <a:t>33</a:t>
-            </a:fld>
-            <a:endParaRPr lang="ko-KR" altLang="en-US"/>
-          </a:p>
-        </p:txBody>
-      </p:sp>
-    </p:spTree>
-    <p:extLst>
-      <p:ext uri="{BB962C8B-B14F-4D97-AF65-F5344CB8AC3E}">
-        <p14:creationId xmlns:p14="http://schemas.microsoft.com/office/powerpoint/2010/main" val="243182125"/>
-      </p:ext>
-    </p:extLst>
-  </p:cSld>
-  <p:clrMapOvr>
-    <a:masterClrMapping/>
-  </p:clrMapOvr>
-</p:notes>
-</file>
-
-<file path=ppt/notesSlides/notesSlide34.xml><?xml version="1.0" encoding="utf-8"?>
-<p:notes xmlns:a="http://schemas.openxmlformats.org/drawingml/2006/main" xmlns:r="http://schemas.openxmlformats.org/officeDocument/2006/relationships" xmlns:p="http://schemas.openxmlformats.org/presentationml/2006/main">
-  <p:cSld>
-    <p:spTree>
-      <p:nvGrpSpPr>
-        <p:cNvPr id="1" name="">
-          <a:extLst>
-            <a:ext uri="{FF2B5EF4-FFF2-40B4-BE49-F238E27FC236}">
-              <a16:creationId xmlns:a16="http://schemas.microsoft.com/office/drawing/2014/main" id="{6443BF75-70E2-E261-2D7C-56EAD45275F8}"/>
-            </a:ext>
-          </a:extLst>
-        </p:cNvPr>
-        <p:cNvGrpSpPr/>
-        <p:nvPr/>
-      </p:nvGrpSpPr>
-      <p:grpSpPr>
-        <a:xfrm>
-          <a:off x="0" y="0"/>
-          <a:ext cx="0" cy="0"/>
-          <a:chOff x="0" y="0"/>
-          <a:chExt cx="0" cy="0"/>
-        </a:xfrm>
-      </p:grpSpPr>
-      <p:sp>
-        <p:nvSpPr>
-          <p:cNvPr id="2" name="슬라이드 이미지 개체 틀 1">
-            <a:extLst>
-              <a:ext uri="{FF2B5EF4-FFF2-40B4-BE49-F238E27FC236}">
-                <a16:creationId xmlns:a16="http://schemas.microsoft.com/office/drawing/2014/main" id="{BC5021E9-121C-84BF-DF58-7D3E3B6E2910}"/>
-              </a:ext>
-            </a:extLst>
-          </p:cNvPr>
-          <p:cNvSpPr>
-            <a:spLocks noGrp="1" noRot="1" noChangeAspect="1"/>
-          </p:cNvSpPr>
-          <p:nvPr>
-            <p:ph type="sldImg"/>
-          </p:nvPr>
-        </p:nvSpPr>
-        <p:spPr/>
-      </p:sp>
-      <p:sp>
-        <p:nvSpPr>
-          <p:cNvPr id="3" name="슬라이드 노트 개체 틀 2">
-            <a:extLst>
-              <a:ext uri="{FF2B5EF4-FFF2-40B4-BE49-F238E27FC236}">
-                <a16:creationId xmlns:a16="http://schemas.microsoft.com/office/drawing/2014/main" id="{89CDE9D5-29C0-07AA-FCD8-51E7250605C6}"/>
-              </a:ext>
-            </a:extLst>
-          </p:cNvPr>
-          <p:cNvSpPr>
-            <a:spLocks noGrp="1"/>
-          </p:cNvSpPr>
-          <p:nvPr>
-            <p:ph type="body" idx="1"/>
-          </p:nvPr>
-        </p:nvSpPr>
-        <p:spPr/>
-        <p:txBody>
-          <a:bodyPr/>
-          <a:lstStyle/>
-          <a:p>
-            <a:r>
-              <a:rPr lang="ko-KR" altLang="en-US" dirty="0"/>
-              <a:t>프로그래밍</a:t>
-            </a:r>
-          </a:p>
-        </p:txBody>
-      </p:sp>
-      <p:sp>
-        <p:nvSpPr>
-          <p:cNvPr id="4" name="슬라이드 번호 개체 틀 3">
-            <a:extLst>
-              <a:ext uri="{FF2B5EF4-FFF2-40B4-BE49-F238E27FC236}">
-                <a16:creationId xmlns:a16="http://schemas.microsoft.com/office/drawing/2014/main" id="{7378B32B-E66D-C9B0-8310-D65B0D309C44}"/>
-              </a:ext>
-            </a:extLst>
-          </p:cNvPr>
-          <p:cNvSpPr>
-            <a:spLocks noGrp="1"/>
-          </p:cNvSpPr>
-          <p:nvPr>
-            <p:ph type="sldNum" sz="quarter" idx="5"/>
-          </p:nvPr>
-        </p:nvSpPr>
-        <p:spPr/>
-        <p:txBody>
-          <a:bodyPr/>
-          <a:lstStyle/>
-          <a:p>
-            <a:fld id="{3599D024-DE68-44ED-822F-D827F84FBD4A}" type="slidenum">
-              <a:rPr lang="ko-KR" altLang="en-US" smtClean="0"/>
-              <a:t>34</a:t>
-            </a:fld>
-            <a:endParaRPr lang="ko-KR" altLang="en-US"/>
-          </a:p>
-        </p:txBody>
-      </p:sp>
-    </p:spTree>
-    <p:extLst>
-      <p:ext uri="{BB962C8B-B14F-4D97-AF65-F5344CB8AC3E}">
-        <p14:creationId xmlns:p14="http://schemas.microsoft.com/office/powerpoint/2010/main" val="2390852696"/>
-      </p:ext>
-    </p:extLst>
-  </p:cSld>
-  <p:clrMapOvr>
-    <a:masterClrMapping/>
-  </p:clrMapOvr>
-</p:notes>
-</file>
-
-<file path=ppt/notesSlides/notesSlide35.xml><?xml version="1.0" encoding="utf-8"?>
-<p:notes xmlns:a="http://schemas.openxmlformats.org/drawingml/2006/main" xmlns:r="http://schemas.openxmlformats.org/officeDocument/2006/relationships" xmlns:p="http://schemas.openxmlformats.org/presentationml/2006/main">
-  <p:cSld>
-    <p:spTree>
-      <p:nvGrpSpPr>
-        <p:cNvPr id="1" name="">
-          <a:extLst>
-            <a:ext uri="{FF2B5EF4-FFF2-40B4-BE49-F238E27FC236}">
-              <a16:creationId xmlns:a16="http://schemas.microsoft.com/office/drawing/2014/main" id="{D3BA3E55-B894-420A-7F3C-517D830490D5}"/>
-            </a:ext>
-          </a:extLst>
-        </p:cNvPr>
-        <p:cNvGrpSpPr/>
-        <p:nvPr/>
-      </p:nvGrpSpPr>
-      <p:grpSpPr>
-        <a:xfrm>
-          <a:off x="0" y="0"/>
-          <a:ext cx="0" cy="0"/>
-          <a:chOff x="0" y="0"/>
-          <a:chExt cx="0" cy="0"/>
-        </a:xfrm>
-      </p:grpSpPr>
-      <p:sp>
-        <p:nvSpPr>
-          <p:cNvPr id="2" name="슬라이드 이미지 개체 틀 1">
-            <a:extLst>
-              <a:ext uri="{FF2B5EF4-FFF2-40B4-BE49-F238E27FC236}">
-                <a16:creationId xmlns:a16="http://schemas.microsoft.com/office/drawing/2014/main" id="{BA44C680-2FE0-097F-DF23-BBE256C42351}"/>
-              </a:ext>
-            </a:extLst>
-          </p:cNvPr>
-          <p:cNvSpPr>
-            <a:spLocks noGrp="1" noRot="1" noChangeAspect="1"/>
-          </p:cNvSpPr>
-          <p:nvPr>
-            <p:ph type="sldImg"/>
-          </p:nvPr>
-        </p:nvSpPr>
-        <p:spPr/>
-      </p:sp>
-      <p:sp>
-        <p:nvSpPr>
-          <p:cNvPr id="3" name="슬라이드 노트 개체 틀 2">
-            <a:extLst>
-              <a:ext uri="{FF2B5EF4-FFF2-40B4-BE49-F238E27FC236}">
-                <a16:creationId xmlns:a16="http://schemas.microsoft.com/office/drawing/2014/main" id="{14961252-5EA3-39B9-137E-FCE06E69F45A}"/>
-              </a:ext>
-            </a:extLst>
-          </p:cNvPr>
-          <p:cNvSpPr>
-            <a:spLocks noGrp="1"/>
-          </p:cNvSpPr>
-          <p:nvPr>
-            <p:ph type="body" idx="1"/>
-          </p:nvPr>
-        </p:nvSpPr>
-        <p:spPr/>
-        <p:txBody>
-          <a:bodyPr/>
-          <a:lstStyle/>
-          <a:p>
-            <a:r>
-              <a:rPr lang="ko-KR" altLang="en-US" dirty="0"/>
-              <a:t>프로그래밍</a:t>
-            </a:r>
-          </a:p>
-        </p:txBody>
-      </p:sp>
-      <p:sp>
-        <p:nvSpPr>
-          <p:cNvPr id="4" name="슬라이드 번호 개체 틀 3">
-            <a:extLst>
-              <a:ext uri="{FF2B5EF4-FFF2-40B4-BE49-F238E27FC236}">
-                <a16:creationId xmlns:a16="http://schemas.microsoft.com/office/drawing/2014/main" id="{D0B3DD8F-8106-9848-EBEE-EE172DFF71A4}"/>
-              </a:ext>
-            </a:extLst>
-          </p:cNvPr>
-          <p:cNvSpPr>
-            <a:spLocks noGrp="1"/>
-          </p:cNvSpPr>
-          <p:nvPr>
-            <p:ph type="sldNum" sz="quarter" idx="5"/>
-          </p:nvPr>
-        </p:nvSpPr>
-        <p:spPr/>
-        <p:txBody>
-          <a:bodyPr/>
-          <a:lstStyle/>
-          <a:p>
-            <a:fld id="{3599D024-DE68-44ED-822F-D827F84FBD4A}" type="slidenum">
-              <a:rPr lang="ko-KR" altLang="en-US" smtClean="0"/>
-              <a:t>35</a:t>
-            </a:fld>
-            <a:endParaRPr lang="ko-KR" altLang="en-US"/>
-          </a:p>
-        </p:txBody>
-      </p:sp>
-    </p:spTree>
-    <p:extLst>
-      <p:ext uri="{BB962C8B-B14F-4D97-AF65-F5344CB8AC3E}">
-        <p14:creationId xmlns:p14="http://schemas.microsoft.com/office/powerpoint/2010/main" val="3560953179"/>
-      </p:ext>
-    </p:extLst>
-  </p:cSld>
-  <p:clrMapOvr>
-    <a:masterClrMapping/>
-  </p:clrMapOvr>
-</p:notes>
-</file>
-
-<file path=ppt/notesSlides/notesSlide36.xml><?xml version="1.0" encoding="utf-8"?>
-<p:notes xmlns:a="http://schemas.openxmlformats.org/drawingml/2006/main" xmlns:r="http://schemas.openxmlformats.org/officeDocument/2006/relationships" xmlns:p="http://schemas.openxmlformats.org/presentationml/2006/main">
-  <p:cSld>
-    <p:spTree>
-      <p:nvGrpSpPr>
-        <p:cNvPr id="1" name="">
-          <a:extLst>
-            <a:ext uri="{FF2B5EF4-FFF2-40B4-BE49-F238E27FC236}">
-              <a16:creationId xmlns:a16="http://schemas.microsoft.com/office/drawing/2014/main" id="{C14FEFAF-7430-70B1-FA1D-3BDFAE41A020}"/>
-            </a:ext>
-          </a:extLst>
-        </p:cNvPr>
-        <p:cNvGrpSpPr/>
-        <p:nvPr/>
-      </p:nvGrpSpPr>
-      <p:grpSpPr>
-        <a:xfrm>
-          <a:off x="0" y="0"/>
-          <a:ext cx="0" cy="0"/>
-          <a:chOff x="0" y="0"/>
-          <a:chExt cx="0" cy="0"/>
-        </a:xfrm>
-      </p:grpSpPr>
-      <p:sp>
-        <p:nvSpPr>
-          <p:cNvPr id="2" name="슬라이드 이미지 개체 틀 1">
-            <a:extLst>
-              <a:ext uri="{FF2B5EF4-FFF2-40B4-BE49-F238E27FC236}">
-                <a16:creationId xmlns:a16="http://schemas.microsoft.com/office/drawing/2014/main" id="{C06D9483-B8F6-ED5B-5A26-8B83BD6E57B7}"/>
-              </a:ext>
-            </a:extLst>
-          </p:cNvPr>
-          <p:cNvSpPr>
-            <a:spLocks noGrp="1" noRot="1" noChangeAspect="1"/>
-          </p:cNvSpPr>
-          <p:nvPr>
-            <p:ph type="sldImg"/>
-          </p:nvPr>
-        </p:nvSpPr>
-        <p:spPr/>
-      </p:sp>
-      <p:sp>
-        <p:nvSpPr>
-          <p:cNvPr id="3" name="슬라이드 노트 개체 틀 2">
-            <a:extLst>
-              <a:ext uri="{FF2B5EF4-FFF2-40B4-BE49-F238E27FC236}">
-                <a16:creationId xmlns:a16="http://schemas.microsoft.com/office/drawing/2014/main" id="{EC6EDD87-82FC-38C3-9023-5121A14B384E}"/>
-              </a:ext>
-            </a:extLst>
-          </p:cNvPr>
-          <p:cNvSpPr>
-            <a:spLocks noGrp="1"/>
-          </p:cNvSpPr>
-          <p:nvPr>
-            <p:ph type="body" idx="1"/>
-          </p:nvPr>
-        </p:nvSpPr>
-        <p:spPr/>
-        <p:txBody>
-          <a:bodyPr/>
-          <a:lstStyle/>
-          <a:p>
-            <a:r>
-              <a:rPr lang="ko-KR" altLang="en-US" dirty="0"/>
-              <a:t>프로그래밍</a:t>
-            </a:r>
-          </a:p>
-        </p:txBody>
-      </p:sp>
-      <p:sp>
-        <p:nvSpPr>
-          <p:cNvPr id="4" name="슬라이드 번호 개체 틀 3">
-            <a:extLst>
-              <a:ext uri="{FF2B5EF4-FFF2-40B4-BE49-F238E27FC236}">
-                <a16:creationId xmlns:a16="http://schemas.microsoft.com/office/drawing/2014/main" id="{F20B17B1-EFCB-2D5A-1B7F-CB5ED3C668A9}"/>
-              </a:ext>
-            </a:extLst>
-          </p:cNvPr>
-          <p:cNvSpPr>
-            <a:spLocks noGrp="1"/>
-          </p:cNvSpPr>
-          <p:nvPr>
-            <p:ph type="sldNum" sz="quarter" idx="5"/>
-          </p:nvPr>
-        </p:nvSpPr>
-        <p:spPr/>
-        <p:txBody>
-          <a:bodyPr/>
-          <a:lstStyle/>
-          <a:p>
-            <a:fld id="{3599D024-DE68-44ED-822F-D827F84FBD4A}" type="slidenum">
-              <a:rPr lang="ko-KR" altLang="en-US" smtClean="0"/>
-              <a:t>36</a:t>
-            </a:fld>
-            <a:endParaRPr lang="ko-KR" altLang="en-US"/>
-          </a:p>
-        </p:txBody>
-      </p:sp>
-    </p:spTree>
-    <p:extLst>
-      <p:ext uri="{BB962C8B-B14F-4D97-AF65-F5344CB8AC3E}">
-        <p14:creationId xmlns:p14="http://schemas.microsoft.com/office/powerpoint/2010/main" val="2380677640"/>
-      </p:ext>
-    </p:extLst>
-  </p:cSld>
-  <p:clrMapOvr>
-    <a:masterClrMapping/>
-  </p:clrMapOvr>
-</p:notes>
-</file>
-
-<file path=ppt/notesSlides/notesSlide37.xml><?xml version="1.0" encoding="utf-8"?>
-<p:notes xmlns:a="http://schemas.openxmlformats.org/drawingml/2006/main" xmlns:r="http://schemas.openxmlformats.org/officeDocument/2006/relationships" xmlns:p="http://schemas.openxmlformats.org/presentationml/2006/main">
-  <p:cSld>
-    <p:spTree>
-      <p:nvGrpSpPr>
-        <p:cNvPr id="1" name="">
-          <a:extLst>
-            <a:ext uri="{FF2B5EF4-FFF2-40B4-BE49-F238E27FC236}">
-              <a16:creationId xmlns:a16="http://schemas.microsoft.com/office/drawing/2014/main" id="{B71354E5-91B2-0882-CFF4-AB7BCEC1D58E}"/>
-            </a:ext>
-          </a:extLst>
-        </p:cNvPr>
-        <p:cNvGrpSpPr/>
-        <p:nvPr/>
-      </p:nvGrpSpPr>
-      <p:grpSpPr>
-        <a:xfrm>
-          <a:off x="0" y="0"/>
-          <a:ext cx="0" cy="0"/>
-          <a:chOff x="0" y="0"/>
-          <a:chExt cx="0" cy="0"/>
-        </a:xfrm>
-      </p:grpSpPr>
-      <p:sp>
-        <p:nvSpPr>
-          <p:cNvPr id="2" name="슬라이드 이미지 개체 틀 1">
-            <a:extLst>
-              <a:ext uri="{FF2B5EF4-FFF2-40B4-BE49-F238E27FC236}">
-                <a16:creationId xmlns:a16="http://schemas.microsoft.com/office/drawing/2014/main" id="{9BCB3579-2CA3-343F-EC94-900C2D5C5EBB}"/>
-              </a:ext>
-            </a:extLst>
-          </p:cNvPr>
-          <p:cNvSpPr>
-            <a:spLocks noGrp="1" noRot="1" noChangeAspect="1"/>
-          </p:cNvSpPr>
-          <p:nvPr>
-            <p:ph type="sldImg"/>
-          </p:nvPr>
-        </p:nvSpPr>
-        <p:spPr/>
-      </p:sp>
-      <p:sp>
-        <p:nvSpPr>
-          <p:cNvPr id="3" name="슬라이드 노트 개체 틀 2">
-            <a:extLst>
-              <a:ext uri="{FF2B5EF4-FFF2-40B4-BE49-F238E27FC236}">
-                <a16:creationId xmlns:a16="http://schemas.microsoft.com/office/drawing/2014/main" id="{06562483-EC75-0DFD-0E4C-B54A502D918A}"/>
-              </a:ext>
-            </a:extLst>
-          </p:cNvPr>
-          <p:cNvSpPr>
-            <a:spLocks noGrp="1"/>
-          </p:cNvSpPr>
-          <p:nvPr>
-            <p:ph type="body" idx="1"/>
-          </p:nvPr>
-        </p:nvSpPr>
-        <p:spPr/>
-        <p:txBody>
-          <a:bodyPr/>
-          <a:lstStyle/>
-          <a:p>
-            <a:r>
-              <a:rPr lang="ko-KR" altLang="en-US" dirty="0"/>
-              <a:t>프로그래밍</a:t>
-            </a:r>
-          </a:p>
-        </p:txBody>
-      </p:sp>
-      <p:sp>
-        <p:nvSpPr>
-          <p:cNvPr id="4" name="슬라이드 번호 개체 틀 3">
-            <a:extLst>
-              <a:ext uri="{FF2B5EF4-FFF2-40B4-BE49-F238E27FC236}">
-                <a16:creationId xmlns:a16="http://schemas.microsoft.com/office/drawing/2014/main" id="{C41A4FD3-446D-5176-4DB9-E2ECD790D6EE}"/>
-              </a:ext>
-            </a:extLst>
-          </p:cNvPr>
-          <p:cNvSpPr>
-            <a:spLocks noGrp="1"/>
-          </p:cNvSpPr>
-          <p:nvPr>
-            <p:ph type="sldNum" sz="quarter" idx="5"/>
-          </p:nvPr>
-        </p:nvSpPr>
-        <p:spPr/>
-        <p:txBody>
-          <a:bodyPr/>
-          <a:lstStyle/>
-          <a:p>
-            <a:fld id="{3599D024-DE68-44ED-822F-D827F84FBD4A}" type="slidenum">
-              <a:rPr lang="ko-KR" altLang="en-US" smtClean="0"/>
-              <a:t>37</a:t>
-            </a:fld>
-            <a:endParaRPr lang="ko-KR" altLang="en-US"/>
-          </a:p>
-        </p:txBody>
-      </p:sp>
-    </p:spTree>
-    <p:extLst>
-      <p:ext uri="{BB962C8B-B14F-4D97-AF65-F5344CB8AC3E}">
-        <p14:creationId xmlns:p14="http://schemas.microsoft.com/office/powerpoint/2010/main" val="1563420698"/>
-      </p:ext>
-    </p:extLst>
-  </p:cSld>
-  <p:clrMapOvr>
-    <a:masterClrMapping/>
-  </p:clrMapOvr>
-</p:notes>
-</file>
-
-<file path=ppt/notesSlides/notesSlide38.xml><?xml version="1.0" encoding="utf-8"?>
-<p:notes xmlns:a="http://schemas.openxmlformats.org/drawingml/2006/main" xmlns:r="http://schemas.openxmlformats.org/officeDocument/2006/relationships" xmlns:p="http://schemas.openxmlformats.org/presentationml/2006/main">
-  <p:cSld>
-    <p:spTree>
-      <p:nvGrpSpPr>
-        <p:cNvPr id="1" name="">
-          <a:extLst>
-            <a:ext uri="{FF2B5EF4-FFF2-40B4-BE49-F238E27FC236}">
-              <a16:creationId xmlns:a16="http://schemas.microsoft.com/office/drawing/2014/main" id="{CF6F4CE0-7D2F-7C54-6C23-75EBE366AD8D}"/>
-            </a:ext>
-          </a:extLst>
-        </p:cNvPr>
-        <p:cNvGrpSpPr/>
-        <p:nvPr/>
-      </p:nvGrpSpPr>
-      <p:grpSpPr>
-        <a:xfrm>
-          <a:off x="0" y="0"/>
-          <a:ext cx="0" cy="0"/>
-          <a:chOff x="0" y="0"/>
-          <a:chExt cx="0" cy="0"/>
-        </a:xfrm>
-      </p:grpSpPr>
-      <p:sp>
-        <p:nvSpPr>
-          <p:cNvPr id="2" name="슬라이드 이미지 개체 틀 1">
-            <a:extLst>
-              <a:ext uri="{FF2B5EF4-FFF2-40B4-BE49-F238E27FC236}">
-                <a16:creationId xmlns:a16="http://schemas.microsoft.com/office/drawing/2014/main" id="{A8AF5F6A-0FBE-10B6-B2D8-D1DAD0B7DF56}"/>
-              </a:ext>
-            </a:extLst>
-          </p:cNvPr>
-          <p:cNvSpPr>
-            <a:spLocks noGrp="1" noRot="1" noChangeAspect="1"/>
-          </p:cNvSpPr>
-          <p:nvPr>
-            <p:ph type="sldImg"/>
-          </p:nvPr>
-        </p:nvSpPr>
-        <p:spPr/>
-      </p:sp>
-      <p:sp>
-        <p:nvSpPr>
-          <p:cNvPr id="3" name="슬라이드 노트 개체 틀 2">
-            <a:extLst>
-              <a:ext uri="{FF2B5EF4-FFF2-40B4-BE49-F238E27FC236}">
-                <a16:creationId xmlns:a16="http://schemas.microsoft.com/office/drawing/2014/main" id="{E4B471A5-C5E1-91B4-AE86-26DA66052AA0}"/>
+                <a16:creationId xmlns:a16="http://schemas.microsoft.com/office/drawing/2014/main" id="{651E566A-FF91-B8EA-BE9C-364EB1569BE6}"/>
               </a:ext>
             </a:extLst>
           </p:cNvPr>
@@ -6364,7 +5810,562 @@
           <p:cNvPr id="4" name="슬라이드 번호 개체 틀 3">
             <a:extLst>
               <a:ext uri="{FF2B5EF4-FFF2-40B4-BE49-F238E27FC236}">
-                <a16:creationId xmlns:a16="http://schemas.microsoft.com/office/drawing/2014/main" id="{3A4231B4-AFD0-F0A6-3A13-3A0A9D67021A}"/>
+                <a16:creationId xmlns:a16="http://schemas.microsoft.com/office/drawing/2014/main" id="{A2EE1A85-1AEE-4B8D-77C4-ED114B4D2548}"/>
+              </a:ext>
+            </a:extLst>
+          </p:cNvPr>
+          <p:cNvSpPr>
+            <a:spLocks noGrp="1"/>
+          </p:cNvSpPr>
+          <p:nvPr>
+            <p:ph type="sldNum" sz="quarter" idx="5"/>
+          </p:nvPr>
+        </p:nvSpPr>
+        <p:spPr/>
+        <p:txBody>
+          <a:bodyPr/>
+          <a:lstStyle/>
+          <a:p>
+            <a:fld id="{3599D024-DE68-44ED-822F-D827F84FBD4A}" type="slidenum">
+              <a:rPr lang="ko-KR" altLang="en-US" smtClean="0"/>
+              <a:t>33</a:t>
+            </a:fld>
+            <a:endParaRPr lang="ko-KR" altLang="en-US"/>
+          </a:p>
+        </p:txBody>
+      </p:sp>
+    </p:spTree>
+    <p:extLst>
+      <p:ext uri="{BB962C8B-B14F-4D97-AF65-F5344CB8AC3E}">
+        <p14:creationId xmlns:p14="http://schemas.microsoft.com/office/powerpoint/2010/main" val="3063466307"/>
+      </p:ext>
+    </p:extLst>
+  </p:cSld>
+  <p:clrMapOvr>
+    <a:masterClrMapping/>
+  </p:clrMapOvr>
+</p:notes>
+</file>
+
+<file path=ppt/notesSlides/notesSlide34.xml><?xml version="1.0" encoding="utf-8"?>
+<p:notes xmlns:a="http://schemas.openxmlformats.org/drawingml/2006/main" xmlns:r="http://schemas.openxmlformats.org/officeDocument/2006/relationships" xmlns:p="http://schemas.openxmlformats.org/presentationml/2006/main">
+  <p:cSld>
+    <p:spTree>
+      <p:nvGrpSpPr>
+        <p:cNvPr id="1" name="">
+          <a:extLst>
+            <a:ext uri="{FF2B5EF4-FFF2-40B4-BE49-F238E27FC236}">
+              <a16:creationId xmlns:a16="http://schemas.microsoft.com/office/drawing/2014/main" id="{C620A808-063F-DB54-33D7-5E772234325E}"/>
+            </a:ext>
+          </a:extLst>
+        </p:cNvPr>
+        <p:cNvGrpSpPr/>
+        <p:nvPr/>
+      </p:nvGrpSpPr>
+      <p:grpSpPr>
+        <a:xfrm>
+          <a:off x="0" y="0"/>
+          <a:ext cx="0" cy="0"/>
+          <a:chOff x="0" y="0"/>
+          <a:chExt cx="0" cy="0"/>
+        </a:xfrm>
+      </p:grpSpPr>
+      <p:sp>
+        <p:nvSpPr>
+          <p:cNvPr id="2" name="슬라이드 이미지 개체 틀 1">
+            <a:extLst>
+              <a:ext uri="{FF2B5EF4-FFF2-40B4-BE49-F238E27FC236}">
+                <a16:creationId xmlns:a16="http://schemas.microsoft.com/office/drawing/2014/main" id="{CFF4FEF9-6C7C-8C98-1A4E-EB0A88BA0633}"/>
+              </a:ext>
+            </a:extLst>
+          </p:cNvPr>
+          <p:cNvSpPr>
+            <a:spLocks noGrp="1" noRot="1" noChangeAspect="1"/>
+          </p:cNvSpPr>
+          <p:nvPr>
+            <p:ph type="sldImg"/>
+          </p:nvPr>
+        </p:nvSpPr>
+        <p:spPr/>
+      </p:sp>
+      <p:sp>
+        <p:nvSpPr>
+          <p:cNvPr id="3" name="슬라이드 노트 개체 틀 2">
+            <a:extLst>
+              <a:ext uri="{FF2B5EF4-FFF2-40B4-BE49-F238E27FC236}">
+                <a16:creationId xmlns:a16="http://schemas.microsoft.com/office/drawing/2014/main" id="{14C5842B-61C3-F015-8668-DFF806E30055}"/>
+              </a:ext>
+            </a:extLst>
+          </p:cNvPr>
+          <p:cNvSpPr>
+            <a:spLocks noGrp="1"/>
+          </p:cNvSpPr>
+          <p:nvPr>
+            <p:ph type="body" idx="1"/>
+          </p:nvPr>
+        </p:nvSpPr>
+        <p:spPr/>
+        <p:txBody>
+          <a:bodyPr/>
+          <a:lstStyle/>
+          <a:p>
+            <a:r>
+              <a:rPr lang="ko-KR" altLang="en-US" dirty="0"/>
+              <a:t>프로그래밍</a:t>
+            </a:r>
+          </a:p>
+        </p:txBody>
+      </p:sp>
+      <p:sp>
+        <p:nvSpPr>
+          <p:cNvPr id="4" name="슬라이드 번호 개체 틀 3">
+            <a:extLst>
+              <a:ext uri="{FF2B5EF4-FFF2-40B4-BE49-F238E27FC236}">
+                <a16:creationId xmlns:a16="http://schemas.microsoft.com/office/drawing/2014/main" id="{A1F6FAF8-14D7-CB3D-C7F2-64383532AF55}"/>
+              </a:ext>
+            </a:extLst>
+          </p:cNvPr>
+          <p:cNvSpPr>
+            <a:spLocks noGrp="1"/>
+          </p:cNvSpPr>
+          <p:nvPr>
+            <p:ph type="sldNum" sz="quarter" idx="5"/>
+          </p:nvPr>
+        </p:nvSpPr>
+        <p:spPr/>
+        <p:txBody>
+          <a:bodyPr/>
+          <a:lstStyle/>
+          <a:p>
+            <a:fld id="{3599D024-DE68-44ED-822F-D827F84FBD4A}" type="slidenum">
+              <a:rPr lang="ko-KR" altLang="en-US" smtClean="0"/>
+              <a:t>34</a:t>
+            </a:fld>
+            <a:endParaRPr lang="ko-KR" altLang="en-US"/>
+          </a:p>
+        </p:txBody>
+      </p:sp>
+    </p:spTree>
+    <p:extLst>
+      <p:ext uri="{BB962C8B-B14F-4D97-AF65-F5344CB8AC3E}">
+        <p14:creationId xmlns:p14="http://schemas.microsoft.com/office/powerpoint/2010/main" val="243182125"/>
+      </p:ext>
+    </p:extLst>
+  </p:cSld>
+  <p:clrMapOvr>
+    <a:masterClrMapping/>
+  </p:clrMapOvr>
+</p:notes>
+</file>
+
+<file path=ppt/notesSlides/notesSlide35.xml><?xml version="1.0" encoding="utf-8"?>
+<p:notes xmlns:a="http://schemas.openxmlformats.org/drawingml/2006/main" xmlns:r="http://schemas.openxmlformats.org/officeDocument/2006/relationships" xmlns:p="http://schemas.openxmlformats.org/presentationml/2006/main">
+  <p:cSld>
+    <p:spTree>
+      <p:nvGrpSpPr>
+        <p:cNvPr id="1" name="">
+          <a:extLst>
+            <a:ext uri="{FF2B5EF4-FFF2-40B4-BE49-F238E27FC236}">
+              <a16:creationId xmlns:a16="http://schemas.microsoft.com/office/drawing/2014/main" id="{6443BF75-70E2-E261-2D7C-56EAD45275F8}"/>
+            </a:ext>
+          </a:extLst>
+        </p:cNvPr>
+        <p:cNvGrpSpPr/>
+        <p:nvPr/>
+      </p:nvGrpSpPr>
+      <p:grpSpPr>
+        <a:xfrm>
+          <a:off x="0" y="0"/>
+          <a:ext cx="0" cy="0"/>
+          <a:chOff x="0" y="0"/>
+          <a:chExt cx="0" cy="0"/>
+        </a:xfrm>
+      </p:grpSpPr>
+      <p:sp>
+        <p:nvSpPr>
+          <p:cNvPr id="2" name="슬라이드 이미지 개체 틀 1">
+            <a:extLst>
+              <a:ext uri="{FF2B5EF4-FFF2-40B4-BE49-F238E27FC236}">
+                <a16:creationId xmlns:a16="http://schemas.microsoft.com/office/drawing/2014/main" id="{BC5021E9-121C-84BF-DF58-7D3E3B6E2910}"/>
+              </a:ext>
+            </a:extLst>
+          </p:cNvPr>
+          <p:cNvSpPr>
+            <a:spLocks noGrp="1" noRot="1" noChangeAspect="1"/>
+          </p:cNvSpPr>
+          <p:nvPr>
+            <p:ph type="sldImg"/>
+          </p:nvPr>
+        </p:nvSpPr>
+        <p:spPr/>
+      </p:sp>
+      <p:sp>
+        <p:nvSpPr>
+          <p:cNvPr id="3" name="슬라이드 노트 개체 틀 2">
+            <a:extLst>
+              <a:ext uri="{FF2B5EF4-FFF2-40B4-BE49-F238E27FC236}">
+                <a16:creationId xmlns:a16="http://schemas.microsoft.com/office/drawing/2014/main" id="{89CDE9D5-29C0-07AA-FCD8-51E7250605C6}"/>
+              </a:ext>
+            </a:extLst>
+          </p:cNvPr>
+          <p:cNvSpPr>
+            <a:spLocks noGrp="1"/>
+          </p:cNvSpPr>
+          <p:nvPr>
+            <p:ph type="body" idx="1"/>
+          </p:nvPr>
+        </p:nvSpPr>
+        <p:spPr/>
+        <p:txBody>
+          <a:bodyPr/>
+          <a:lstStyle/>
+          <a:p>
+            <a:r>
+              <a:rPr lang="ko-KR" altLang="en-US" dirty="0"/>
+              <a:t>프로그래밍</a:t>
+            </a:r>
+          </a:p>
+        </p:txBody>
+      </p:sp>
+      <p:sp>
+        <p:nvSpPr>
+          <p:cNvPr id="4" name="슬라이드 번호 개체 틀 3">
+            <a:extLst>
+              <a:ext uri="{FF2B5EF4-FFF2-40B4-BE49-F238E27FC236}">
+                <a16:creationId xmlns:a16="http://schemas.microsoft.com/office/drawing/2014/main" id="{7378B32B-E66D-C9B0-8310-D65B0D309C44}"/>
+              </a:ext>
+            </a:extLst>
+          </p:cNvPr>
+          <p:cNvSpPr>
+            <a:spLocks noGrp="1"/>
+          </p:cNvSpPr>
+          <p:nvPr>
+            <p:ph type="sldNum" sz="quarter" idx="5"/>
+          </p:nvPr>
+        </p:nvSpPr>
+        <p:spPr/>
+        <p:txBody>
+          <a:bodyPr/>
+          <a:lstStyle/>
+          <a:p>
+            <a:fld id="{3599D024-DE68-44ED-822F-D827F84FBD4A}" type="slidenum">
+              <a:rPr lang="ko-KR" altLang="en-US" smtClean="0"/>
+              <a:t>35</a:t>
+            </a:fld>
+            <a:endParaRPr lang="ko-KR" altLang="en-US"/>
+          </a:p>
+        </p:txBody>
+      </p:sp>
+    </p:spTree>
+    <p:extLst>
+      <p:ext uri="{BB962C8B-B14F-4D97-AF65-F5344CB8AC3E}">
+        <p14:creationId xmlns:p14="http://schemas.microsoft.com/office/powerpoint/2010/main" val="2390852696"/>
+      </p:ext>
+    </p:extLst>
+  </p:cSld>
+  <p:clrMapOvr>
+    <a:masterClrMapping/>
+  </p:clrMapOvr>
+</p:notes>
+</file>
+
+<file path=ppt/notesSlides/notesSlide36.xml><?xml version="1.0" encoding="utf-8"?>
+<p:notes xmlns:a="http://schemas.openxmlformats.org/drawingml/2006/main" xmlns:r="http://schemas.openxmlformats.org/officeDocument/2006/relationships" xmlns:p="http://schemas.openxmlformats.org/presentationml/2006/main">
+  <p:cSld>
+    <p:spTree>
+      <p:nvGrpSpPr>
+        <p:cNvPr id="1" name="">
+          <a:extLst>
+            <a:ext uri="{FF2B5EF4-FFF2-40B4-BE49-F238E27FC236}">
+              <a16:creationId xmlns:a16="http://schemas.microsoft.com/office/drawing/2014/main" id="{D3BA3E55-B894-420A-7F3C-517D830490D5}"/>
+            </a:ext>
+          </a:extLst>
+        </p:cNvPr>
+        <p:cNvGrpSpPr/>
+        <p:nvPr/>
+      </p:nvGrpSpPr>
+      <p:grpSpPr>
+        <a:xfrm>
+          <a:off x="0" y="0"/>
+          <a:ext cx="0" cy="0"/>
+          <a:chOff x="0" y="0"/>
+          <a:chExt cx="0" cy="0"/>
+        </a:xfrm>
+      </p:grpSpPr>
+      <p:sp>
+        <p:nvSpPr>
+          <p:cNvPr id="2" name="슬라이드 이미지 개체 틀 1">
+            <a:extLst>
+              <a:ext uri="{FF2B5EF4-FFF2-40B4-BE49-F238E27FC236}">
+                <a16:creationId xmlns:a16="http://schemas.microsoft.com/office/drawing/2014/main" id="{BA44C680-2FE0-097F-DF23-BBE256C42351}"/>
+              </a:ext>
+            </a:extLst>
+          </p:cNvPr>
+          <p:cNvSpPr>
+            <a:spLocks noGrp="1" noRot="1" noChangeAspect="1"/>
+          </p:cNvSpPr>
+          <p:nvPr>
+            <p:ph type="sldImg"/>
+          </p:nvPr>
+        </p:nvSpPr>
+        <p:spPr/>
+      </p:sp>
+      <p:sp>
+        <p:nvSpPr>
+          <p:cNvPr id="3" name="슬라이드 노트 개체 틀 2">
+            <a:extLst>
+              <a:ext uri="{FF2B5EF4-FFF2-40B4-BE49-F238E27FC236}">
+                <a16:creationId xmlns:a16="http://schemas.microsoft.com/office/drawing/2014/main" id="{14961252-5EA3-39B9-137E-FCE06E69F45A}"/>
+              </a:ext>
+            </a:extLst>
+          </p:cNvPr>
+          <p:cNvSpPr>
+            <a:spLocks noGrp="1"/>
+          </p:cNvSpPr>
+          <p:nvPr>
+            <p:ph type="body" idx="1"/>
+          </p:nvPr>
+        </p:nvSpPr>
+        <p:spPr/>
+        <p:txBody>
+          <a:bodyPr/>
+          <a:lstStyle/>
+          <a:p>
+            <a:r>
+              <a:rPr lang="ko-KR" altLang="en-US" dirty="0"/>
+              <a:t>프로그래밍</a:t>
+            </a:r>
+          </a:p>
+        </p:txBody>
+      </p:sp>
+      <p:sp>
+        <p:nvSpPr>
+          <p:cNvPr id="4" name="슬라이드 번호 개체 틀 3">
+            <a:extLst>
+              <a:ext uri="{FF2B5EF4-FFF2-40B4-BE49-F238E27FC236}">
+                <a16:creationId xmlns:a16="http://schemas.microsoft.com/office/drawing/2014/main" id="{D0B3DD8F-8106-9848-EBEE-EE172DFF71A4}"/>
+              </a:ext>
+            </a:extLst>
+          </p:cNvPr>
+          <p:cNvSpPr>
+            <a:spLocks noGrp="1"/>
+          </p:cNvSpPr>
+          <p:nvPr>
+            <p:ph type="sldNum" sz="quarter" idx="5"/>
+          </p:nvPr>
+        </p:nvSpPr>
+        <p:spPr/>
+        <p:txBody>
+          <a:bodyPr/>
+          <a:lstStyle/>
+          <a:p>
+            <a:fld id="{3599D024-DE68-44ED-822F-D827F84FBD4A}" type="slidenum">
+              <a:rPr lang="ko-KR" altLang="en-US" smtClean="0"/>
+              <a:t>36</a:t>
+            </a:fld>
+            <a:endParaRPr lang="ko-KR" altLang="en-US"/>
+          </a:p>
+        </p:txBody>
+      </p:sp>
+    </p:spTree>
+    <p:extLst>
+      <p:ext uri="{BB962C8B-B14F-4D97-AF65-F5344CB8AC3E}">
+        <p14:creationId xmlns:p14="http://schemas.microsoft.com/office/powerpoint/2010/main" val="3560953179"/>
+      </p:ext>
+    </p:extLst>
+  </p:cSld>
+  <p:clrMapOvr>
+    <a:masterClrMapping/>
+  </p:clrMapOvr>
+</p:notes>
+</file>
+
+<file path=ppt/notesSlides/notesSlide37.xml><?xml version="1.0" encoding="utf-8"?>
+<p:notes xmlns:a="http://schemas.openxmlformats.org/drawingml/2006/main" xmlns:r="http://schemas.openxmlformats.org/officeDocument/2006/relationships" xmlns:p="http://schemas.openxmlformats.org/presentationml/2006/main">
+  <p:cSld>
+    <p:spTree>
+      <p:nvGrpSpPr>
+        <p:cNvPr id="1" name="">
+          <a:extLst>
+            <a:ext uri="{FF2B5EF4-FFF2-40B4-BE49-F238E27FC236}">
+              <a16:creationId xmlns:a16="http://schemas.microsoft.com/office/drawing/2014/main" id="{C14FEFAF-7430-70B1-FA1D-3BDFAE41A020}"/>
+            </a:ext>
+          </a:extLst>
+        </p:cNvPr>
+        <p:cNvGrpSpPr/>
+        <p:nvPr/>
+      </p:nvGrpSpPr>
+      <p:grpSpPr>
+        <a:xfrm>
+          <a:off x="0" y="0"/>
+          <a:ext cx="0" cy="0"/>
+          <a:chOff x="0" y="0"/>
+          <a:chExt cx="0" cy="0"/>
+        </a:xfrm>
+      </p:grpSpPr>
+      <p:sp>
+        <p:nvSpPr>
+          <p:cNvPr id="2" name="슬라이드 이미지 개체 틀 1">
+            <a:extLst>
+              <a:ext uri="{FF2B5EF4-FFF2-40B4-BE49-F238E27FC236}">
+                <a16:creationId xmlns:a16="http://schemas.microsoft.com/office/drawing/2014/main" id="{C06D9483-B8F6-ED5B-5A26-8B83BD6E57B7}"/>
+              </a:ext>
+            </a:extLst>
+          </p:cNvPr>
+          <p:cNvSpPr>
+            <a:spLocks noGrp="1" noRot="1" noChangeAspect="1"/>
+          </p:cNvSpPr>
+          <p:nvPr>
+            <p:ph type="sldImg"/>
+          </p:nvPr>
+        </p:nvSpPr>
+        <p:spPr/>
+      </p:sp>
+      <p:sp>
+        <p:nvSpPr>
+          <p:cNvPr id="3" name="슬라이드 노트 개체 틀 2">
+            <a:extLst>
+              <a:ext uri="{FF2B5EF4-FFF2-40B4-BE49-F238E27FC236}">
+                <a16:creationId xmlns:a16="http://schemas.microsoft.com/office/drawing/2014/main" id="{EC6EDD87-82FC-38C3-9023-5121A14B384E}"/>
+              </a:ext>
+            </a:extLst>
+          </p:cNvPr>
+          <p:cNvSpPr>
+            <a:spLocks noGrp="1"/>
+          </p:cNvSpPr>
+          <p:nvPr>
+            <p:ph type="body" idx="1"/>
+          </p:nvPr>
+        </p:nvSpPr>
+        <p:spPr/>
+        <p:txBody>
+          <a:bodyPr/>
+          <a:lstStyle/>
+          <a:p>
+            <a:r>
+              <a:rPr lang="ko-KR" altLang="en-US" dirty="0"/>
+              <a:t>프로그래밍</a:t>
+            </a:r>
+          </a:p>
+        </p:txBody>
+      </p:sp>
+      <p:sp>
+        <p:nvSpPr>
+          <p:cNvPr id="4" name="슬라이드 번호 개체 틀 3">
+            <a:extLst>
+              <a:ext uri="{FF2B5EF4-FFF2-40B4-BE49-F238E27FC236}">
+                <a16:creationId xmlns:a16="http://schemas.microsoft.com/office/drawing/2014/main" id="{F20B17B1-EFCB-2D5A-1B7F-CB5ED3C668A9}"/>
+              </a:ext>
+            </a:extLst>
+          </p:cNvPr>
+          <p:cNvSpPr>
+            <a:spLocks noGrp="1"/>
+          </p:cNvSpPr>
+          <p:nvPr>
+            <p:ph type="sldNum" sz="quarter" idx="5"/>
+          </p:nvPr>
+        </p:nvSpPr>
+        <p:spPr/>
+        <p:txBody>
+          <a:bodyPr/>
+          <a:lstStyle/>
+          <a:p>
+            <a:fld id="{3599D024-DE68-44ED-822F-D827F84FBD4A}" type="slidenum">
+              <a:rPr lang="ko-KR" altLang="en-US" smtClean="0"/>
+              <a:t>37</a:t>
+            </a:fld>
+            <a:endParaRPr lang="ko-KR" altLang="en-US"/>
+          </a:p>
+        </p:txBody>
+      </p:sp>
+    </p:spTree>
+    <p:extLst>
+      <p:ext uri="{BB962C8B-B14F-4D97-AF65-F5344CB8AC3E}">
+        <p14:creationId xmlns:p14="http://schemas.microsoft.com/office/powerpoint/2010/main" val="2380677640"/>
+      </p:ext>
+    </p:extLst>
+  </p:cSld>
+  <p:clrMapOvr>
+    <a:masterClrMapping/>
+  </p:clrMapOvr>
+</p:notes>
+</file>
+
+<file path=ppt/notesSlides/notesSlide38.xml><?xml version="1.0" encoding="utf-8"?>
+<p:notes xmlns:a="http://schemas.openxmlformats.org/drawingml/2006/main" xmlns:r="http://schemas.openxmlformats.org/officeDocument/2006/relationships" xmlns:p="http://schemas.openxmlformats.org/presentationml/2006/main">
+  <p:cSld>
+    <p:spTree>
+      <p:nvGrpSpPr>
+        <p:cNvPr id="1" name="">
+          <a:extLst>
+            <a:ext uri="{FF2B5EF4-FFF2-40B4-BE49-F238E27FC236}">
+              <a16:creationId xmlns:a16="http://schemas.microsoft.com/office/drawing/2014/main" id="{B71354E5-91B2-0882-CFF4-AB7BCEC1D58E}"/>
+            </a:ext>
+          </a:extLst>
+        </p:cNvPr>
+        <p:cNvGrpSpPr/>
+        <p:nvPr/>
+      </p:nvGrpSpPr>
+      <p:grpSpPr>
+        <a:xfrm>
+          <a:off x="0" y="0"/>
+          <a:ext cx="0" cy="0"/>
+          <a:chOff x="0" y="0"/>
+          <a:chExt cx="0" cy="0"/>
+        </a:xfrm>
+      </p:grpSpPr>
+      <p:sp>
+        <p:nvSpPr>
+          <p:cNvPr id="2" name="슬라이드 이미지 개체 틀 1">
+            <a:extLst>
+              <a:ext uri="{FF2B5EF4-FFF2-40B4-BE49-F238E27FC236}">
+                <a16:creationId xmlns:a16="http://schemas.microsoft.com/office/drawing/2014/main" id="{9BCB3579-2CA3-343F-EC94-900C2D5C5EBB}"/>
+              </a:ext>
+            </a:extLst>
+          </p:cNvPr>
+          <p:cNvSpPr>
+            <a:spLocks noGrp="1" noRot="1" noChangeAspect="1"/>
+          </p:cNvSpPr>
+          <p:nvPr>
+            <p:ph type="sldImg"/>
+          </p:nvPr>
+        </p:nvSpPr>
+        <p:spPr/>
+      </p:sp>
+      <p:sp>
+        <p:nvSpPr>
+          <p:cNvPr id="3" name="슬라이드 노트 개체 틀 2">
+            <a:extLst>
+              <a:ext uri="{FF2B5EF4-FFF2-40B4-BE49-F238E27FC236}">
+                <a16:creationId xmlns:a16="http://schemas.microsoft.com/office/drawing/2014/main" id="{06562483-EC75-0DFD-0E4C-B54A502D918A}"/>
+              </a:ext>
+            </a:extLst>
+          </p:cNvPr>
+          <p:cNvSpPr>
+            <a:spLocks noGrp="1"/>
+          </p:cNvSpPr>
+          <p:nvPr>
+            <p:ph type="body" idx="1"/>
+          </p:nvPr>
+        </p:nvSpPr>
+        <p:spPr/>
+        <p:txBody>
+          <a:bodyPr/>
+          <a:lstStyle/>
+          <a:p>
+            <a:r>
+              <a:rPr lang="ko-KR" altLang="en-US" dirty="0"/>
+              <a:t>프로그래밍</a:t>
+            </a:r>
+          </a:p>
+        </p:txBody>
+      </p:sp>
+      <p:sp>
+        <p:nvSpPr>
+          <p:cNvPr id="4" name="슬라이드 번호 개체 틀 3">
+            <a:extLst>
+              <a:ext uri="{FF2B5EF4-FFF2-40B4-BE49-F238E27FC236}">
+                <a16:creationId xmlns:a16="http://schemas.microsoft.com/office/drawing/2014/main" id="{C41A4FD3-446D-5176-4DB9-E2ECD790D6EE}"/>
               </a:ext>
             </a:extLst>
           </p:cNvPr>
@@ -6391,7 +6392,7 @@
     </p:spTree>
     <p:extLst>
       <p:ext uri="{BB962C8B-B14F-4D97-AF65-F5344CB8AC3E}">
-        <p14:creationId xmlns:p14="http://schemas.microsoft.com/office/powerpoint/2010/main" val="4169100668"/>
+        <p14:creationId xmlns:p14="http://schemas.microsoft.com/office/powerpoint/2010/main" val="1563420698"/>
       </p:ext>
     </p:extLst>
   </p:cSld>
@@ -6409,7 +6410,7 @@
         <p:cNvPr id="1" name="">
           <a:extLst>
             <a:ext uri="{FF2B5EF4-FFF2-40B4-BE49-F238E27FC236}">
-              <a16:creationId xmlns:a16="http://schemas.microsoft.com/office/drawing/2014/main" id="{AD5D6691-443E-EB7B-09AD-A7AC62166E2D}"/>
+              <a16:creationId xmlns:a16="http://schemas.microsoft.com/office/drawing/2014/main" id="{CF6F4CE0-7D2F-7C54-6C23-75EBE366AD8D}"/>
             </a:ext>
           </a:extLst>
         </p:cNvPr>
@@ -6429,7 +6430,7 @@
           <p:cNvPr id="2" name="슬라이드 이미지 개체 틀 1">
             <a:extLst>
               <a:ext uri="{FF2B5EF4-FFF2-40B4-BE49-F238E27FC236}">
-                <a16:creationId xmlns:a16="http://schemas.microsoft.com/office/drawing/2014/main" id="{1D8F973B-9CCA-90A2-584D-016D9B9AD0A4}"/>
+                <a16:creationId xmlns:a16="http://schemas.microsoft.com/office/drawing/2014/main" id="{A8AF5F6A-0FBE-10B6-B2D8-D1DAD0B7DF56}"/>
               </a:ext>
             </a:extLst>
           </p:cNvPr>
@@ -6447,7 +6448,7 @@
           <p:cNvPr id="3" name="슬라이드 노트 개체 틀 2">
             <a:extLst>
               <a:ext uri="{FF2B5EF4-FFF2-40B4-BE49-F238E27FC236}">
-                <a16:creationId xmlns:a16="http://schemas.microsoft.com/office/drawing/2014/main" id="{EB778186-07E5-1D8E-03B2-4143479133C1}"/>
+                <a16:creationId xmlns:a16="http://schemas.microsoft.com/office/drawing/2014/main" id="{E4B471A5-C5E1-91B4-AE86-26DA66052AA0}"/>
               </a:ext>
             </a:extLst>
           </p:cNvPr>
@@ -6496,7 +6497,7 @@
           <p:cNvPr id="4" name="슬라이드 번호 개체 틀 3">
             <a:extLst>
               <a:ext uri="{FF2B5EF4-FFF2-40B4-BE49-F238E27FC236}">
-                <a16:creationId xmlns:a16="http://schemas.microsoft.com/office/drawing/2014/main" id="{95A842B1-2C17-B89E-7307-D863FE884B8A}"/>
+                <a16:creationId xmlns:a16="http://schemas.microsoft.com/office/drawing/2014/main" id="{3A4231B4-AFD0-F0A6-3A13-3A0A9D67021A}"/>
               </a:ext>
             </a:extLst>
           </p:cNvPr>
@@ -6523,7 +6524,7 @@
     </p:spTree>
     <p:extLst>
       <p:ext uri="{BB962C8B-B14F-4D97-AF65-F5344CB8AC3E}">
-        <p14:creationId xmlns:p14="http://schemas.microsoft.com/office/powerpoint/2010/main" val="3341201137"/>
+        <p14:creationId xmlns:p14="http://schemas.microsoft.com/office/powerpoint/2010/main" val="4169100668"/>
       </p:ext>
     </p:extLst>
   </p:cSld>
@@ -6673,7 +6674,7 @@
         <p:cNvPr id="1" name="">
           <a:extLst>
             <a:ext uri="{FF2B5EF4-FFF2-40B4-BE49-F238E27FC236}">
-              <a16:creationId xmlns:a16="http://schemas.microsoft.com/office/drawing/2014/main" id="{0DF23C2F-7D40-1AE1-38AE-A261F1DE7C98}"/>
+              <a16:creationId xmlns:a16="http://schemas.microsoft.com/office/drawing/2014/main" id="{AD5D6691-443E-EB7B-09AD-A7AC62166E2D}"/>
             </a:ext>
           </a:extLst>
         </p:cNvPr>
@@ -6693,7 +6694,7 @@
           <p:cNvPr id="2" name="슬라이드 이미지 개체 틀 1">
             <a:extLst>
               <a:ext uri="{FF2B5EF4-FFF2-40B4-BE49-F238E27FC236}">
-                <a16:creationId xmlns:a16="http://schemas.microsoft.com/office/drawing/2014/main" id="{1A449151-E21D-0E07-905F-665E7F0818A4}"/>
+                <a16:creationId xmlns:a16="http://schemas.microsoft.com/office/drawing/2014/main" id="{1D8F973B-9CCA-90A2-584D-016D9B9AD0A4}"/>
               </a:ext>
             </a:extLst>
           </p:cNvPr>
@@ -6711,7 +6712,7 @@
           <p:cNvPr id="3" name="슬라이드 노트 개체 틀 2">
             <a:extLst>
               <a:ext uri="{FF2B5EF4-FFF2-40B4-BE49-F238E27FC236}">
-                <a16:creationId xmlns:a16="http://schemas.microsoft.com/office/drawing/2014/main" id="{96D80661-1443-3CF7-C40E-BFB6A8BF9840}"/>
+                <a16:creationId xmlns:a16="http://schemas.microsoft.com/office/drawing/2014/main" id="{EB778186-07E5-1D8E-03B2-4143479133C1}"/>
               </a:ext>
             </a:extLst>
           </p:cNvPr>
@@ -6760,7 +6761,7 @@
           <p:cNvPr id="4" name="슬라이드 번호 개체 틀 3">
             <a:extLst>
               <a:ext uri="{FF2B5EF4-FFF2-40B4-BE49-F238E27FC236}">
-                <a16:creationId xmlns:a16="http://schemas.microsoft.com/office/drawing/2014/main" id="{4272D748-2A86-C3CF-42E3-8CAC7F616DCF}"/>
+                <a16:creationId xmlns:a16="http://schemas.microsoft.com/office/drawing/2014/main" id="{95A842B1-2C17-B89E-7307-D863FE884B8A}"/>
               </a:ext>
             </a:extLst>
           </p:cNvPr>
@@ -6787,7 +6788,7 @@
     </p:spTree>
     <p:extLst>
       <p:ext uri="{BB962C8B-B14F-4D97-AF65-F5344CB8AC3E}">
-        <p14:creationId xmlns:p14="http://schemas.microsoft.com/office/powerpoint/2010/main" val="3219764159"/>
+        <p14:creationId xmlns:p14="http://schemas.microsoft.com/office/powerpoint/2010/main" val="3341201137"/>
       </p:ext>
     </p:extLst>
   </p:cSld>
@@ -6805,7 +6806,7 @@
         <p:cNvPr id="1" name="">
           <a:extLst>
             <a:ext uri="{FF2B5EF4-FFF2-40B4-BE49-F238E27FC236}">
-              <a16:creationId xmlns:a16="http://schemas.microsoft.com/office/drawing/2014/main" id="{034B4BCE-D74C-80A8-A52D-73A43465F725}"/>
+              <a16:creationId xmlns:a16="http://schemas.microsoft.com/office/drawing/2014/main" id="{0DF23C2F-7D40-1AE1-38AE-A261F1DE7C98}"/>
             </a:ext>
           </a:extLst>
         </p:cNvPr>
@@ -6825,7 +6826,7 @@
           <p:cNvPr id="2" name="슬라이드 이미지 개체 틀 1">
             <a:extLst>
               <a:ext uri="{FF2B5EF4-FFF2-40B4-BE49-F238E27FC236}">
-                <a16:creationId xmlns:a16="http://schemas.microsoft.com/office/drawing/2014/main" id="{4E7F5753-F0A5-9296-929D-E2602DC5D9FD}"/>
+                <a16:creationId xmlns:a16="http://schemas.microsoft.com/office/drawing/2014/main" id="{1A449151-E21D-0E07-905F-665E7F0818A4}"/>
               </a:ext>
             </a:extLst>
           </p:cNvPr>
@@ -6843,562 +6844,7 @@
           <p:cNvPr id="3" name="슬라이드 노트 개체 틀 2">
             <a:extLst>
               <a:ext uri="{FF2B5EF4-FFF2-40B4-BE49-F238E27FC236}">
-                <a16:creationId xmlns:a16="http://schemas.microsoft.com/office/drawing/2014/main" id="{BE1F9F60-CF56-3853-2A74-D96094114CC9}"/>
-              </a:ext>
-            </a:extLst>
-          </p:cNvPr>
-          <p:cNvSpPr>
-            <a:spLocks noGrp="1"/>
-          </p:cNvSpPr>
-          <p:nvPr>
-            <p:ph type="body" idx="1"/>
-          </p:nvPr>
-        </p:nvSpPr>
-        <p:spPr/>
-        <p:txBody>
-          <a:bodyPr/>
-          <a:lstStyle/>
-          <a:p>
-            <a:r>
-              <a:rPr lang="ko-KR" altLang="en-US" dirty="0"/>
-              <a:t>프로그래밍</a:t>
-            </a:r>
-          </a:p>
-        </p:txBody>
-      </p:sp>
-      <p:sp>
-        <p:nvSpPr>
-          <p:cNvPr id="4" name="슬라이드 번호 개체 틀 3">
-            <a:extLst>
-              <a:ext uri="{FF2B5EF4-FFF2-40B4-BE49-F238E27FC236}">
-                <a16:creationId xmlns:a16="http://schemas.microsoft.com/office/drawing/2014/main" id="{7FB5FE54-8584-BDD4-B6B8-9CE40FA9CE29}"/>
-              </a:ext>
-            </a:extLst>
-          </p:cNvPr>
-          <p:cNvSpPr>
-            <a:spLocks noGrp="1"/>
-          </p:cNvSpPr>
-          <p:nvPr>
-            <p:ph type="sldNum" sz="quarter" idx="5"/>
-          </p:nvPr>
-        </p:nvSpPr>
-        <p:spPr/>
-        <p:txBody>
-          <a:bodyPr/>
-          <a:lstStyle/>
-          <a:p>
-            <a:fld id="{3599D024-DE68-44ED-822F-D827F84FBD4A}" type="slidenum">
-              <a:rPr lang="ko-KR" altLang="en-US" smtClean="0"/>
-              <a:t>41</a:t>
-            </a:fld>
-            <a:endParaRPr lang="ko-KR" altLang="en-US"/>
-          </a:p>
-        </p:txBody>
-      </p:sp>
-    </p:spTree>
-    <p:extLst>
-      <p:ext uri="{BB962C8B-B14F-4D97-AF65-F5344CB8AC3E}">
-        <p14:creationId xmlns:p14="http://schemas.microsoft.com/office/powerpoint/2010/main" val="3825128874"/>
-      </p:ext>
-    </p:extLst>
-  </p:cSld>
-  <p:clrMapOvr>
-    <a:masterClrMapping/>
-  </p:clrMapOvr>
-</p:notes>
-</file>
-
-<file path=ppt/notesSlides/notesSlide42.xml><?xml version="1.0" encoding="utf-8"?>
-<p:notes xmlns:a="http://schemas.openxmlformats.org/drawingml/2006/main" xmlns:r="http://schemas.openxmlformats.org/officeDocument/2006/relationships" xmlns:p="http://schemas.openxmlformats.org/presentationml/2006/main">
-  <p:cSld>
-    <p:spTree>
-      <p:nvGrpSpPr>
-        <p:cNvPr id="1" name="">
-          <a:extLst>
-            <a:ext uri="{FF2B5EF4-FFF2-40B4-BE49-F238E27FC236}">
-              <a16:creationId xmlns:a16="http://schemas.microsoft.com/office/drawing/2014/main" id="{4602B23F-CFB6-7739-E65A-B2E3E6EEA225}"/>
-            </a:ext>
-          </a:extLst>
-        </p:cNvPr>
-        <p:cNvGrpSpPr/>
-        <p:nvPr/>
-      </p:nvGrpSpPr>
-      <p:grpSpPr>
-        <a:xfrm>
-          <a:off x="0" y="0"/>
-          <a:ext cx="0" cy="0"/>
-          <a:chOff x="0" y="0"/>
-          <a:chExt cx="0" cy="0"/>
-        </a:xfrm>
-      </p:grpSpPr>
-      <p:sp>
-        <p:nvSpPr>
-          <p:cNvPr id="2" name="슬라이드 이미지 개체 틀 1">
-            <a:extLst>
-              <a:ext uri="{FF2B5EF4-FFF2-40B4-BE49-F238E27FC236}">
-                <a16:creationId xmlns:a16="http://schemas.microsoft.com/office/drawing/2014/main" id="{B40DB949-E536-B81C-054D-6FDB674BC194}"/>
-              </a:ext>
-            </a:extLst>
-          </p:cNvPr>
-          <p:cNvSpPr>
-            <a:spLocks noGrp="1" noRot="1" noChangeAspect="1"/>
-          </p:cNvSpPr>
-          <p:nvPr>
-            <p:ph type="sldImg"/>
-          </p:nvPr>
-        </p:nvSpPr>
-        <p:spPr/>
-      </p:sp>
-      <p:sp>
-        <p:nvSpPr>
-          <p:cNvPr id="3" name="슬라이드 노트 개체 틀 2">
-            <a:extLst>
-              <a:ext uri="{FF2B5EF4-FFF2-40B4-BE49-F238E27FC236}">
-                <a16:creationId xmlns:a16="http://schemas.microsoft.com/office/drawing/2014/main" id="{B1D1A4AD-6DF9-D9D0-B4AD-A71377AB0DD1}"/>
-              </a:ext>
-            </a:extLst>
-          </p:cNvPr>
-          <p:cNvSpPr>
-            <a:spLocks noGrp="1"/>
-          </p:cNvSpPr>
-          <p:nvPr>
-            <p:ph type="body" idx="1"/>
-          </p:nvPr>
-        </p:nvSpPr>
-        <p:spPr/>
-        <p:txBody>
-          <a:bodyPr/>
-          <a:lstStyle/>
-          <a:p>
-            <a:r>
-              <a:rPr lang="ko-KR" altLang="en-US" dirty="0"/>
-              <a:t>프로그래밍</a:t>
-            </a:r>
-          </a:p>
-        </p:txBody>
-      </p:sp>
-      <p:sp>
-        <p:nvSpPr>
-          <p:cNvPr id="4" name="슬라이드 번호 개체 틀 3">
-            <a:extLst>
-              <a:ext uri="{FF2B5EF4-FFF2-40B4-BE49-F238E27FC236}">
-                <a16:creationId xmlns:a16="http://schemas.microsoft.com/office/drawing/2014/main" id="{676435A9-A1AE-C493-123D-76516A360E39}"/>
-              </a:ext>
-            </a:extLst>
-          </p:cNvPr>
-          <p:cNvSpPr>
-            <a:spLocks noGrp="1"/>
-          </p:cNvSpPr>
-          <p:nvPr>
-            <p:ph type="sldNum" sz="quarter" idx="5"/>
-          </p:nvPr>
-        </p:nvSpPr>
-        <p:spPr/>
-        <p:txBody>
-          <a:bodyPr/>
-          <a:lstStyle/>
-          <a:p>
-            <a:fld id="{3599D024-DE68-44ED-822F-D827F84FBD4A}" type="slidenum">
-              <a:rPr lang="ko-KR" altLang="en-US" smtClean="0"/>
-              <a:t>42</a:t>
-            </a:fld>
-            <a:endParaRPr lang="ko-KR" altLang="en-US"/>
-          </a:p>
-        </p:txBody>
-      </p:sp>
-    </p:spTree>
-    <p:extLst>
-      <p:ext uri="{BB962C8B-B14F-4D97-AF65-F5344CB8AC3E}">
-        <p14:creationId xmlns:p14="http://schemas.microsoft.com/office/powerpoint/2010/main" val="692489372"/>
-      </p:ext>
-    </p:extLst>
-  </p:cSld>
-  <p:clrMapOvr>
-    <a:masterClrMapping/>
-  </p:clrMapOvr>
-</p:notes>
-</file>
-
-<file path=ppt/notesSlides/notesSlide43.xml><?xml version="1.0" encoding="utf-8"?>
-<p:notes xmlns:a="http://schemas.openxmlformats.org/drawingml/2006/main" xmlns:r="http://schemas.openxmlformats.org/officeDocument/2006/relationships" xmlns:p="http://schemas.openxmlformats.org/presentationml/2006/main">
-  <p:cSld>
-    <p:spTree>
-      <p:nvGrpSpPr>
-        <p:cNvPr id="1" name="">
-          <a:extLst>
-            <a:ext uri="{FF2B5EF4-FFF2-40B4-BE49-F238E27FC236}">
-              <a16:creationId xmlns:a16="http://schemas.microsoft.com/office/drawing/2014/main" id="{233FA75D-2E90-2945-F357-6070F174C427}"/>
-            </a:ext>
-          </a:extLst>
-        </p:cNvPr>
-        <p:cNvGrpSpPr/>
-        <p:nvPr/>
-      </p:nvGrpSpPr>
-      <p:grpSpPr>
-        <a:xfrm>
-          <a:off x="0" y="0"/>
-          <a:ext cx="0" cy="0"/>
-          <a:chOff x="0" y="0"/>
-          <a:chExt cx="0" cy="0"/>
-        </a:xfrm>
-      </p:grpSpPr>
-      <p:sp>
-        <p:nvSpPr>
-          <p:cNvPr id="2" name="슬라이드 이미지 개체 틀 1">
-            <a:extLst>
-              <a:ext uri="{FF2B5EF4-FFF2-40B4-BE49-F238E27FC236}">
-                <a16:creationId xmlns:a16="http://schemas.microsoft.com/office/drawing/2014/main" id="{B2658B33-C885-4BC2-2EAD-1B3E4E00E6EA}"/>
-              </a:ext>
-            </a:extLst>
-          </p:cNvPr>
-          <p:cNvSpPr>
-            <a:spLocks noGrp="1" noRot="1" noChangeAspect="1"/>
-          </p:cNvSpPr>
-          <p:nvPr>
-            <p:ph type="sldImg"/>
-          </p:nvPr>
-        </p:nvSpPr>
-        <p:spPr/>
-      </p:sp>
-      <p:sp>
-        <p:nvSpPr>
-          <p:cNvPr id="3" name="슬라이드 노트 개체 틀 2">
-            <a:extLst>
-              <a:ext uri="{FF2B5EF4-FFF2-40B4-BE49-F238E27FC236}">
-                <a16:creationId xmlns:a16="http://schemas.microsoft.com/office/drawing/2014/main" id="{879F8394-2040-D1BF-C0DE-BE2CC725F3E5}"/>
-              </a:ext>
-            </a:extLst>
-          </p:cNvPr>
-          <p:cNvSpPr>
-            <a:spLocks noGrp="1"/>
-          </p:cNvSpPr>
-          <p:nvPr>
-            <p:ph type="body" idx="1"/>
-          </p:nvPr>
-        </p:nvSpPr>
-        <p:spPr/>
-        <p:txBody>
-          <a:bodyPr/>
-          <a:lstStyle/>
-          <a:p>
-            <a:r>
-              <a:rPr lang="ko-KR" altLang="en-US" dirty="0"/>
-              <a:t>프로그래밍</a:t>
-            </a:r>
-          </a:p>
-        </p:txBody>
-      </p:sp>
-      <p:sp>
-        <p:nvSpPr>
-          <p:cNvPr id="4" name="슬라이드 번호 개체 틀 3">
-            <a:extLst>
-              <a:ext uri="{FF2B5EF4-FFF2-40B4-BE49-F238E27FC236}">
-                <a16:creationId xmlns:a16="http://schemas.microsoft.com/office/drawing/2014/main" id="{72807314-D5A4-22C7-53A0-71215CCF59D0}"/>
-              </a:ext>
-            </a:extLst>
-          </p:cNvPr>
-          <p:cNvSpPr>
-            <a:spLocks noGrp="1"/>
-          </p:cNvSpPr>
-          <p:nvPr>
-            <p:ph type="sldNum" sz="quarter" idx="5"/>
-          </p:nvPr>
-        </p:nvSpPr>
-        <p:spPr/>
-        <p:txBody>
-          <a:bodyPr/>
-          <a:lstStyle/>
-          <a:p>
-            <a:fld id="{3599D024-DE68-44ED-822F-D827F84FBD4A}" type="slidenum">
-              <a:rPr lang="ko-KR" altLang="en-US" smtClean="0"/>
-              <a:t>43</a:t>
-            </a:fld>
-            <a:endParaRPr lang="ko-KR" altLang="en-US"/>
-          </a:p>
-        </p:txBody>
-      </p:sp>
-    </p:spTree>
-    <p:extLst>
-      <p:ext uri="{BB962C8B-B14F-4D97-AF65-F5344CB8AC3E}">
-        <p14:creationId xmlns:p14="http://schemas.microsoft.com/office/powerpoint/2010/main" val="1692042454"/>
-      </p:ext>
-    </p:extLst>
-  </p:cSld>
-  <p:clrMapOvr>
-    <a:masterClrMapping/>
-  </p:clrMapOvr>
-</p:notes>
-</file>
-
-<file path=ppt/notesSlides/notesSlide44.xml><?xml version="1.0" encoding="utf-8"?>
-<p:notes xmlns:a="http://schemas.openxmlformats.org/drawingml/2006/main" xmlns:r="http://schemas.openxmlformats.org/officeDocument/2006/relationships" xmlns:p="http://schemas.openxmlformats.org/presentationml/2006/main">
-  <p:cSld>
-    <p:spTree>
-      <p:nvGrpSpPr>
-        <p:cNvPr id="1" name="">
-          <a:extLst>
-            <a:ext uri="{FF2B5EF4-FFF2-40B4-BE49-F238E27FC236}">
-              <a16:creationId xmlns:a16="http://schemas.microsoft.com/office/drawing/2014/main" id="{13A57F28-D6EB-A5F1-E193-7FE9A4B5FCD5}"/>
-            </a:ext>
-          </a:extLst>
-        </p:cNvPr>
-        <p:cNvGrpSpPr/>
-        <p:nvPr/>
-      </p:nvGrpSpPr>
-      <p:grpSpPr>
-        <a:xfrm>
-          <a:off x="0" y="0"/>
-          <a:ext cx="0" cy="0"/>
-          <a:chOff x="0" y="0"/>
-          <a:chExt cx="0" cy="0"/>
-        </a:xfrm>
-      </p:grpSpPr>
-      <p:sp>
-        <p:nvSpPr>
-          <p:cNvPr id="2" name="슬라이드 이미지 개체 틀 1">
-            <a:extLst>
-              <a:ext uri="{FF2B5EF4-FFF2-40B4-BE49-F238E27FC236}">
-                <a16:creationId xmlns:a16="http://schemas.microsoft.com/office/drawing/2014/main" id="{BEC6FF79-CF80-E0A5-48EA-63834C100A2D}"/>
-              </a:ext>
-            </a:extLst>
-          </p:cNvPr>
-          <p:cNvSpPr>
-            <a:spLocks noGrp="1" noRot="1" noChangeAspect="1"/>
-          </p:cNvSpPr>
-          <p:nvPr>
-            <p:ph type="sldImg"/>
-          </p:nvPr>
-        </p:nvSpPr>
-        <p:spPr/>
-      </p:sp>
-      <p:sp>
-        <p:nvSpPr>
-          <p:cNvPr id="3" name="슬라이드 노트 개체 틀 2">
-            <a:extLst>
-              <a:ext uri="{FF2B5EF4-FFF2-40B4-BE49-F238E27FC236}">
-                <a16:creationId xmlns:a16="http://schemas.microsoft.com/office/drawing/2014/main" id="{C6DD16C4-A589-7F2C-767F-C2D5E511A664}"/>
-              </a:ext>
-            </a:extLst>
-          </p:cNvPr>
-          <p:cNvSpPr>
-            <a:spLocks noGrp="1"/>
-          </p:cNvSpPr>
-          <p:nvPr>
-            <p:ph type="body" idx="1"/>
-          </p:nvPr>
-        </p:nvSpPr>
-        <p:spPr/>
-        <p:txBody>
-          <a:bodyPr/>
-          <a:lstStyle/>
-          <a:p>
-            <a:r>
-              <a:rPr lang="ko-KR" altLang="en-US" dirty="0"/>
-              <a:t>프로그래밍</a:t>
-            </a:r>
-          </a:p>
-        </p:txBody>
-      </p:sp>
-      <p:sp>
-        <p:nvSpPr>
-          <p:cNvPr id="4" name="슬라이드 번호 개체 틀 3">
-            <a:extLst>
-              <a:ext uri="{FF2B5EF4-FFF2-40B4-BE49-F238E27FC236}">
-                <a16:creationId xmlns:a16="http://schemas.microsoft.com/office/drawing/2014/main" id="{767BD9FB-1976-A717-D5F1-55A8D9A584E1}"/>
-              </a:ext>
-            </a:extLst>
-          </p:cNvPr>
-          <p:cNvSpPr>
-            <a:spLocks noGrp="1"/>
-          </p:cNvSpPr>
-          <p:nvPr>
-            <p:ph type="sldNum" sz="quarter" idx="5"/>
-          </p:nvPr>
-        </p:nvSpPr>
-        <p:spPr/>
-        <p:txBody>
-          <a:bodyPr/>
-          <a:lstStyle/>
-          <a:p>
-            <a:fld id="{3599D024-DE68-44ED-822F-D827F84FBD4A}" type="slidenum">
-              <a:rPr lang="ko-KR" altLang="en-US" smtClean="0"/>
-              <a:t>44</a:t>
-            </a:fld>
-            <a:endParaRPr lang="ko-KR" altLang="en-US"/>
-          </a:p>
-        </p:txBody>
-      </p:sp>
-    </p:spTree>
-    <p:extLst>
-      <p:ext uri="{BB962C8B-B14F-4D97-AF65-F5344CB8AC3E}">
-        <p14:creationId xmlns:p14="http://schemas.microsoft.com/office/powerpoint/2010/main" val="2922483791"/>
-      </p:ext>
-    </p:extLst>
-  </p:cSld>
-  <p:clrMapOvr>
-    <a:masterClrMapping/>
-  </p:clrMapOvr>
-</p:notes>
-</file>
-
-<file path=ppt/notesSlides/notesSlide45.xml><?xml version="1.0" encoding="utf-8"?>
-<p:notes xmlns:a="http://schemas.openxmlformats.org/drawingml/2006/main" xmlns:r="http://schemas.openxmlformats.org/officeDocument/2006/relationships" xmlns:p="http://schemas.openxmlformats.org/presentationml/2006/main">
-  <p:cSld>
-    <p:spTree>
-      <p:nvGrpSpPr>
-        <p:cNvPr id="1" name="">
-          <a:extLst>
-            <a:ext uri="{FF2B5EF4-FFF2-40B4-BE49-F238E27FC236}">
-              <a16:creationId xmlns:a16="http://schemas.microsoft.com/office/drawing/2014/main" id="{B69FD9F4-138A-D0F7-672F-C3B81430B7FF}"/>
-            </a:ext>
-          </a:extLst>
-        </p:cNvPr>
-        <p:cNvGrpSpPr/>
-        <p:nvPr/>
-      </p:nvGrpSpPr>
-      <p:grpSpPr>
-        <a:xfrm>
-          <a:off x="0" y="0"/>
-          <a:ext cx="0" cy="0"/>
-          <a:chOff x="0" y="0"/>
-          <a:chExt cx="0" cy="0"/>
-        </a:xfrm>
-      </p:grpSpPr>
-      <p:sp>
-        <p:nvSpPr>
-          <p:cNvPr id="2" name="슬라이드 이미지 개체 틀 1">
-            <a:extLst>
-              <a:ext uri="{FF2B5EF4-FFF2-40B4-BE49-F238E27FC236}">
-                <a16:creationId xmlns:a16="http://schemas.microsoft.com/office/drawing/2014/main" id="{7E4E8DE2-185D-A9C5-2BDF-2F58C6D3EB5A}"/>
-              </a:ext>
-            </a:extLst>
-          </p:cNvPr>
-          <p:cNvSpPr>
-            <a:spLocks noGrp="1" noRot="1" noChangeAspect="1"/>
-          </p:cNvSpPr>
-          <p:nvPr>
-            <p:ph type="sldImg"/>
-          </p:nvPr>
-        </p:nvSpPr>
-        <p:spPr/>
-      </p:sp>
-      <p:sp>
-        <p:nvSpPr>
-          <p:cNvPr id="3" name="슬라이드 노트 개체 틀 2">
-            <a:extLst>
-              <a:ext uri="{FF2B5EF4-FFF2-40B4-BE49-F238E27FC236}">
-                <a16:creationId xmlns:a16="http://schemas.microsoft.com/office/drawing/2014/main" id="{08C18EC0-E7F5-B446-17BB-FFC505309108}"/>
-              </a:ext>
-            </a:extLst>
-          </p:cNvPr>
-          <p:cNvSpPr>
-            <a:spLocks noGrp="1"/>
-          </p:cNvSpPr>
-          <p:nvPr>
-            <p:ph type="body" idx="1"/>
-          </p:nvPr>
-        </p:nvSpPr>
-        <p:spPr/>
-        <p:txBody>
-          <a:bodyPr/>
-          <a:lstStyle/>
-          <a:p>
-            <a:r>
-              <a:rPr lang="ko-KR" altLang="en-US" dirty="0"/>
-              <a:t>프로그래밍</a:t>
-            </a:r>
-          </a:p>
-        </p:txBody>
-      </p:sp>
-      <p:sp>
-        <p:nvSpPr>
-          <p:cNvPr id="4" name="슬라이드 번호 개체 틀 3">
-            <a:extLst>
-              <a:ext uri="{FF2B5EF4-FFF2-40B4-BE49-F238E27FC236}">
-                <a16:creationId xmlns:a16="http://schemas.microsoft.com/office/drawing/2014/main" id="{3E76B4FE-3A46-C9B5-DC45-92D711FC4367}"/>
-              </a:ext>
-            </a:extLst>
-          </p:cNvPr>
-          <p:cNvSpPr>
-            <a:spLocks noGrp="1"/>
-          </p:cNvSpPr>
-          <p:nvPr>
-            <p:ph type="sldNum" sz="quarter" idx="5"/>
-          </p:nvPr>
-        </p:nvSpPr>
-        <p:spPr/>
-        <p:txBody>
-          <a:bodyPr/>
-          <a:lstStyle/>
-          <a:p>
-            <a:fld id="{3599D024-DE68-44ED-822F-D827F84FBD4A}" type="slidenum">
-              <a:rPr lang="ko-KR" altLang="en-US" smtClean="0"/>
-              <a:t>45</a:t>
-            </a:fld>
-            <a:endParaRPr lang="ko-KR" altLang="en-US"/>
-          </a:p>
-        </p:txBody>
-      </p:sp>
-    </p:spTree>
-    <p:extLst>
-      <p:ext uri="{BB962C8B-B14F-4D97-AF65-F5344CB8AC3E}">
-        <p14:creationId xmlns:p14="http://schemas.microsoft.com/office/powerpoint/2010/main" val="3681834392"/>
-      </p:ext>
-    </p:extLst>
-  </p:cSld>
-  <p:clrMapOvr>
-    <a:masterClrMapping/>
-  </p:clrMapOvr>
-</p:notes>
-</file>
-
-<file path=ppt/notesSlides/notesSlide46.xml><?xml version="1.0" encoding="utf-8"?>
-<p:notes xmlns:a="http://schemas.openxmlformats.org/drawingml/2006/main" xmlns:r="http://schemas.openxmlformats.org/officeDocument/2006/relationships" xmlns:p="http://schemas.openxmlformats.org/presentationml/2006/main">
-  <p:cSld>
-    <p:spTree>
-      <p:nvGrpSpPr>
-        <p:cNvPr id="1" name="">
-          <a:extLst>
-            <a:ext uri="{FF2B5EF4-FFF2-40B4-BE49-F238E27FC236}">
-              <a16:creationId xmlns:a16="http://schemas.microsoft.com/office/drawing/2014/main" id="{598A5B56-CA06-0A3D-554D-F35B40E0E94B}"/>
-            </a:ext>
-          </a:extLst>
-        </p:cNvPr>
-        <p:cNvGrpSpPr/>
-        <p:nvPr/>
-      </p:nvGrpSpPr>
-      <p:grpSpPr>
-        <a:xfrm>
-          <a:off x="0" y="0"/>
-          <a:ext cx="0" cy="0"/>
-          <a:chOff x="0" y="0"/>
-          <a:chExt cx="0" cy="0"/>
-        </a:xfrm>
-      </p:grpSpPr>
-      <p:sp>
-        <p:nvSpPr>
-          <p:cNvPr id="2" name="슬라이드 이미지 개체 틀 1">
-            <a:extLst>
-              <a:ext uri="{FF2B5EF4-FFF2-40B4-BE49-F238E27FC236}">
-                <a16:creationId xmlns:a16="http://schemas.microsoft.com/office/drawing/2014/main" id="{2D9BBEFF-88CD-87B1-8871-4B5038DA82F0}"/>
-              </a:ext>
-            </a:extLst>
-          </p:cNvPr>
-          <p:cNvSpPr>
-            <a:spLocks noGrp="1" noRot="1" noChangeAspect="1"/>
-          </p:cNvSpPr>
-          <p:nvPr>
-            <p:ph type="sldImg"/>
-          </p:nvPr>
-        </p:nvSpPr>
-        <p:spPr/>
-      </p:sp>
-      <p:sp>
-        <p:nvSpPr>
-          <p:cNvPr id="3" name="슬라이드 노트 개체 틀 2">
-            <a:extLst>
-              <a:ext uri="{FF2B5EF4-FFF2-40B4-BE49-F238E27FC236}">
-                <a16:creationId xmlns:a16="http://schemas.microsoft.com/office/drawing/2014/main" id="{1B47D9AB-9FE0-7717-81ED-A4E1BB05875F}"/>
+                <a16:creationId xmlns:a16="http://schemas.microsoft.com/office/drawing/2014/main" id="{96D80661-1443-3CF7-C40E-BFB6A8BF9840}"/>
               </a:ext>
             </a:extLst>
           </p:cNvPr>
@@ -7447,7 +6893,562 @@
           <p:cNvPr id="4" name="슬라이드 번호 개체 틀 3">
             <a:extLst>
               <a:ext uri="{FF2B5EF4-FFF2-40B4-BE49-F238E27FC236}">
-                <a16:creationId xmlns:a16="http://schemas.microsoft.com/office/drawing/2014/main" id="{A6DA8553-90C0-CAC0-DD76-537C86BCBF6B}"/>
+                <a16:creationId xmlns:a16="http://schemas.microsoft.com/office/drawing/2014/main" id="{4272D748-2A86-C3CF-42E3-8CAC7F616DCF}"/>
+              </a:ext>
+            </a:extLst>
+          </p:cNvPr>
+          <p:cNvSpPr>
+            <a:spLocks noGrp="1"/>
+          </p:cNvSpPr>
+          <p:nvPr>
+            <p:ph type="sldNum" sz="quarter" idx="5"/>
+          </p:nvPr>
+        </p:nvSpPr>
+        <p:spPr/>
+        <p:txBody>
+          <a:bodyPr/>
+          <a:lstStyle/>
+          <a:p>
+            <a:fld id="{3599D024-DE68-44ED-822F-D827F84FBD4A}" type="slidenum">
+              <a:rPr lang="ko-KR" altLang="en-US" smtClean="0"/>
+              <a:t>41</a:t>
+            </a:fld>
+            <a:endParaRPr lang="ko-KR" altLang="en-US"/>
+          </a:p>
+        </p:txBody>
+      </p:sp>
+    </p:spTree>
+    <p:extLst>
+      <p:ext uri="{BB962C8B-B14F-4D97-AF65-F5344CB8AC3E}">
+        <p14:creationId xmlns:p14="http://schemas.microsoft.com/office/powerpoint/2010/main" val="3219764159"/>
+      </p:ext>
+    </p:extLst>
+  </p:cSld>
+  <p:clrMapOvr>
+    <a:masterClrMapping/>
+  </p:clrMapOvr>
+</p:notes>
+</file>
+
+<file path=ppt/notesSlides/notesSlide42.xml><?xml version="1.0" encoding="utf-8"?>
+<p:notes xmlns:a="http://schemas.openxmlformats.org/drawingml/2006/main" xmlns:r="http://schemas.openxmlformats.org/officeDocument/2006/relationships" xmlns:p="http://schemas.openxmlformats.org/presentationml/2006/main">
+  <p:cSld>
+    <p:spTree>
+      <p:nvGrpSpPr>
+        <p:cNvPr id="1" name="">
+          <a:extLst>
+            <a:ext uri="{FF2B5EF4-FFF2-40B4-BE49-F238E27FC236}">
+              <a16:creationId xmlns:a16="http://schemas.microsoft.com/office/drawing/2014/main" id="{034B4BCE-D74C-80A8-A52D-73A43465F725}"/>
+            </a:ext>
+          </a:extLst>
+        </p:cNvPr>
+        <p:cNvGrpSpPr/>
+        <p:nvPr/>
+      </p:nvGrpSpPr>
+      <p:grpSpPr>
+        <a:xfrm>
+          <a:off x="0" y="0"/>
+          <a:ext cx="0" cy="0"/>
+          <a:chOff x="0" y="0"/>
+          <a:chExt cx="0" cy="0"/>
+        </a:xfrm>
+      </p:grpSpPr>
+      <p:sp>
+        <p:nvSpPr>
+          <p:cNvPr id="2" name="슬라이드 이미지 개체 틀 1">
+            <a:extLst>
+              <a:ext uri="{FF2B5EF4-FFF2-40B4-BE49-F238E27FC236}">
+                <a16:creationId xmlns:a16="http://schemas.microsoft.com/office/drawing/2014/main" id="{4E7F5753-F0A5-9296-929D-E2602DC5D9FD}"/>
+              </a:ext>
+            </a:extLst>
+          </p:cNvPr>
+          <p:cNvSpPr>
+            <a:spLocks noGrp="1" noRot="1" noChangeAspect="1"/>
+          </p:cNvSpPr>
+          <p:nvPr>
+            <p:ph type="sldImg"/>
+          </p:nvPr>
+        </p:nvSpPr>
+        <p:spPr/>
+      </p:sp>
+      <p:sp>
+        <p:nvSpPr>
+          <p:cNvPr id="3" name="슬라이드 노트 개체 틀 2">
+            <a:extLst>
+              <a:ext uri="{FF2B5EF4-FFF2-40B4-BE49-F238E27FC236}">
+                <a16:creationId xmlns:a16="http://schemas.microsoft.com/office/drawing/2014/main" id="{BE1F9F60-CF56-3853-2A74-D96094114CC9}"/>
+              </a:ext>
+            </a:extLst>
+          </p:cNvPr>
+          <p:cNvSpPr>
+            <a:spLocks noGrp="1"/>
+          </p:cNvSpPr>
+          <p:nvPr>
+            <p:ph type="body" idx="1"/>
+          </p:nvPr>
+        </p:nvSpPr>
+        <p:spPr/>
+        <p:txBody>
+          <a:bodyPr/>
+          <a:lstStyle/>
+          <a:p>
+            <a:r>
+              <a:rPr lang="ko-KR" altLang="en-US" dirty="0"/>
+              <a:t>프로그래밍</a:t>
+            </a:r>
+          </a:p>
+        </p:txBody>
+      </p:sp>
+      <p:sp>
+        <p:nvSpPr>
+          <p:cNvPr id="4" name="슬라이드 번호 개체 틀 3">
+            <a:extLst>
+              <a:ext uri="{FF2B5EF4-FFF2-40B4-BE49-F238E27FC236}">
+                <a16:creationId xmlns:a16="http://schemas.microsoft.com/office/drawing/2014/main" id="{7FB5FE54-8584-BDD4-B6B8-9CE40FA9CE29}"/>
+              </a:ext>
+            </a:extLst>
+          </p:cNvPr>
+          <p:cNvSpPr>
+            <a:spLocks noGrp="1"/>
+          </p:cNvSpPr>
+          <p:nvPr>
+            <p:ph type="sldNum" sz="quarter" idx="5"/>
+          </p:nvPr>
+        </p:nvSpPr>
+        <p:spPr/>
+        <p:txBody>
+          <a:bodyPr/>
+          <a:lstStyle/>
+          <a:p>
+            <a:fld id="{3599D024-DE68-44ED-822F-D827F84FBD4A}" type="slidenum">
+              <a:rPr lang="ko-KR" altLang="en-US" smtClean="0"/>
+              <a:t>42</a:t>
+            </a:fld>
+            <a:endParaRPr lang="ko-KR" altLang="en-US"/>
+          </a:p>
+        </p:txBody>
+      </p:sp>
+    </p:spTree>
+    <p:extLst>
+      <p:ext uri="{BB962C8B-B14F-4D97-AF65-F5344CB8AC3E}">
+        <p14:creationId xmlns:p14="http://schemas.microsoft.com/office/powerpoint/2010/main" val="3825128874"/>
+      </p:ext>
+    </p:extLst>
+  </p:cSld>
+  <p:clrMapOvr>
+    <a:masterClrMapping/>
+  </p:clrMapOvr>
+</p:notes>
+</file>
+
+<file path=ppt/notesSlides/notesSlide43.xml><?xml version="1.0" encoding="utf-8"?>
+<p:notes xmlns:a="http://schemas.openxmlformats.org/drawingml/2006/main" xmlns:r="http://schemas.openxmlformats.org/officeDocument/2006/relationships" xmlns:p="http://schemas.openxmlformats.org/presentationml/2006/main">
+  <p:cSld>
+    <p:spTree>
+      <p:nvGrpSpPr>
+        <p:cNvPr id="1" name="">
+          <a:extLst>
+            <a:ext uri="{FF2B5EF4-FFF2-40B4-BE49-F238E27FC236}">
+              <a16:creationId xmlns:a16="http://schemas.microsoft.com/office/drawing/2014/main" id="{4602B23F-CFB6-7739-E65A-B2E3E6EEA225}"/>
+            </a:ext>
+          </a:extLst>
+        </p:cNvPr>
+        <p:cNvGrpSpPr/>
+        <p:nvPr/>
+      </p:nvGrpSpPr>
+      <p:grpSpPr>
+        <a:xfrm>
+          <a:off x="0" y="0"/>
+          <a:ext cx="0" cy="0"/>
+          <a:chOff x="0" y="0"/>
+          <a:chExt cx="0" cy="0"/>
+        </a:xfrm>
+      </p:grpSpPr>
+      <p:sp>
+        <p:nvSpPr>
+          <p:cNvPr id="2" name="슬라이드 이미지 개체 틀 1">
+            <a:extLst>
+              <a:ext uri="{FF2B5EF4-FFF2-40B4-BE49-F238E27FC236}">
+                <a16:creationId xmlns:a16="http://schemas.microsoft.com/office/drawing/2014/main" id="{B40DB949-E536-B81C-054D-6FDB674BC194}"/>
+              </a:ext>
+            </a:extLst>
+          </p:cNvPr>
+          <p:cNvSpPr>
+            <a:spLocks noGrp="1" noRot="1" noChangeAspect="1"/>
+          </p:cNvSpPr>
+          <p:nvPr>
+            <p:ph type="sldImg"/>
+          </p:nvPr>
+        </p:nvSpPr>
+        <p:spPr/>
+      </p:sp>
+      <p:sp>
+        <p:nvSpPr>
+          <p:cNvPr id="3" name="슬라이드 노트 개체 틀 2">
+            <a:extLst>
+              <a:ext uri="{FF2B5EF4-FFF2-40B4-BE49-F238E27FC236}">
+                <a16:creationId xmlns:a16="http://schemas.microsoft.com/office/drawing/2014/main" id="{B1D1A4AD-6DF9-D9D0-B4AD-A71377AB0DD1}"/>
+              </a:ext>
+            </a:extLst>
+          </p:cNvPr>
+          <p:cNvSpPr>
+            <a:spLocks noGrp="1"/>
+          </p:cNvSpPr>
+          <p:nvPr>
+            <p:ph type="body" idx="1"/>
+          </p:nvPr>
+        </p:nvSpPr>
+        <p:spPr/>
+        <p:txBody>
+          <a:bodyPr/>
+          <a:lstStyle/>
+          <a:p>
+            <a:r>
+              <a:rPr lang="ko-KR" altLang="en-US" dirty="0"/>
+              <a:t>프로그래밍</a:t>
+            </a:r>
+          </a:p>
+        </p:txBody>
+      </p:sp>
+      <p:sp>
+        <p:nvSpPr>
+          <p:cNvPr id="4" name="슬라이드 번호 개체 틀 3">
+            <a:extLst>
+              <a:ext uri="{FF2B5EF4-FFF2-40B4-BE49-F238E27FC236}">
+                <a16:creationId xmlns:a16="http://schemas.microsoft.com/office/drawing/2014/main" id="{676435A9-A1AE-C493-123D-76516A360E39}"/>
+              </a:ext>
+            </a:extLst>
+          </p:cNvPr>
+          <p:cNvSpPr>
+            <a:spLocks noGrp="1"/>
+          </p:cNvSpPr>
+          <p:nvPr>
+            <p:ph type="sldNum" sz="quarter" idx="5"/>
+          </p:nvPr>
+        </p:nvSpPr>
+        <p:spPr/>
+        <p:txBody>
+          <a:bodyPr/>
+          <a:lstStyle/>
+          <a:p>
+            <a:fld id="{3599D024-DE68-44ED-822F-D827F84FBD4A}" type="slidenum">
+              <a:rPr lang="ko-KR" altLang="en-US" smtClean="0"/>
+              <a:t>43</a:t>
+            </a:fld>
+            <a:endParaRPr lang="ko-KR" altLang="en-US"/>
+          </a:p>
+        </p:txBody>
+      </p:sp>
+    </p:spTree>
+    <p:extLst>
+      <p:ext uri="{BB962C8B-B14F-4D97-AF65-F5344CB8AC3E}">
+        <p14:creationId xmlns:p14="http://schemas.microsoft.com/office/powerpoint/2010/main" val="692489372"/>
+      </p:ext>
+    </p:extLst>
+  </p:cSld>
+  <p:clrMapOvr>
+    <a:masterClrMapping/>
+  </p:clrMapOvr>
+</p:notes>
+</file>
+
+<file path=ppt/notesSlides/notesSlide44.xml><?xml version="1.0" encoding="utf-8"?>
+<p:notes xmlns:a="http://schemas.openxmlformats.org/drawingml/2006/main" xmlns:r="http://schemas.openxmlformats.org/officeDocument/2006/relationships" xmlns:p="http://schemas.openxmlformats.org/presentationml/2006/main">
+  <p:cSld>
+    <p:spTree>
+      <p:nvGrpSpPr>
+        <p:cNvPr id="1" name="">
+          <a:extLst>
+            <a:ext uri="{FF2B5EF4-FFF2-40B4-BE49-F238E27FC236}">
+              <a16:creationId xmlns:a16="http://schemas.microsoft.com/office/drawing/2014/main" id="{233FA75D-2E90-2945-F357-6070F174C427}"/>
+            </a:ext>
+          </a:extLst>
+        </p:cNvPr>
+        <p:cNvGrpSpPr/>
+        <p:nvPr/>
+      </p:nvGrpSpPr>
+      <p:grpSpPr>
+        <a:xfrm>
+          <a:off x="0" y="0"/>
+          <a:ext cx="0" cy="0"/>
+          <a:chOff x="0" y="0"/>
+          <a:chExt cx="0" cy="0"/>
+        </a:xfrm>
+      </p:grpSpPr>
+      <p:sp>
+        <p:nvSpPr>
+          <p:cNvPr id="2" name="슬라이드 이미지 개체 틀 1">
+            <a:extLst>
+              <a:ext uri="{FF2B5EF4-FFF2-40B4-BE49-F238E27FC236}">
+                <a16:creationId xmlns:a16="http://schemas.microsoft.com/office/drawing/2014/main" id="{B2658B33-C885-4BC2-2EAD-1B3E4E00E6EA}"/>
+              </a:ext>
+            </a:extLst>
+          </p:cNvPr>
+          <p:cNvSpPr>
+            <a:spLocks noGrp="1" noRot="1" noChangeAspect="1"/>
+          </p:cNvSpPr>
+          <p:nvPr>
+            <p:ph type="sldImg"/>
+          </p:nvPr>
+        </p:nvSpPr>
+        <p:spPr/>
+      </p:sp>
+      <p:sp>
+        <p:nvSpPr>
+          <p:cNvPr id="3" name="슬라이드 노트 개체 틀 2">
+            <a:extLst>
+              <a:ext uri="{FF2B5EF4-FFF2-40B4-BE49-F238E27FC236}">
+                <a16:creationId xmlns:a16="http://schemas.microsoft.com/office/drawing/2014/main" id="{879F8394-2040-D1BF-C0DE-BE2CC725F3E5}"/>
+              </a:ext>
+            </a:extLst>
+          </p:cNvPr>
+          <p:cNvSpPr>
+            <a:spLocks noGrp="1"/>
+          </p:cNvSpPr>
+          <p:nvPr>
+            <p:ph type="body" idx="1"/>
+          </p:nvPr>
+        </p:nvSpPr>
+        <p:spPr/>
+        <p:txBody>
+          <a:bodyPr/>
+          <a:lstStyle/>
+          <a:p>
+            <a:r>
+              <a:rPr lang="ko-KR" altLang="en-US" dirty="0"/>
+              <a:t>프로그래밍</a:t>
+            </a:r>
+          </a:p>
+        </p:txBody>
+      </p:sp>
+      <p:sp>
+        <p:nvSpPr>
+          <p:cNvPr id="4" name="슬라이드 번호 개체 틀 3">
+            <a:extLst>
+              <a:ext uri="{FF2B5EF4-FFF2-40B4-BE49-F238E27FC236}">
+                <a16:creationId xmlns:a16="http://schemas.microsoft.com/office/drawing/2014/main" id="{72807314-D5A4-22C7-53A0-71215CCF59D0}"/>
+              </a:ext>
+            </a:extLst>
+          </p:cNvPr>
+          <p:cNvSpPr>
+            <a:spLocks noGrp="1"/>
+          </p:cNvSpPr>
+          <p:nvPr>
+            <p:ph type="sldNum" sz="quarter" idx="5"/>
+          </p:nvPr>
+        </p:nvSpPr>
+        <p:spPr/>
+        <p:txBody>
+          <a:bodyPr/>
+          <a:lstStyle/>
+          <a:p>
+            <a:fld id="{3599D024-DE68-44ED-822F-D827F84FBD4A}" type="slidenum">
+              <a:rPr lang="ko-KR" altLang="en-US" smtClean="0"/>
+              <a:t>44</a:t>
+            </a:fld>
+            <a:endParaRPr lang="ko-KR" altLang="en-US"/>
+          </a:p>
+        </p:txBody>
+      </p:sp>
+    </p:spTree>
+    <p:extLst>
+      <p:ext uri="{BB962C8B-B14F-4D97-AF65-F5344CB8AC3E}">
+        <p14:creationId xmlns:p14="http://schemas.microsoft.com/office/powerpoint/2010/main" val="1692042454"/>
+      </p:ext>
+    </p:extLst>
+  </p:cSld>
+  <p:clrMapOvr>
+    <a:masterClrMapping/>
+  </p:clrMapOvr>
+</p:notes>
+</file>
+
+<file path=ppt/notesSlides/notesSlide45.xml><?xml version="1.0" encoding="utf-8"?>
+<p:notes xmlns:a="http://schemas.openxmlformats.org/drawingml/2006/main" xmlns:r="http://schemas.openxmlformats.org/officeDocument/2006/relationships" xmlns:p="http://schemas.openxmlformats.org/presentationml/2006/main">
+  <p:cSld>
+    <p:spTree>
+      <p:nvGrpSpPr>
+        <p:cNvPr id="1" name="">
+          <a:extLst>
+            <a:ext uri="{FF2B5EF4-FFF2-40B4-BE49-F238E27FC236}">
+              <a16:creationId xmlns:a16="http://schemas.microsoft.com/office/drawing/2014/main" id="{13A57F28-D6EB-A5F1-E193-7FE9A4B5FCD5}"/>
+            </a:ext>
+          </a:extLst>
+        </p:cNvPr>
+        <p:cNvGrpSpPr/>
+        <p:nvPr/>
+      </p:nvGrpSpPr>
+      <p:grpSpPr>
+        <a:xfrm>
+          <a:off x="0" y="0"/>
+          <a:ext cx="0" cy="0"/>
+          <a:chOff x="0" y="0"/>
+          <a:chExt cx="0" cy="0"/>
+        </a:xfrm>
+      </p:grpSpPr>
+      <p:sp>
+        <p:nvSpPr>
+          <p:cNvPr id="2" name="슬라이드 이미지 개체 틀 1">
+            <a:extLst>
+              <a:ext uri="{FF2B5EF4-FFF2-40B4-BE49-F238E27FC236}">
+                <a16:creationId xmlns:a16="http://schemas.microsoft.com/office/drawing/2014/main" id="{BEC6FF79-CF80-E0A5-48EA-63834C100A2D}"/>
+              </a:ext>
+            </a:extLst>
+          </p:cNvPr>
+          <p:cNvSpPr>
+            <a:spLocks noGrp="1" noRot="1" noChangeAspect="1"/>
+          </p:cNvSpPr>
+          <p:nvPr>
+            <p:ph type="sldImg"/>
+          </p:nvPr>
+        </p:nvSpPr>
+        <p:spPr/>
+      </p:sp>
+      <p:sp>
+        <p:nvSpPr>
+          <p:cNvPr id="3" name="슬라이드 노트 개체 틀 2">
+            <a:extLst>
+              <a:ext uri="{FF2B5EF4-FFF2-40B4-BE49-F238E27FC236}">
+                <a16:creationId xmlns:a16="http://schemas.microsoft.com/office/drawing/2014/main" id="{C6DD16C4-A589-7F2C-767F-C2D5E511A664}"/>
+              </a:ext>
+            </a:extLst>
+          </p:cNvPr>
+          <p:cNvSpPr>
+            <a:spLocks noGrp="1"/>
+          </p:cNvSpPr>
+          <p:nvPr>
+            <p:ph type="body" idx="1"/>
+          </p:nvPr>
+        </p:nvSpPr>
+        <p:spPr/>
+        <p:txBody>
+          <a:bodyPr/>
+          <a:lstStyle/>
+          <a:p>
+            <a:r>
+              <a:rPr lang="ko-KR" altLang="en-US" dirty="0"/>
+              <a:t>프로그래밍</a:t>
+            </a:r>
+          </a:p>
+        </p:txBody>
+      </p:sp>
+      <p:sp>
+        <p:nvSpPr>
+          <p:cNvPr id="4" name="슬라이드 번호 개체 틀 3">
+            <a:extLst>
+              <a:ext uri="{FF2B5EF4-FFF2-40B4-BE49-F238E27FC236}">
+                <a16:creationId xmlns:a16="http://schemas.microsoft.com/office/drawing/2014/main" id="{767BD9FB-1976-A717-D5F1-55A8D9A584E1}"/>
+              </a:ext>
+            </a:extLst>
+          </p:cNvPr>
+          <p:cNvSpPr>
+            <a:spLocks noGrp="1"/>
+          </p:cNvSpPr>
+          <p:nvPr>
+            <p:ph type="sldNum" sz="quarter" idx="5"/>
+          </p:nvPr>
+        </p:nvSpPr>
+        <p:spPr/>
+        <p:txBody>
+          <a:bodyPr/>
+          <a:lstStyle/>
+          <a:p>
+            <a:fld id="{3599D024-DE68-44ED-822F-D827F84FBD4A}" type="slidenum">
+              <a:rPr lang="ko-KR" altLang="en-US" smtClean="0"/>
+              <a:t>45</a:t>
+            </a:fld>
+            <a:endParaRPr lang="ko-KR" altLang="en-US"/>
+          </a:p>
+        </p:txBody>
+      </p:sp>
+    </p:spTree>
+    <p:extLst>
+      <p:ext uri="{BB962C8B-B14F-4D97-AF65-F5344CB8AC3E}">
+        <p14:creationId xmlns:p14="http://schemas.microsoft.com/office/powerpoint/2010/main" val="2922483791"/>
+      </p:ext>
+    </p:extLst>
+  </p:cSld>
+  <p:clrMapOvr>
+    <a:masterClrMapping/>
+  </p:clrMapOvr>
+</p:notes>
+</file>
+
+<file path=ppt/notesSlides/notesSlide46.xml><?xml version="1.0" encoding="utf-8"?>
+<p:notes xmlns:a="http://schemas.openxmlformats.org/drawingml/2006/main" xmlns:r="http://schemas.openxmlformats.org/officeDocument/2006/relationships" xmlns:p="http://schemas.openxmlformats.org/presentationml/2006/main">
+  <p:cSld>
+    <p:spTree>
+      <p:nvGrpSpPr>
+        <p:cNvPr id="1" name="">
+          <a:extLst>
+            <a:ext uri="{FF2B5EF4-FFF2-40B4-BE49-F238E27FC236}">
+              <a16:creationId xmlns:a16="http://schemas.microsoft.com/office/drawing/2014/main" id="{B69FD9F4-138A-D0F7-672F-C3B81430B7FF}"/>
+            </a:ext>
+          </a:extLst>
+        </p:cNvPr>
+        <p:cNvGrpSpPr/>
+        <p:nvPr/>
+      </p:nvGrpSpPr>
+      <p:grpSpPr>
+        <a:xfrm>
+          <a:off x="0" y="0"/>
+          <a:ext cx="0" cy="0"/>
+          <a:chOff x="0" y="0"/>
+          <a:chExt cx="0" cy="0"/>
+        </a:xfrm>
+      </p:grpSpPr>
+      <p:sp>
+        <p:nvSpPr>
+          <p:cNvPr id="2" name="슬라이드 이미지 개체 틀 1">
+            <a:extLst>
+              <a:ext uri="{FF2B5EF4-FFF2-40B4-BE49-F238E27FC236}">
+                <a16:creationId xmlns:a16="http://schemas.microsoft.com/office/drawing/2014/main" id="{7E4E8DE2-185D-A9C5-2BDF-2F58C6D3EB5A}"/>
+              </a:ext>
+            </a:extLst>
+          </p:cNvPr>
+          <p:cNvSpPr>
+            <a:spLocks noGrp="1" noRot="1" noChangeAspect="1"/>
+          </p:cNvSpPr>
+          <p:nvPr>
+            <p:ph type="sldImg"/>
+          </p:nvPr>
+        </p:nvSpPr>
+        <p:spPr/>
+      </p:sp>
+      <p:sp>
+        <p:nvSpPr>
+          <p:cNvPr id="3" name="슬라이드 노트 개체 틀 2">
+            <a:extLst>
+              <a:ext uri="{FF2B5EF4-FFF2-40B4-BE49-F238E27FC236}">
+                <a16:creationId xmlns:a16="http://schemas.microsoft.com/office/drawing/2014/main" id="{08C18EC0-E7F5-B446-17BB-FFC505309108}"/>
+              </a:ext>
+            </a:extLst>
+          </p:cNvPr>
+          <p:cNvSpPr>
+            <a:spLocks noGrp="1"/>
+          </p:cNvSpPr>
+          <p:nvPr>
+            <p:ph type="body" idx="1"/>
+          </p:nvPr>
+        </p:nvSpPr>
+        <p:spPr/>
+        <p:txBody>
+          <a:bodyPr/>
+          <a:lstStyle/>
+          <a:p>
+            <a:r>
+              <a:rPr lang="ko-KR" altLang="en-US" dirty="0"/>
+              <a:t>프로그래밍</a:t>
+            </a:r>
+          </a:p>
+        </p:txBody>
+      </p:sp>
+      <p:sp>
+        <p:nvSpPr>
+          <p:cNvPr id="4" name="슬라이드 번호 개체 틀 3">
+            <a:extLst>
+              <a:ext uri="{FF2B5EF4-FFF2-40B4-BE49-F238E27FC236}">
+                <a16:creationId xmlns:a16="http://schemas.microsoft.com/office/drawing/2014/main" id="{3E76B4FE-3A46-C9B5-DC45-92D711FC4367}"/>
               </a:ext>
             </a:extLst>
           </p:cNvPr>
@@ -7474,7 +7475,7 @@
     </p:spTree>
     <p:extLst>
       <p:ext uri="{BB962C8B-B14F-4D97-AF65-F5344CB8AC3E}">
-        <p14:creationId xmlns:p14="http://schemas.microsoft.com/office/powerpoint/2010/main" val="205065584"/>
+        <p14:creationId xmlns:p14="http://schemas.microsoft.com/office/powerpoint/2010/main" val="3681834392"/>
       </p:ext>
     </p:extLst>
   </p:cSld>
@@ -7492,7 +7493,7 @@
         <p:cNvPr id="1" name="">
           <a:extLst>
             <a:ext uri="{FF2B5EF4-FFF2-40B4-BE49-F238E27FC236}">
-              <a16:creationId xmlns:a16="http://schemas.microsoft.com/office/drawing/2014/main" id="{FAB8C118-5175-C9B7-F31E-B77D709A7696}"/>
+              <a16:creationId xmlns:a16="http://schemas.microsoft.com/office/drawing/2014/main" id="{598A5B56-CA06-0A3D-554D-F35B40E0E94B}"/>
             </a:ext>
           </a:extLst>
         </p:cNvPr>
@@ -7512,7 +7513,7 @@
           <p:cNvPr id="2" name="슬라이드 이미지 개체 틀 1">
             <a:extLst>
               <a:ext uri="{FF2B5EF4-FFF2-40B4-BE49-F238E27FC236}">
-                <a16:creationId xmlns:a16="http://schemas.microsoft.com/office/drawing/2014/main" id="{1525E783-4F5C-0A3D-68F8-7ED4A454DB3F}"/>
+                <a16:creationId xmlns:a16="http://schemas.microsoft.com/office/drawing/2014/main" id="{2D9BBEFF-88CD-87B1-8871-4B5038DA82F0}"/>
               </a:ext>
             </a:extLst>
           </p:cNvPr>
@@ -7530,7 +7531,7 @@
           <p:cNvPr id="3" name="슬라이드 노트 개체 틀 2">
             <a:extLst>
               <a:ext uri="{FF2B5EF4-FFF2-40B4-BE49-F238E27FC236}">
-                <a16:creationId xmlns:a16="http://schemas.microsoft.com/office/drawing/2014/main" id="{0B33BE79-C269-F093-741B-FD577C03BE3D}"/>
+                <a16:creationId xmlns:a16="http://schemas.microsoft.com/office/drawing/2014/main" id="{1B47D9AB-9FE0-7717-81ED-A4E1BB05875F}"/>
               </a:ext>
             </a:extLst>
           </p:cNvPr>
@@ -7579,7 +7580,7 @@
           <p:cNvPr id="4" name="슬라이드 번호 개체 틀 3">
             <a:extLst>
               <a:ext uri="{FF2B5EF4-FFF2-40B4-BE49-F238E27FC236}">
-                <a16:creationId xmlns:a16="http://schemas.microsoft.com/office/drawing/2014/main" id="{A362E7A9-11F0-D0F1-63FB-AF12026D7282}"/>
+                <a16:creationId xmlns:a16="http://schemas.microsoft.com/office/drawing/2014/main" id="{A6DA8553-90C0-CAC0-DD76-537C86BCBF6B}"/>
               </a:ext>
             </a:extLst>
           </p:cNvPr>
@@ -7606,7 +7607,7 @@
     </p:spTree>
     <p:extLst>
       <p:ext uri="{BB962C8B-B14F-4D97-AF65-F5344CB8AC3E}">
-        <p14:creationId xmlns:p14="http://schemas.microsoft.com/office/powerpoint/2010/main" val="335191101"/>
+        <p14:creationId xmlns:p14="http://schemas.microsoft.com/office/powerpoint/2010/main" val="205065584"/>
       </p:ext>
     </p:extLst>
   </p:cSld>
@@ -7624,7 +7625,7 @@
         <p:cNvPr id="1" name="">
           <a:extLst>
             <a:ext uri="{FF2B5EF4-FFF2-40B4-BE49-F238E27FC236}">
-              <a16:creationId xmlns:a16="http://schemas.microsoft.com/office/drawing/2014/main" id="{2C01CB16-0C70-2EAC-9D2B-97DC73993310}"/>
+              <a16:creationId xmlns:a16="http://schemas.microsoft.com/office/drawing/2014/main" id="{FAB8C118-5175-C9B7-F31E-B77D709A7696}"/>
             </a:ext>
           </a:extLst>
         </p:cNvPr>
@@ -7644,7 +7645,7 @@
           <p:cNvPr id="2" name="슬라이드 이미지 개체 틀 1">
             <a:extLst>
               <a:ext uri="{FF2B5EF4-FFF2-40B4-BE49-F238E27FC236}">
-                <a16:creationId xmlns:a16="http://schemas.microsoft.com/office/drawing/2014/main" id="{0DEB9AE9-5C53-6EA7-D13C-4B852AF7318C}"/>
+                <a16:creationId xmlns:a16="http://schemas.microsoft.com/office/drawing/2014/main" id="{1525E783-4F5C-0A3D-68F8-7ED4A454DB3F}"/>
               </a:ext>
             </a:extLst>
           </p:cNvPr>
@@ -7662,7 +7663,7 @@
           <p:cNvPr id="3" name="슬라이드 노트 개체 틀 2">
             <a:extLst>
               <a:ext uri="{FF2B5EF4-FFF2-40B4-BE49-F238E27FC236}">
-                <a16:creationId xmlns:a16="http://schemas.microsoft.com/office/drawing/2014/main" id="{58D81E76-804E-1D36-9A0F-D2E7A2C2E328}"/>
+                <a16:creationId xmlns:a16="http://schemas.microsoft.com/office/drawing/2014/main" id="{0B33BE79-C269-F093-741B-FD577C03BE3D}"/>
               </a:ext>
             </a:extLst>
           </p:cNvPr>
@@ -7711,7 +7712,7 @@
           <p:cNvPr id="4" name="슬라이드 번호 개체 틀 3">
             <a:extLst>
               <a:ext uri="{FF2B5EF4-FFF2-40B4-BE49-F238E27FC236}">
-                <a16:creationId xmlns:a16="http://schemas.microsoft.com/office/drawing/2014/main" id="{288941DE-6BCD-BE51-AAD0-50A84AAB842C}"/>
+                <a16:creationId xmlns:a16="http://schemas.microsoft.com/office/drawing/2014/main" id="{A362E7A9-11F0-D0F1-63FB-AF12026D7282}"/>
               </a:ext>
             </a:extLst>
           </p:cNvPr>
@@ -7738,7 +7739,7 @@
     </p:spTree>
     <p:extLst>
       <p:ext uri="{BB962C8B-B14F-4D97-AF65-F5344CB8AC3E}">
-        <p14:creationId xmlns:p14="http://schemas.microsoft.com/office/powerpoint/2010/main" val="1634442979"/>
+        <p14:creationId xmlns:p14="http://schemas.microsoft.com/office/powerpoint/2010/main" val="335191101"/>
       </p:ext>
     </p:extLst>
   </p:cSld>
@@ -7756,7 +7757,7 @@
         <p:cNvPr id="1" name="">
           <a:extLst>
             <a:ext uri="{FF2B5EF4-FFF2-40B4-BE49-F238E27FC236}">
-              <a16:creationId xmlns:a16="http://schemas.microsoft.com/office/drawing/2014/main" id="{D99B15A4-95A3-8BC2-019F-2FD5CEEB5FFA}"/>
+              <a16:creationId xmlns:a16="http://schemas.microsoft.com/office/drawing/2014/main" id="{2C01CB16-0C70-2EAC-9D2B-97DC73993310}"/>
             </a:ext>
           </a:extLst>
         </p:cNvPr>
@@ -7776,7 +7777,7 @@
           <p:cNvPr id="2" name="슬라이드 이미지 개체 틀 1">
             <a:extLst>
               <a:ext uri="{FF2B5EF4-FFF2-40B4-BE49-F238E27FC236}">
-                <a16:creationId xmlns:a16="http://schemas.microsoft.com/office/drawing/2014/main" id="{367C7C21-3E27-1381-0833-0C2EADFEF485}"/>
+                <a16:creationId xmlns:a16="http://schemas.microsoft.com/office/drawing/2014/main" id="{0DEB9AE9-5C53-6EA7-D13C-4B852AF7318C}"/>
               </a:ext>
             </a:extLst>
           </p:cNvPr>
@@ -7794,7 +7795,7 @@
           <p:cNvPr id="3" name="슬라이드 노트 개체 틀 2">
             <a:extLst>
               <a:ext uri="{FF2B5EF4-FFF2-40B4-BE49-F238E27FC236}">
-                <a16:creationId xmlns:a16="http://schemas.microsoft.com/office/drawing/2014/main" id="{88301070-6CB9-2EE5-65F2-DAFDE7BCE1E0}"/>
+                <a16:creationId xmlns:a16="http://schemas.microsoft.com/office/drawing/2014/main" id="{58D81E76-804E-1D36-9A0F-D2E7A2C2E328}"/>
               </a:ext>
             </a:extLst>
           </p:cNvPr>
@@ -7810,10 +7811,31 @@
           <a:bodyPr/>
           <a:lstStyle/>
           <a:p>
-            <a:r>
-              <a:rPr lang="ko-KR" altLang="en-US" dirty="0"/>
-              <a:t>프로그래밍</a:t>
-            </a:r>
+            <a:pPr marL="0" marR="0" lvl="0" indent="0" algn="l" defTabSz="914400" rtl="0" eaLnBrk="1" fontAlgn="auto" latinLnBrk="1" hangingPunct="1">
+              <a:lnSpc>
+                <a:spcPct val="100000"/>
+              </a:lnSpc>
+              <a:spcBef>
+                <a:spcPts val="0"/>
+              </a:spcBef>
+              <a:spcAft>
+                <a:spcPts val="0"/>
+              </a:spcAft>
+              <a:buClrTx/>
+              <a:buSzTx/>
+              <a:buFontTx/>
+              <a:buNone/>
+              <a:tabLst/>
+              <a:defRPr/>
+            </a:pPr>
+            <a:endParaRPr lang="ko-KR" altLang="en-US" b="0" i="0" dirty="0">
+              <a:solidFill>
+                <a:srgbClr val="292A2D"/>
+              </a:solidFill>
+              <a:effectLst/>
+              <a:latin typeface="Noto Sans KR" panose="020B0200000000000000" pitchFamily="50" charset="-127"/>
+              <a:ea typeface="Noto Sans KR" panose="020B0200000000000000" pitchFamily="50" charset="-127"/>
+            </a:endParaRPr>
           </a:p>
         </p:txBody>
       </p:sp>
@@ -7822,7 +7844,7 @@
           <p:cNvPr id="4" name="슬라이드 번호 개체 틀 3">
             <a:extLst>
               <a:ext uri="{FF2B5EF4-FFF2-40B4-BE49-F238E27FC236}">
-                <a16:creationId xmlns:a16="http://schemas.microsoft.com/office/drawing/2014/main" id="{16C32642-9B64-5AF9-94E5-49F90D3EA85B}"/>
+                <a16:creationId xmlns:a16="http://schemas.microsoft.com/office/drawing/2014/main" id="{288941DE-6BCD-BE51-AAD0-50A84AAB842C}"/>
               </a:ext>
             </a:extLst>
           </p:cNvPr>
@@ -7849,7 +7871,7 @@
     </p:spTree>
     <p:extLst>
       <p:ext uri="{BB962C8B-B14F-4D97-AF65-F5344CB8AC3E}">
-        <p14:creationId xmlns:p14="http://schemas.microsoft.com/office/powerpoint/2010/main" val="3141045409"/>
+        <p14:creationId xmlns:p14="http://schemas.microsoft.com/office/powerpoint/2010/main" val="1634442979"/>
       </p:ext>
     </p:extLst>
   </p:cSld>
@@ -7999,6 +8021,117 @@
         <p:cNvPr id="1" name="">
           <a:extLst>
             <a:ext uri="{FF2B5EF4-FFF2-40B4-BE49-F238E27FC236}">
+              <a16:creationId xmlns:a16="http://schemas.microsoft.com/office/drawing/2014/main" id="{D99B15A4-95A3-8BC2-019F-2FD5CEEB5FFA}"/>
+            </a:ext>
+          </a:extLst>
+        </p:cNvPr>
+        <p:cNvGrpSpPr/>
+        <p:nvPr/>
+      </p:nvGrpSpPr>
+      <p:grpSpPr>
+        <a:xfrm>
+          <a:off x="0" y="0"/>
+          <a:ext cx="0" cy="0"/>
+          <a:chOff x="0" y="0"/>
+          <a:chExt cx="0" cy="0"/>
+        </a:xfrm>
+      </p:grpSpPr>
+      <p:sp>
+        <p:nvSpPr>
+          <p:cNvPr id="2" name="슬라이드 이미지 개체 틀 1">
+            <a:extLst>
+              <a:ext uri="{FF2B5EF4-FFF2-40B4-BE49-F238E27FC236}">
+                <a16:creationId xmlns:a16="http://schemas.microsoft.com/office/drawing/2014/main" id="{367C7C21-3E27-1381-0833-0C2EADFEF485}"/>
+              </a:ext>
+            </a:extLst>
+          </p:cNvPr>
+          <p:cNvSpPr>
+            <a:spLocks noGrp="1" noRot="1" noChangeAspect="1"/>
+          </p:cNvSpPr>
+          <p:nvPr>
+            <p:ph type="sldImg"/>
+          </p:nvPr>
+        </p:nvSpPr>
+        <p:spPr/>
+      </p:sp>
+      <p:sp>
+        <p:nvSpPr>
+          <p:cNvPr id="3" name="슬라이드 노트 개체 틀 2">
+            <a:extLst>
+              <a:ext uri="{FF2B5EF4-FFF2-40B4-BE49-F238E27FC236}">
+                <a16:creationId xmlns:a16="http://schemas.microsoft.com/office/drawing/2014/main" id="{88301070-6CB9-2EE5-65F2-DAFDE7BCE1E0}"/>
+              </a:ext>
+            </a:extLst>
+          </p:cNvPr>
+          <p:cNvSpPr>
+            <a:spLocks noGrp="1"/>
+          </p:cNvSpPr>
+          <p:nvPr>
+            <p:ph type="body" idx="1"/>
+          </p:nvPr>
+        </p:nvSpPr>
+        <p:spPr/>
+        <p:txBody>
+          <a:bodyPr/>
+          <a:lstStyle/>
+          <a:p>
+            <a:r>
+              <a:rPr lang="ko-KR" altLang="en-US" dirty="0"/>
+              <a:t>프로그래밍</a:t>
+            </a:r>
+          </a:p>
+        </p:txBody>
+      </p:sp>
+      <p:sp>
+        <p:nvSpPr>
+          <p:cNvPr id="4" name="슬라이드 번호 개체 틀 3">
+            <a:extLst>
+              <a:ext uri="{FF2B5EF4-FFF2-40B4-BE49-F238E27FC236}">
+                <a16:creationId xmlns:a16="http://schemas.microsoft.com/office/drawing/2014/main" id="{16C32642-9B64-5AF9-94E5-49F90D3EA85B}"/>
+              </a:ext>
+            </a:extLst>
+          </p:cNvPr>
+          <p:cNvSpPr>
+            <a:spLocks noGrp="1"/>
+          </p:cNvSpPr>
+          <p:nvPr>
+            <p:ph type="sldNum" sz="quarter" idx="5"/>
+          </p:nvPr>
+        </p:nvSpPr>
+        <p:spPr/>
+        <p:txBody>
+          <a:bodyPr/>
+          <a:lstStyle/>
+          <a:p>
+            <a:fld id="{3599D024-DE68-44ED-822F-D827F84FBD4A}" type="slidenum">
+              <a:rPr lang="ko-KR" altLang="en-US" smtClean="0"/>
+              <a:t>50</a:t>
+            </a:fld>
+            <a:endParaRPr lang="ko-KR" altLang="en-US"/>
+          </a:p>
+        </p:txBody>
+      </p:sp>
+    </p:spTree>
+    <p:extLst>
+      <p:ext uri="{BB962C8B-B14F-4D97-AF65-F5344CB8AC3E}">
+        <p14:creationId xmlns:p14="http://schemas.microsoft.com/office/powerpoint/2010/main" val="3141045409"/>
+      </p:ext>
+    </p:extLst>
+  </p:cSld>
+  <p:clrMapOvr>
+    <a:masterClrMapping/>
+  </p:clrMapOvr>
+</p:notes>
+</file>
+
+<file path=ppt/notesSlides/notesSlide51.xml><?xml version="1.0" encoding="utf-8"?>
+<p:notes xmlns:a="http://schemas.openxmlformats.org/drawingml/2006/main" xmlns:r="http://schemas.openxmlformats.org/officeDocument/2006/relationships" xmlns:p="http://schemas.openxmlformats.org/presentationml/2006/main">
+  <p:cSld>
+    <p:spTree>
+      <p:nvGrpSpPr>
+        <p:cNvPr id="1" name="">
+          <a:extLst>
+            <a:ext uri="{FF2B5EF4-FFF2-40B4-BE49-F238E27FC236}">
               <a16:creationId xmlns:a16="http://schemas.microsoft.com/office/drawing/2014/main" id="{E06B7847-2964-17BD-3EF6-6239BCBBD9CC}"/>
             </a:ext>
           </a:extLst>
@@ -8083,7 +8216,7 @@
           <a:p>
             <a:fld id="{3599D024-DE68-44ED-822F-D827F84FBD4A}" type="slidenum">
               <a:rPr lang="ko-KR" altLang="en-US" smtClean="0"/>
-              <a:t>50</a:t>
+              <a:t>51</a:t>
             </a:fld>
             <a:endParaRPr lang="ko-KR" altLang="en-US"/>
           </a:p>
@@ -8102,7 +8235,7 @@
 </p:notes>
 </file>
 
-<file path=ppt/notesSlides/notesSlide51.xml><?xml version="1.0" encoding="utf-8"?>
+<file path=ppt/notesSlides/notesSlide52.xml><?xml version="1.0" encoding="utf-8"?>
 <p:notes xmlns:a="http://schemas.openxmlformats.org/drawingml/2006/main" xmlns:r="http://schemas.openxmlformats.org/officeDocument/2006/relationships" xmlns:p="http://schemas.openxmlformats.org/presentationml/2006/main">
   <p:cSld>
     <p:spTree>
@@ -8194,7 +8327,7 @@
           <a:p>
             <a:fld id="{3599D024-DE68-44ED-822F-D827F84FBD4A}" type="slidenum">
               <a:rPr lang="ko-KR" altLang="en-US" smtClean="0"/>
-              <a:t>51</a:t>
+              <a:t>52</a:t>
             </a:fld>
             <a:endParaRPr lang="ko-KR" altLang="en-US"/>
           </a:p>
@@ -8213,7 +8346,7 @@
 </p:notes>
 </file>
 
-<file path=ppt/notesSlides/notesSlide52.xml><?xml version="1.0" encoding="utf-8"?>
+<file path=ppt/notesSlides/notesSlide53.xml><?xml version="1.0" encoding="utf-8"?>
 <p:notes xmlns:a="http://schemas.openxmlformats.org/drawingml/2006/main" xmlns:r="http://schemas.openxmlformats.org/officeDocument/2006/relationships" xmlns:p="http://schemas.openxmlformats.org/presentationml/2006/main">
   <p:cSld>
     <p:spTree>
@@ -8305,7 +8438,7 @@
           <a:p>
             <a:fld id="{3599D024-DE68-44ED-822F-D827F84FBD4A}" type="slidenum">
               <a:rPr lang="ko-KR" altLang="en-US" smtClean="0"/>
-              <a:t>52</a:t>
+              <a:t>53</a:t>
             </a:fld>
             <a:endParaRPr lang="ko-KR" altLang="en-US"/>
           </a:p>
@@ -8324,7 +8457,7 @@
 </p:notes>
 </file>
 
-<file path=ppt/notesSlides/notesSlide53.xml><?xml version="1.0" encoding="utf-8"?>
+<file path=ppt/notesSlides/notesSlide54.xml><?xml version="1.0" encoding="utf-8"?>
 <p:notes xmlns:a="http://schemas.openxmlformats.org/drawingml/2006/main" xmlns:r="http://schemas.openxmlformats.org/officeDocument/2006/relationships" xmlns:p="http://schemas.openxmlformats.org/presentationml/2006/main">
   <p:cSld>
     <p:spTree>
@@ -8416,7 +8549,7 @@
           <a:p>
             <a:fld id="{3599D024-DE68-44ED-822F-D827F84FBD4A}" type="slidenum">
               <a:rPr lang="ko-KR" altLang="en-US" smtClean="0"/>
-              <a:t>53</a:t>
+              <a:t>54</a:t>
             </a:fld>
             <a:endParaRPr lang="ko-KR" altLang="en-US"/>
           </a:p>
@@ -8435,7 +8568,7 @@
 </p:notes>
 </file>
 
-<file path=ppt/notesSlides/notesSlide54.xml><?xml version="1.0" encoding="utf-8"?>
+<file path=ppt/notesSlides/notesSlide55.xml><?xml version="1.0" encoding="utf-8"?>
 <p:notes xmlns:a="http://schemas.openxmlformats.org/drawingml/2006/main" xmlns:r="http://schemas.openxmlformats.org/officeDocument/2006/relationships" xmlns:p="http://schemas.openxmlformats.org/presentationml/2006/main">
   <p:cSld>
     <p:spTree>
@@ -8548,7 +8681,7 @@
           <a:p>
             <a:fld id="{3599D024-DE68-44ED-822F-D827F84FBD4A}" type="slidenum">
               <a:rPr lang="ko-KR" altLang="en-US" smtClean="0"/>
-              <a:t>54</a:t>
+              <a:t>55</a:t>
             </a:fld>
             <a:endParaRPr lang="ko-KR" altLang="en-US"/>
           </a:p>
@@ -8567,7 +8700,7 @@
 </p:notes>
 </file>
 
-<file path=ppt/notesSlides/notesSlide55.xml><?xml version="1.0" encoding="utf-8"?>
+<file path=ppt/notesSlides/notesSlide56.xml><?xml version="1.0" encoding="utf-8"?>
 <p:notes xmlns:a="http://schemas.openxmlformats.org/drawingml/2006/main" xmlns:r="http://schemas.openxmlformats.org/officeDocument/2006/relationships" xmlns:p="http://schemas.openxmlformats.org/presentationml/2006/main">
   <p:cSld>
     <p:spTree>
@@ -8680,7 +8813,7 @@
           <a:p>
             <a:fld id="{3599D024-DE68-44ED-822F-D827F84FBD4A}" type="slidenum">
               <a:rPr lang="ko-KR" altLang="en-US" smtClean="0"/>
-              <a:t>55</a:t>
+              <a:t>56</a:t>
             </a:fld>
             <a:endParaRPr lang="ko-KR" altLang="en-US"/>
           </a:p>
@@ -21133,6 +21266,218 @@
 </file>
 
 <file path=ppt/slides/slide30.xml><?xml version="1.0" encoding="utf-8"?>
+<p:sld xmlns:a="http://schemas.openxmlformats.org/drawingml/2006/main" xmlns:r="http://schemas.openxmlformats.org/officeDocument/2006/relationships" xmlns:p="http://schemas.openxmlformats.org/presentationml/2006/main">
+  <p:cSld>
+    <p:spTree>
+      <p:nvGrpSpPr>
+        <p:cNvPr id="1" name="">
+          <a:extLst>
+            <a:ext uri="{FF2B5EF4-FFF2-40B4-BE49-F238E27FC236}">
+              <a16:creationId xmlns:a16="http://schemas.microsoft.com/office/drawing/2014/main" id="{395AA406-27C3-A872-E7EC-947B2E3340F6}"/>
+            </a:ext>
+          </a:extLst>
+        </p:cNvPr>
+        <p:cNvGrpSpPr/>
+        <p:nvPr/>
+      </p:nvGrpSpPr>
+      <p:grpSpPr>
+        <a:xfrm>
+          <a:off x="0" y="0"/>
+          <a:ext cx="0" cy="0"/>
+          <a:chOff x="0" y="0"/>
+          <a:chExt cx="0" cy="0"/>
+        </a:xfrm>
+      </p:grpSpPr>
+      <p:sp>
+        <p:nvSpPr>
+          <p:cNvPr id="2" name="제목 1">
+            <a:extLst>
+              <a:ext uri="{FF2B5EF4-FFF2-40B4-BE49-F238E27FC236}">
+                <a16:creationId xmlns:a16="http://schemas.microsoft.com/office/drawing/2014/main" id="{71DEA1A3-4A76-AB8B-0FAD-5D34D7706D7A}"/>
+              </a:ext>
+            </a:extLst>
+          </p:cNvPr>
+          <p:cNvSpPr>
+            <a:spLocks noGrp="1"/>
+          </p:cNvSpPr>
+          <p:nvPr>
+            <p:ph type="title"/>
+          </p:nvPr>
+        </p:nvSpPr>
+        <p:spPr/>
+        <p:txBody>
+          <a:bodyPr>
+            <a:normAutofit/>
+          </a:bodyPr>
+          <a:lstStyle/>
+          <a:p>
+            <a:r>
+              <a:rPr lang="ko-KR" altLang="en-US" dirty="0" err="1"/>
+              <a:t>택트</a:t>
+            </a:r>
+            <a:r>
+              <a:rPr lang="ko-KR" altLang="en-US" dirty="0"/>
+              <a:t> 스위치 실습 </a:t>
+            </a:r>
+            <a:r>
+              <a:rPr lang="en-US" altLang="ko-KR" dirty="0"/>
+              <a:t>Quiz (2)</a:t>
+            </a:r>
+            <a:endParaRPr lang="ko-KR" altLang="en-US" dirty="0"/>
+          </a:p>
+        </p:txBody>
+      </p:sp>
+      <p:sp>
+        <p:nvSpPr>
+          <p:cNvPr id="4" name="슬라이드 번호 개체 틀 3">
+            <a:extLst>
+              <a:ext uri="{FF2B5EF4-FFF2-40B4-BE49-F238E27FC236}">
+                <a16:creationId xmlns:a16="http://schemas.microsoft.com/office/drawing/2014/main" id="{08531538-2374-6CB9-5DD8-3370393E03B4}"/>
+              </a:ext>
+            </a:extLst>
+          </p:cNvPr>
+          <p:cNvSpPr>
+            <a:spLocks noGrp="1"/>
+          </p:cNvSpPr>
+          <p:nvPr>
+            <p:ph type="sldNum" sz="quarter" idx="12"/>
+          </p:nvPr>
+        </p:nvSpPr>
+        <p:spPr/>
+        <p:txBody>
+          <a:bodyPr/>
+          <a:lstStyle/>
+          <a:p>
+            <a:fld id="{083A2CE0-18CD-4102-B738-4ACFF9E68BA4}" type="slidenum">
+              <a:rPr lang="ko-KR" altLang="en-US" smtClean="0"/>
+              <a:pPr/>
+              <a:t>30</a:t>
+            </a:fld>
+            <a:endParaRPr lang="ko-KR" altLang="en-US" dirty="0"/>
+          </a:p>
+        </p:txBody>
+      </p:sp>
+      <p:sp>
+        <p:nvSpPr>
+          <p:cNvPr id="7" name="내용 개체 틀 5">
+            <a:extLst>
+              <a:ext uri="{FF2B5EF4-FFF2-40B4-BE49-F238E27FC236}">
+                <a16:creationId xmlns:a16="http://schemas.microsoft.com/office/drawing/2014/main" id="{DCF8161B-E502-69B6-8AF6-D2AF8FCE9528}"/>
+              </a:ext>
+            </a:extLst>
+          </p:cNvPr>
+          <p:cNvSpPr>
+            <a:spLocks noGrp="1"/>
+          </p:cNvSpPr>
+          <p:nvPr>
+            <p:ph idx="1"/>
+          </p:nvPr>
+        </p:nvSpPr>
+        <p:spPr>
+          <a:xfrm>
+            <a:off x="838200" y="1549839"/>
+            <a:ext cx="10515600" cy="4627124"/>
+          </a:xfrm>
+        </p:spPr>
+        <p:txBody>
+          <a:bodyPr>
+            <a:normAutofit/>
+          </a:bodyPr>
+          <a:lstStyle/>
+          <a:p>
+            <a:pPr marL="0" indent="0">
+              <a:buNone/>
+            </a:pPr>
+            <a:r>
+              <a:rPr lang="ko-KR" altLang="en-US" sz="4000" b="1" dirty="0">
+                <a:solidFill>
+                  <a:srgbClr val="FF0000"/>
+                </a:solidFill>
+              </a:rPr>
+              <a:t>정답</a:t>
+            </a:r>
+            <a:endParaRPr lang="en-US" altLang="ko-KR" sz="4000" b="1" dirty="0">
+              <a:solidFill>
+                <a:srgbClr val="FF0000"/>
+              </a:solidFill>
+            </a:endParaRPr>
+          </a:p>
+        </p:txBody>
+      </p:sp>
+      <p:pic>
+        <p:nvPicPr>
+          <p:cNvPr id="5" name="그림 4">
+            <a:extLst>
+              <a:ext uri="{FF2B5EF4-FFF2-40B4-BE49-F238E27FC236}">
+                <a16:creationId xmlns:a16="http://schemas.microsoft.com/office/drawing/2014/main" id="{90C9965A-4BDF-07FB-9FC6-B081231EE7FD}"/>
+              </a:ext>
+            </a:extLst>
+          </p:cNvPr>
+          <p:cNvPicPr>
+            <a:picLocks noChangeAspect="1"/>
+          </p:cNvPicPr>
+          <p:nvPr/>
+        </p:nvPicPr>
+        <p:blipFill>
+          <a:blip r:embed="rId3"/>
+          <a:stretch>
+            <a:fillRect/>
+          </a:stretch>
+        </p:blipFill>
+        <p:spPr>
+          <a:xfrm>
+            <a:off x="782453" y="2557463"/>
+            <a:ext cx="4972050" cy="3619500"/>
+          </a:xfrm>
+          <a:prstGeom prst="rect">
+            <a:avLst/>
+          </a:prstGeom>
+        </p:spPr>
+      </p:pic>
+      <p:pic>
+        <p:nvPicPr>
+          <p:cNvPr id="8" name="그림 7">
+            <a:extLst>
+              <a:ext uri="{FF2B5EF4-FFF2-40B4-BE49-F238E27FC236}">
+                <a16:creationId xmlns:a16="http://schemas.microsoft.com/office/drawing/2014/main" id="{DF2BF71C-CD3D-C8F6-5767-00C4F3B4810C}"/>
+              </a:ext>
+            </a:extLst>
+          </p:cNvPr>
+          <p:cNvPicPr>
+            <a:picLocks noChangeAspect="1"/>
+          </p:cNvPicPr>
+          <p:nvPr/>
+        </p:nvPicPr>
+        <p:blipFill>
+          <a:blip r:embed="rId4"/>
+          <a:stretch>
+            <a:fillRect/>
+          </a:stretch>
+        </p:blipFill>
+        <p:spPr>
+          <a:xfrm>
+            <a:off x="6096000" y="1477199"/>
+            <a:ext cx="4583803" cy="4772403"/>
+          </a:xfrm>
+          <a:prstGeom prst="rect">
+            <a:avLst/>
+          </a:prstGeom>
+        </p:spPr>
+      </p:pic>
+    </p:spTree>
+    <p:extLst>
+      <p:ext uri="{BB962C8B-B14F-4D97-AF65-F5344CB8AC3E}">
+        <p14:creationId xmlns:p14="http://schemas.microsoft.com/office/powerpoint/2010/main" val="3125738384"/>
+      </p:ext>
+    </p:extLst>
+  </p:cSld>
+  <p:clrMapOvr>
+    <a:masterClrMapping/>
+  </p:clrMapOvr>
+</p:sld>
+</file>
+
+<file path=ppt/slides/slide31.xml><?xml version="1.0" encoding="utf-8"?>
 <p:sld xmlns:a="http://schemas.openxmlformats.org/drawingml/2006/main" xmlns:r="http://schemas.openxmlformats.org/officeDocument/2006/relationships" xmlns:p="http://schemas.openxmlformats.org/presentationml/2006/main" show="0">
   <p:cSld>
     <p:spTree>
@@ -21218,7 +21563,7 @@
             <a:fld id="{083A2CE0-18CD-4102-B738-4ACFF9E68BA4}" type="slidenum">
               <a:rPr lang="ko-KR" altLang="en-US" smtClean="0"/>
               <a:pPr/>
-              <a:t>30</a:t>
+              <a:t>31</a:t>
             </a:fld>
             <a:endParaRPr lang="ko-KR" altLang="en-US" dirty="0"/>
           </a:p>
@@ -21297,7 +21642,7 @@
 </p:sld>
 </file>
 
-<file path=ppt/slides/slide31.xml><?xml version="1.0" encoding="utf-8"?>
+<file path=ppt/slides/slide32.xml><?xml version="1.0" encoding="utf-8"?>
 <p:sld xmlns:a="http://schemas.openxmlformats.org/drawingml/2006/main" xmlns:r="http://schemas.openxmlformats.org/officeDocument/2006/relationships" xmlns:p="http://schemas.openxmlformats.org/presentationml/2006/main">
   <p:cSld>
     <p:spTree>
@@ -21383,7 +21728,7 @@
             <a:fld id="{083A2CE0-18CD-4102-B738-4ACFF9E68BA4}" type="slidenum">
               <a:rPr lang="ko-KR" altLang="en-US" smtClean="0"/>
               <a:pPr/>
-              <a:t>31</a:t>
+              <a:t>32</a:t>
             </a:fld>
             <a:endParaRPr lang="ko-KR" altLang="en-US" dirty="0"/>
           </a:p>
@@ -21556,7 +21901,7 @@
 </p:sld>
 </file>
 
-<file path=ppt/slides/slide32.xml><?xml version="1.0" encoding="utf-8"?>
+<file path=ppt/slides/slide33.xml><?xml version="1.0" encoding="utf-8"?>
 <p:sld xmlns:a="http://schemas.openxmlformats.org/drawingml/2006/main" xmlns:r="http://schemas.openxmlformats.org/officeDocument/2006/relationships" xmlns:p="http://schemas.openxmlformats.org/presentationml/2006/main">
   <p:cSld>
     <p:spTree>
@@ -21645,7 +21990,7 @@
             <a:fld id="{083A2CE0-18CD-4102-B738-4ACFF9E68BA4}" type="slidenum">
               <a:rPr lang="ko-KR" altLang="en-US" smtClean="0"/>
               <a:pPr/>
-              <a:t>32</a:t>
+              <a:t>33</a:t>
             </a:fld>
             <a:endParaRPr lang="ko-KR" altLang="en-US" dirty="0"/>
           </a:p>
@@ -22398,7 +22743,7 @@
 </p:sld>
 </file>
 
-<file path=ppt/slides/slide33.xml><?xml version="1.0" encoding="utf-8"?>
+<file path=ppt/slides/slide34.xml><?xml version="1.0" encoding="utf-8"?>
 <p:sld xmlns:a="http://schemas.openxmlformats.org/drawingml/2006/main" xmlns:r="http://schemas.openxmlformats.org/officeDocument/2006/relationships" xmlns:p="http://schemas.openxmlformats.org/presentationml/2006/main">
   <p:cSld>
     <p:spTree>
@@ -22557,7 +22902,7 @@
 </p:sld>
 </file>
 
-<file path=ppt/slides/slide34.xml><?xml version="1.0" encoding="utf-8"?>
+<file path=ppt/slides/slide35.xml><?xml version="1.0" encoding="utf-8"?>
 <p:sld xmlns:a="http://schemas.openxmlformats.org/drawingml/2006/main" xmlns:r="http://schemas.openxmlformats.org/officeDocument/2006/relationships" xmlns:p="http://schemas.openxmlformats.org/presentationml/2006/main">
   <p:cSld>
     <p:spTree>
@@ -22733,7 +23078,7 @@
 </p:sld>
 </file>
 
-<file path=ppt/slides/slide35.xml><?xml version="1.0" encoding="utf-8"?>
+<file path=ppt/slides/slide36.xml><?xml version="1.0" encoding="utf-8"?>
 <p:sld xmlns:a="http://schemas.openxmlformats.org/drawingml/2006/main" xmlns:r="http://schemas.openxmlformats.org/officeDocument/2006/relationships" xmlns:p="http://schemas.openxmlformats.org/presentationml/2006/main">
   <p:cSld>
     <p:spTree>
@@ -22892,7 +23237,7 @@
 </p:sld>
 </file>
 
-<file path=ppt/slides/slide36.xml><?xml version="1.0" encoding="utf-8"?>
+<file path=ppt/slides/slide37.xml><?xml version="1.0" encoding="utf-8"?>
 <p:sld xmlns:a="http://schemas.openxmlformats.org/drawingml/2006/main" xmlns:r="http://schemas.openxmlformats.org/officeDocument/2006/relationships" xmlns:p="http://schemas.openxmlformats.org/presentationml/2006/main">
   <p:cSld>
     <p:spTree>
@@ -23051,7 +23396,7 @@
 </p:sld>
 </file>
 
-<file path=ppt/slides/slide37.xml><?xml version="1.0" encoding="utf-8"?>
+<file path=ppt/slides/slide38.xml><?xml version="1.0" encoding="utf-8"?>
 <p:sld xmlns:a="http://schemas.openxmlformats.org/drawingml/2006/main" xmlns:r="http://schemas.openxmlformats.org/officeDocument/2006/relationships" xmlns:p="http://schemas.openxmlformats.org/presentationml/2006/main">
   <p:cSld>
     <p:spTree>
@@ -23210,7 +23555,7 @@
 </p:sld>
 </file>
 
-<file path=ppt/slides/slide38.xml><?xml version="1.0" encoding="utf-8"?>
+<file path=ppt/slides/slide39.xml><?xml version="1.0" encoding="utf-8"?>
 <p:sld xmlns:a="http://schemas.openxmlformats.org/drawingml/2006/main" xmlns:r="http://schemas.openxmlformats.org/officeDocument/2006/relationships" xmlns:p="http://schemas.openxmlformats.org/presentationml/2006/main">
   <p:cSld>
     <p:spTree>
@@ -23304,7 +23649,7 @@
             <a:fld id="{083A2CE0-18CD-4102-B738-4ACFF9E68BA4}" type="slidenum">
               <a:rPr lang="ko-KR" altLang="en-US" smtClean="0"/>
               <a:pPr/>
-              <a:t>38</a:t>
+              <a:t>39</a:t>
             </a:fld>
             <a:endParaRPr lang="ko-KR" altLang="en-US" dirty="0"/>
           </a:p>
@@ -23788,196 +24133,6 @@
     <p:extLst>
       <p:ext uri="{BB962C8B-B14F-4D97-AF65-F5344CB8AC3E}">
         <p14:creationId xmlns:p14="http://schemas.microsoft.com/office/powerpoint/2010/main" val="791912612"/>
-      </p:ext>
-    </p:extLst>
-  </p:cSld>
-  <p:clrMapOvr>
-    <a:masterClrMapping/>
-  </p:clrMapOvr>
-</p:sld>
-</file>
-
-<file path=ppt/slides/slide39.xml><?xml version="1.0" encoding="utf-8"?>
-<p:sld xmlns:a="http://schemas.openxmlformats.org/drawingml/2006/main" xmlns:r="http://schemas.openxmlformats.org/officeDocument/2006/relationships" xmlns:p="http://schemas.openxmlformats.org/presentationml/2006/main">
-  <p:cSld>
-    <p:spTree>
-      <p:nvGrpSpPr>
-        <p:cNvPr id="1" name="">
-          <a:extLst>
-            <a:ext uri="{FF2B5EF4-FFF2-40B4-BE49-F238E27FC236}">
-              <a16:creationId xmlns:a16="http://schemas.microsoft.com/office/drawing/2014/main" id="{42A751D3-9F90-EC32-4511-9E18BE6C8D78}"/>
-            </a:ext>
-          </a:extLst>
-        </p:cNvPr>
-        <p:cNvGrpSpPr/>
-        <p:nvPr/>
-      </p:nvGrpSpPr>
-      <p:grpSpPr>
-        <a:xfrm>
-          <a:off x="0" y="0"/>
-          <a:ext cx="0" cy="0"/>
-          <a:chOff x="0" y="0"/>
-          <a:chExt cx="0" cy="0"/>
-        </a:xfrm>
-      </p:grpSpPr>
-      <p:sp>
-        <p:nvSpPr>
-          <p:cNvPr id="2" name="제목 1">
-            <a:extLst>
-              <a:ext uri="{FF2B5EF4-FFF2-40B4-BE49-F238E27FC236}">
-                <a16:creationId xmlns:a16="http://schemas.microsoft.com/office/drawing/2014/main" id="{56FE2324-7080-703D-BA44-9FE20F286CD9}"/>
-              </a:ext>
-            </a:extLst>
-          </p:cNvPr>
-          <p:cNvSpPr>
-            <a:spLocks noGrp="1"/>
-          </p:cNvSpPr>
-          <p:nvPr>
-            <p:ph type="title"/>
-          </p:nvPr>
-        </p:nvSpPr>
-        <p:spPr/>
-        <p:txBody>
-          <a:bodyPr>
-            <a:normAutofit/>
-          </a:bodyPr>
-          <a:lstStyle/>
-          <a:p>
-            <a:r>
-              <a:rPr lang="ko-KR" altLang="en-US" dirty="0" err="1"/>
-              <a:t>피에조</a:t>
-            </a:r>
-            <a:r>
-              <a:rPr lang="ko-KR" altLang="en-US" dirty="0"/>
-              <a:t> </a:t>
-            </a:r>
-            <a:r>
-              <a:rPr lang="ko-KR" altLang="en-US" dirty="0" err="1"/>
-              <a:t>부저</a:t>
-            </a:r>
-            <a:r>
-              <a:rPr lang="ko-KR" altLang="en-US" dirty="0"/>
-              <a:t> </a:t>
-            </a:r>
-            <a:r>
-              <a:rPr lang="en-US" altLang="ko-KR" dirty="0"/>
-              <a:t>Quiz</a:t>
-            </a:r>
-            <a:endParaRPr lang="ko-KR" altLang="en-US" dirty="0"/>
-          </a:p>
-        </p:txBody>
-      </p:sp>
-      <p:sp>
-        <p:nvSpPr>
-          <p:cNvPr id="4" name="슬라이드 번호 개체 틀 3">
-            <a:extLst>
-              <a:ext uri="{FF2B5EF4-FFF2-40B4-BE49-F238E27FC236}">
-                <a16:creationId xmlns:a16="http://schemas.microsoft.com/office/drawing/2014/main" id="{50B40CA8-9311-FE7B-4020-1B1343735490}"/>
-              </a:ext>
-            </a:extLst>
-          </p:cNvPr>
-          <p:cNvSpPr>
-            <a:spLocks noGrp="1"/>
-          </p:cNvSpPr>
-          <p:nvPr>
-            <p:ph type="sldNum" sz="quarter" idx="12"/>
-          </p:nvPr>
-        </p:nvSpPr>
-        <p:spPr/>
-        <p:txBody>
-          <a:bodyPr/>
-          <a:lstStyle/>
-          <a:p>
-            <a:fld id="{083A2CE0-18CD-4102-B738-4ACFF9E68BA4}" type="slidenum">
-              <a:rPr lang="ko-KR" altLang="en-US" smtClean="0"/>
-              <a:pPr/>
-              <a:t>39</a:t>
-            </a:fld>
-            <a:endParaRPr lang="ko-KR" altLang="en-US" dirty="0"/>
-          </a:p>
-        </p:txBody>
-      </p:sp>
-      <p:sp>
-        <p:nvSpPr>
-          <p:cNvPr id="7" name="내용 개체 틀 5">
-            <a:extLst>
-              <a:ext uri="{FF2B5EF4-FFF2-40B4-BE49-F238E27FC236}">
-                <a16:creationId xmlns:a16="http://schemas.microsoft.com/office/drawing/2014/main" id="{AF27D6F0-07F5-2846-EF4F-B6B0888469BD}"/>
-              </a:ext>
-            </a:extLst>
-          </p:cNvPr>
-          <p:cNvSpPr>
-            <a:spLocks noGrp="1"/>
-          </p:cNvSpPr>
-          <p:nvPr>
-            <p:ph idx="1"/>
-          </p:nvPr>
-        </p:nvSpPr>
-        <p:spPr>
-          <a:xfrm>
-            <a:off x="838200" y="1549839"/>
-            <a:ext cx="10515600" cy="4627124"/>
-          </a:xfrm>
-        </p:spPr>
-        <p:txBody>
-          <a:bodyPr>
-            <a:normAutofit/>
-          </a:bodyPr>
-          <a:lstStyle/>
-          <a:p>
-            <a:pPr marL="0" indent="0">
-              <a:buNone/>
-            </a:pPr>
-            <a:r>
-              <a:rPr lang="ko-KR" altLang="en-US" sz="4000" b="1" dirty="0">
-                <a:solidFill>
-                  <a:srgbClr val="FF0000"/>
-                </a:solidFill>
-              </a:rPr>
-              <a:t>정답</a:t>
-            </a:r>
-            <a:endParaRPr lang="en-US" altLang="ko-KR" sz="4000" b="1" dirty="0">
-              <a:solidFill>
-                <a:srgbClr val="FF0000"/>
-              </a:solidFill>
-            </a:endParaRPr>
-          </a:p>
-        </p:txBody>
-      </p:sp>
-      <p:pic>
-        <p:nvPicPr>
-          <p:cNvPr id="9" name="그림 8">
-            <a:extLst>
-              <a:ext uri="{FF2B5EF4-FFF2-40B4-BE49-F238E27FC236}">
-                <a16:creationId xmlns:a16="http://schemas.microsoft.com/office/drawing/2014/main" id="{A8AAABEC-F115-3CFF-3658-84B5C3EBF9C3}"/>
-              </a:ext>
-            </a:extLst>
-          </p:cNvPr>
-          <p:cNvPicPr>
-            <a:picLocks noChangeAspect="1"/>
-          </p:cNvPicPr>
-          <p:nvPr/>
-        </p:nvPicPr>
-        <p:blipFill>
-          <a:blip r:embed="rId3"/>
-          <a:stretch>
-            <a:fillRect/>
-          </a:stretch>
-        </p:blipFill>
-        <p:spPr>
-          <a:xfrm>
-            <a:off x="3868737" y="1382139"/>
-            <a:ext cx="6105525" cy="4962525"/>
-          </a:xfrm>
-          <a:prstGeom prst="rect">
-            <a:avLst/>
-          </a:prstGeom>
-        </p:spPr>
-      </p:pic>
-    </p:spTree>
-    <p:extLst>
-      <p:ext uri="{BB962C8B-B14F-4D97-AF65-F5344CB8AC3E}">
-        <p14:creationId xmlns:p14="http://schemas.microsoft.com/office/powerpoint/2010/main" val="2414460316"/>
       </p:ext>
     </p:extLst>
   </p:cSld>
@@ -24125,6 +24280,196 @@
         <p:cNvPr id="1" name="">
           <a:extLst>
             <a:ext uri="{FF2B5EF4-FFF2-40B4-BE49-F238E27FC236}">
+              <a16:creationId xmlns:a16="http://schemas.microsoft.com/office/drawing/2014/main" id="{42A751D3-9F90-EC32-4511-9E18BE6C8D78}"/>
+            </a:ext>
+          </a:extLst>
+        </p:cNvPr>
+        <p:cNvGrpSpPr/>
+        <p:nvPr/>
+      </p:nvGrpSpPr>
+      <p:grpSpPr>
+        <a:xfrm>
+          <a:off x="0" y="0"/>
+          <a:ext cx="0" cy="0"/>
+          <a:chOff x="0" y="0"/>
+          <a:chExt cx="0" cy="0"/>
+        </a:xfrm>
+      </p:grpSpPr>
+      <p:sp>
+        <p:nvSpPr>
+          <p:cNvPr id="2" name="제목 1">
+            <a:extLst>
+              <a:ext uri="{FF2B5EF4-FFF2-40B4-BE49-F238E27FC236}">
+                <a16:creationId xmlns:a16="http://schemas.microsoft.com/office/drawing/2014/main" id="{56FE2324-7080-703D-BA44-9FE20F286CD9}"/>
+              </a:ext>
+            </a:extLst>
+          </p:cNvPr>
+          <p:cNvSpPr>
+            <a:spLocks noGrp="1"/>
+          </p:cNvSpPr>
+          <p:nvPr>
+            <p:ph type="title"/>
+          </p:nvPr>
+        </p:nvSpPr>
+        <p:spPr/>
+        <p:txBody>
+          <a:bodyPr>
+            <a:normAutofit/>
+          </a:bodyPr>
+          <a:lstStyle/>
+          <a:p>
+            <a:r>
+              <a:rPr lang="ko-KR" altLang="en-US" dirty="0" err="1"/>
+              <a:t>피에조</a:t>
+            </a:r>
+            <a:r>
+              <a:rPr lang="ko-KR" altLang="en-US" dirty="0"/>
+              <a:t> </a:t>
+            </a:r>
+            <a:r>
+              <a:rPr lang="ko-KR" altLang="en-US" dirty="0" err="1"/>
+              <a:t>부저</a:t>
+            </a:r>
+            <a:r>
+              <a:rPr lang="ko-KR" altLang="en-US" dirty="0"/>
+              <a:t> </a:t>
+            </a:r>
+            <a:r>
+              <a:rPr lang="en-US" altLang="ko-KR" dirty="0"/>
+              <a:t>Quiz</a:t>
+            </a:r>
+            <a:endParaRPr lang="ko-KR" altLang="en-US" dirty="0"/>
+          </a:p>
+        </p:txBody>
+      </p:sp>
+      <p:sp>
+        <p:nvSpPr>
+          <p:cNvPr id="4" name="슬라이드 번호 개체 틀 3">
+            <a:extLst>
+              <a:ext uri="{FF2B5EF4-FFF2-40B4-BE49-F238E27FC236}">
+                <a16:creationId xmlns:a16="http://schemas.microsoft.com/office/drawing/2014/main" id="{50B40CA8-9311-FE7B-4020-1B1343735490}"/>
+              </a:ext>
+            </a:extLst>
+          </p:cNvPr>
+          <p:cNvSpPr>
+            <a:spLocks noGrp="1"/>
+          </p:cNvSpPr>
+          <p:nvPr>
+            <p:ph type="sldNum" sz="quarter" idx="12"/>
+          </p:nvPr>
+        </p:nvSpPr>
+        <p:spPr/>
+        <p:txBody>
+          <a:bodyPr/>
+          <a:lstStyle/>
+          <a:p>
+            <a:fld id="{083A2CE0-18CD-4102-B738-4ACFF9E68BA4}" type="slidenum">
+              <a:rPr lang="ko-KR" altLang="en-US" smtClean="0"/>
+              <a:pPr/>
+              <a:t>40</a:t>
+            </a:fld>
+            <a:endParaRPr lang="ko-KR" altLang="en-US" dirty="0"/>
+          </a:p>
+        </p:txBody>
+      </p:sp>
+      <p:sp>
+        <p:nvSpPr>
+          <p:cNvPr id="7" name="내용 개체 틀 5">
+            <a:extLst>
+              <a:ext uri="{FF2B5EF4-FFF2-40B4-BE49-F238E27FC236}">
+                <a16:creationId xmlns:a16="http://schemas.microsoft.com/office/drawing/2014/main" id="{AF27D6F0-07F5-2846-EF4F-B6B0888469BD}"/>
+              </a:ext>
+            </a:extLst>
+          </p:cNvPr>
+          <p:cNvSpPr>
+            <a:spLocks noGrp="1"/>
+          </p:cNvSpPr>
+          <p:nvPr>
+            <p:ph idx="1"/>
+          </p:nvPr>
+        </p:nvSpPr>
+        <p:spPr>
+          <a:xfrm>
+            <a:off x="838200" y="1549839"/>
+            <a:ext cx="10515600" cy="4627124"/>
+          </a:xfrm>
+        </p:spPr>
+        <p:txBody>
+          <a:bodyPr>
+            <a:normAutofit/>
+          </a:bodyPr>
+          <a:lstStyle/>
+          <a:p>
+            <a:pPr marL="0" indent="0">
+              <a:buNone/>
+            </a:pPr>
+            <a:r>
+              <a:rPr lang="ko-KR" altLang="en-US" sz="4000" b="1" dirty="0">
+                <a:solidFill>
+                  <a:srgbClr val="FF0000"/>
+                </a:solidFill>
+              </a:rPr>
+              <a:t>정답</a:t>
+            </a:r>
+            <a:endParaRPr lang="en-US" altLang="ko-KR" sz="4000" b="1" dirty="0">
+              <a:solidFill>
+                <a:srgbClr val="FF0000"/>
+              </a:solidFill>
+            </a:endParaRPr>
+          </a:p>
+        </p:txBody>
+      </p:sp>
+      <p:pic>
+        <p:nvPicPr>
+          <p:cNvPr id="9" name="그림 8">
+            <a:extLst>
+              <a:ext uri="{FF2B5EF4-FFF2-40B4-BE49-F238E27FC236}">
+                <a16:creationId xmlns:a16="http://schemas.microsoft.com/office/drawing/2014/main" id="{A8AAABEC-F115-3CFF-3658-84B5C3EBF9C3}"/>
+              </a:ext>
+            </a:extLst>
+          </p:cNvPr>
+          <p:cNvPicPr>
+            <a:picLocks noChangeAspect="1"/>
+          </p:cNvPicPr>
+          <p:nvPr/>
+        </p:nvPicPr>
+        <p:blipFill>
+          <a:blip r:embed="rId3"/>
+          <a:stretch>
+            <a:fillRect/>
+          </a:stretch>
+        </p:blipFill>
+        <p:spPr>
+          <a:xfrm>
+            <a:off x="3868737" y="1382139"/>
+            <a:ext cx="6105525" cy="4962525"/>
+          </a:xfrm>
+          <a:prstGeom prst="rect">
+            <a:avLst/>
+          </a:prstGeom>
+        </p:spPr>
+      </p:pic>
+    </p:spTree>
+    <p:extLst>
+      <p:ext uri="{BB962C8B-B14F-4D97-AF65-F5344CB8AC3E}">
+        <p14:creationId xmlns:p14="http://schemas.microsoft.com/office/powerpoint/2010/main" val="2414460316"/>
+      </p:ext>
+    </p:extLst>
+  </p:cSld>
+  <p:clrMapOvr>
+    <a:masterClrMapping/>
+  </p:clrMapOvr>
+</p:sld>
+</file>
+
+<file path=ppt/slides/slide41.xml><?xml version="1.0" encoding="utf-8"?>
+<p:sld xmlns:a="http://schemas.openxmlformats.org/drawingml/2006/main" xmlns:r="http://schemas.openxmlformats.org/officeDocument/2006/relationships" xmlns:p="http://schemas.openxmlformats.org/presentationml/2006/main">
+  <p:cSld>
+    <p:spTree>
+      <p:nvGrpSpPr>
+        <p:cNvPr id="1" name="">
+          <a:extLst>
+            <a:ext uri="{FF2B5EF4-FFF2-40B4-BE49-F238E27FC236}">
               <a16:creationId xmlns:a16="http://schemas.microsoft.com/office/drawing/2014/main" id="{36F20BC3-9ECB-983B-0A5B-A4582BA17091}"/>
             </a:ext>
           </a:extLst>
@@ -24211,7 +24556,7 @@
             <a:fld id="{083A2CE0-18CD-4102-B738-4ACFF9E68BA4}" type="slidenum">
               <a:rPr lang="ko-KR" altLang="en-US" smtClean="0"/>
               <a:pPr/>
-              <a:t>40</a:t>
+              <a:t>41</a:t>
             </a:fld>
             <a:endParaRPr lang="ko-KR" altLang="en-US" dirty="0"/>
           </a:p>
@@ -24308,7 +24653,7 @@
 </p:sld>
 </file>
 
-<file path=ppt/slides/slide41.xml><?xml version="1.0" encoding="utf-8"?>
+<file path=ppt/slides/slide42.xml><?xml version="1.0" encoding="utf-8"?>
 <p:sld xmlns:a="http://schemas.openxmlformats.org/drawingml/2006/main" xmlns:r="http://schemas.openxmlformats.org/officeDocument/2006/relationships" xmlns:p="http://schemas.openxmlformats.org/presentationml/2006/main">
   <p:cSld>
     <p:spTree>
@@ -24550,7 +24895,7 @@
 </p:sld>
 </file>
 
-<file path=ppt/slides/slide42.xml><?xml version="1.0" encoding="utf-8"?>
+<file path=ppt/slides/slide43.xml><?xml version="1.0" encoding="utf-8"?>
 <p:sld xmlns:a="http://schemas.openxmlformats.org/drawingml/2006/main" xmlns:r="http://schemas.openxmlformats.org/officeDocument/2006/relationships" xmlns:p="http://schemas.openxmlformats.org/presentationml/2006/main">
   <p:cSld>
     <p:spTree>
@@ -24786,7 +25131,7 @@
 </p:sld>
 </file>
 
-<file path=ppt/slides/slide43.xml><?xml version="1.0" encoding="utf-8"?>
+<file path=ppt/slides/slide44.xml><?xml version="1.0" encoding="utf-8"?>
 <p:sld xmlns:a="http://schemas.openxmlformats.org/drawingml/2006/main" xmlns:r="http://schemas.openxmlformats.org/officeDocument/2006/relationships" xmlns:p="http://schemas.openxmlformats.org/presentationml/2006/main">
   <p:cSld>
     <p:spTree>
@@ -24941,7 +25286,7 @@
 </p:sld>
 </file>
 
-<file path=ppt/slides/slide44.xml><?xml version="1.0" encoding="utf-8"?>
+<file path=ppt/slides/slide45.xml><?xml version="1.0" encoding="utf-8"?>
 <p:sld xmlns:a="http://schemas.openxmlformats.org/drawingml/2006/main" xmlns:r="http://schemas.openxmlformats.org/officeDocument/2006/relationships" xmlns:p="http://schemas.openxmlformats.org/presentationml/2006/main">
   <p:cSld>
     <p:spTree>
@@ -25095,7 +25440,7 @@
 </p:sld>
 </file>
 
-<file path=ppt/slides/slide45.xml><?xml version="1.0" encoding="utf-8"?>
+<file path=ppt/slides/slide46.xml><?xml version="1.0" encoding="utf-8"?>
 <p:sld xmlns:a="http://schemas.openxmlformats.org/drawingml/2006/main" xmlns:r="http://schemas.openxmlformats.org/officeDocument/2006/relationships" xmlns:p="http://schemas.openxmlformats.org/presentationml/2006/main">
   <p:cSld>
     <p:spTree>
@@ -25804,7 +26149,7 @@
 </p:sld>
 </file>
 
-<file path=ppt/slides/slide46.xml><?xml version="1.0" encoding="utf-8"?>
+<file path=ppt/slides/slide47.xml><?xml version="1.0" encoding="utf-8"?>
 <p:sld xmlns:a="http://schemas.openxmlformats.org/drawingml/2006/main" xmlns:r="http://schemas.openxmlformats.org/officeDocument/2006/relationships" xmlns:p="http://schemas.openxmlformats.org/presentationml/2006/main">
   <p:cSld>
     <p:spTree>
@@ -25886,7 +26231,7 @@
             <a:fld id="{083A2CE0-18CD-4102-B738-4ACFF9E68BA4}" type="slidenum">
               <a:rPr lang="ko-KR" altLang="en-US" smtClean="0"/>
               <a:pPr/>
-              <a:t>46</a:t>
+              <a:t>47</a:t>
             </a:fld>
             <a:endParaRPr lang="ko-KR" altLang="en-US" dirty="0"/>
           </a:p>
@@ -25982,7 +26327,7 @@
 </p:sld>
 </file>
 
-<file path=ppt/slides/slide47.xml><?xml version="1.0" encoding="utf-8"?>
+<file path=ppt/slides/slide48.xml><?xml version="1.0" encoding="utf-8"?>
 <p:sld xmlns:a="http://schemas.openxmlformats.org/drawingml/2006/main" xmlns:r="http://schemas.openxmlformats.org/officeDocument/2006/relationships" xmlns:p="http://schemas.openxmlformats.org/presentationml/2006/main">
   <p:cSld>
     <p:spTree>
@@ -26064,7 +26409,7 @@
             <a:fld id="{083A2CE0-18CD-4102-B738-4ACFF9E68BA4}" type="slidenum">
               <a:rPr lang="ko-KR" altLang="en-US" smtClean="0"/>
               <a:pPr/>
-              <a:t>47</a:t>
+              <a:t>48</a:t>
             </a:fld>
             <a:endParaRPr lang="ko-KR" altLang="en-US" dirty="0"/>
           </a:p>
@@ -26160,7 +26505,7 @@
 </p:sld>
 </file>
 
-<file path=ppt/slides/slide48.xml><?xml version="1.0" encoding="utf-8"?>
+<file path=ppt/slides/slide49.xml><?xml version="1.0" encoding="utf-8"?>
 <p:sld xmlns:a="http://schemas.openxmlformats.org/drawingml/2006/main" xmlns:r="http://schemas.openxmlformats.org/officeDocument/2006/relationships" xmlns:p="http://schemas.openxmlformats.org/presentationml/2006/main" show="0">
   <p:cSld>
     <p:spTree>
@@ -26242,7 +26587,7 @@
             <a:fld id="{083A2CE0-18CD-4102-B738-4ACFF9E68BA4}" type="slidenum">
               <a:rPr lang="ko-KR" altLang="en-US" smtClean="0"/>
               <a:pPr/>
-              <a:t>48</a:t>
+              <a:t>49</a:t>
             </a:fld>
             <a:endParaRPr lang="ko-KR" altLang="en-US" dirty="0"/>
           </a:p>
@@ -26379,206 +26724,6 @@
     <p:extLst>
       <p:ext uri="{BB962C8B-B14F-4D97-AF65-F5344CB8AC3E}">
         <p14:creationId xmlns:p14="http://schemas.microsoft.com/office/powerpoint/2010/main" val="3733798826"/>
-      </p:ext>
-    </p:extLst>
-  </p:cSld>
-  <p:clrMapOvr>
-    <a:masterClrMapping/>
-  </p:clrMapOvr>
-</p:sld>
-</file>
-
-<file path=ppt/slides/slide49.xml><?xml version="1.0" encoding="utf-8"?>
-<p:sld xmlns:a="http://schemas.openxmlformats.org/drawingml/2006/main" xmlns:r="http://schemas.openxmlformats.org/officeDocument/2006/relationships" xmlns:p="http://schemas.openxmlformats.org/presentationml/2006/main">
-  <p:cSld>
-    <p:spTree>
-      <p:nvGrpSpPr>
-        <p:cNvPr id="1" name="">
-          <a:extLst>
-            <a:ext uri="{FF2B5EF4-FFF2-40B4-BE49-F238E27FC236}">
-              <a16:creationId xmlns:a16="http://schemas.microsoft.com/office/drawing/2014/main" id="{08109D6B-22D3-170D-BC86-E8C10173779C}"/>
-            </a:ext>
-          </a:extLst>
-        </p:cNvPr>
-        <p:cNvGrpSpPr/>
-        <p:nvPr/>
-      </p:nvGrpSpPr>
-      <p:grpSpPr>
-        <a:xfrm>
-          <a:off x="0" y="0"/>
-          <a:ext cx="0" cy="0"/>
-          <a:chOff x="0" y="0"/>
-          <a:chExt cx="0" cy="0"/>
-        </a:xfrm>
-      </p:grpSpPr>
-      <p:sp>
-        <p:nvSpPr>
-          <p:cNvPr id="2" name="제목 1">
-            <a:extLst>
-              <a:ext uri="{FF2B5EF4-FFF2-40B4-BE49-F238E27FC236}">
-                <a16:creationId xmlns:a16="http://schemas.microsoft.com/office/drawing/2014/main" id="{9B693180-A605-77E0-2C8B-16DA66CDCCB9}"/>
-              </a:ext>
-            </a:extLst>
-          </p:cNvPr>
-          <p:cNvSpPr>
-            <a:spLocks noGrp="1"/>
-          </p:cNvSpPr>
-          <p:nvPr>
-            <p:ph type="title"/>
-          </p:nvPr>
-        </p:nvSpPr>
-        <p:spPr/>
-        <p:txBody>
-          <a:bodyPr/>
-          <a:lstStyle/>
-          <a:p>
-            <a:r>
-              <a:rPr lang="ko-KR" altLang="en-US" dirty="0"/>
-              <a:t>조도 센서</a:t>
-            </a:r>
-          </a:p>
-        </p:txBody>
-      </p:sp>
-      <p:sp>
-        <p:nvSpPr>
-          <p:cNvPr id="8" name="TextBox 7">
-            <a:extLst>
-              <a:ext uri="{FF2B5EF4-FFF2-40B4-BE49-F238E27FC236}">
-                <a16:creationId xmlns:a16="http://schemas.microsoft.com/office/drawing/2014/main" id="{5C7BE079-378D-C4EE-D43F-9E152CD92A35}"/>
-              </a:ext>
-            </a:extLst>
-          </p:cNvPr>
-          <p:cNvSpPr txBox="1"/>
-          <p:nvPr/>
-        </p:nvSpPr>
-        <p:spPr>
-          <a:xfrm>
-            <a:off x="6096000" y="1730405"/>
-            <a:ext cx="4216474" cy="369332"/>
-          </a:xfrm>
-          <a:prstGeom prst="rect">
-            <a:avLst/>
-          </a:prstGeom>
-          <a:noFill/>
-        </p:spPr>
-        <p:txBody>
-          <a:bodyPr wrap="square" rtlCol="0">
-            <a:spAutoFit/>
-          </a:bodyPr>
-          <a:lstStyle/>
-          <a:p>
-            <a:endParaRPr lang="en-US" altLang="ko-KR" dirty="0">
-              <a:latin typeface="G마켓 산스 TTF Medium" panose="02000000000000000000" pitchFamily="2" charset="-127"/>
-              <a:ea typeface="G마켓 산스 TTF Medium" panose="02000000000000000000" pitchFamily="2" charset="-127"/>
-            </a:endParaRPr>
-          </a:p>
-        </p:txBody>
-      </p:sp>
-      <p:sp>
-        <p:nvSpPr>
-          <p:cNvPr id="10" name="내용 개체 틀 2">
-            <a:extLst>
-              <a:ext uri="{FF2B5EF4-FFF2-40B4-BE49-F238E27FC236}">
-                <a16:creationId xmlns:a16="http://schemas.microsoft.com/office/drawing/2014/main" id="{88B81D1A-E019-5082-DE63-F0B8CCC1F100}"/>
-              </a:ext>
-            </a:extLst>
-          </p:cNvPr>
-          <p:cNvSpPr>
-            <a:spLocks noGrp="1"/>
-          </p:cNvSpPr>
-          <p:nvPr>
-            <p:ph idx="1"/>
-          </p:nvPr>
-        </p:nvSpPr>
-        <p:spPr>
-          <a:xfrm>
-            <a:off x="5603760" y="1884556"/>
-            <a:ext cx="5861280" cy="4292406"/>
-          </a:xfrm>
-        </p:spPr>
-        <p:txBody>
-          <a:bodyPr>
-            <a:normAutofit/>
-          </a:bodyPr>
-          <a:lstStyle/>
-          <a:p>
-            <a:r>
-              <a:rPr lang="ko-KR" altLang="en-US" sz="2000" dirty="0"/>
-              <a:t>주변 밝기를 측정하여 측정된 빛의 세기에 따라 저항 값이 변하는 센서</a:t>
-            </a:r>
-            <a:endParaRPr lang="en-US" altLang="ko-KR" sz="2000" dirty="0"/>
-          </a:p>
-          <a:p>
-            <a:r>
-              <a:rPr lang="ko-KR" altLang="en-US" sz="2000" dirty="0"/>
-              <a:t>빛이 강하면 저항 값이 작아지고</a:t>
-            </a:r>
-            <a:r>
-              <a:rPr lang="en-US" altLang="ko-KR" sz="2000" dirty="0"/>
-              <a:t>, </a:t>
-            </a:r>
-            <a:r>
-              <a:rPr lang="ko-KR" altLang="en-US" sz="2000" dirty="0"/>
-              <a:t>빛이 약하면 저항 값이 커진다</a:t>
-            </a:r>
-            <a:r>
-              <a:rPr lang="en-US" altLang="ko-KR" sz="2000" dirty="0"/>
-              <a:t>.</a:t>
-            </a:r>
-          </a:p>
-        </p:txBody>
-      </p:sp>
-      <p:pic>
-        <p:nvPicPr>
-          <p:cNvPr id="48132" name="Picture 4" descr="조도센서 CDS 황화카드뮴셀 7파이 GM7537-1 / 인투피온">
-            <a:extLst>
-              <a:ext uri="{FF2B5EF4-FFF2-40B4-BE49-F238E27FC236}">
-                <a16:creationId xmlns:a16="http://schemas.microsoft.com/office/drawing/2014/main" id="{9876772E-0DDA-152E-BC2E-4F26380CBAEE}"/>
-              </a:ext>
-            </a:extLst>
-          </p:cNvPr>
-          <p:cNvPicPr>
-            <a:picLocks noChangeAspect="1" noChangeArrowheads="1"/>
-          </p:cNvPicPr>
-          <p:nvPr/>
-        </p:nvPicPr>
-        <p:blipFill rotWithShape="1">
-          <a:blip r:embed="rId3">
-            <a:extLst>
-              <a:ext uri="{28A0092B-C50C-407E-A947-70E740481C1C}">
-                <a14:useLocalDpi xmlns:a14="http://schemas.microsoft.com/office/drawing/2010/main" val="0"/>
-              </a:ext>
-            </a:extLst>
-          </a:blip>
-          <a:srcRect l="17222" t="30617" r="12037" b="24444"/>
-          <a:stretch>
-            <a:fillRect/>
-          </a:stretch>
-        </p:blipFill>
-        <p:spPr bwMode="auto">
-          <a:xfrm>
-            <a:off x="1069860" y="2129728"/>
-            <a:ext cx="4090569" cy="2598544"/>
-          </a:xfrm>
-          <a:prstGeom prst="rect">
-            <a:avLst/>
-          </a:prstGeom>
-          <a:noFill/>
-          <a:extLst>
-            <a:ext uri="{909E8E84-426E-40DD-AFC4-6F175D3DCCD1}">
-              <a14:hiddenFill xmlns:a14="http://schemas.microsoft.com/office/drawing/2010/main">
-                <a:solidFill>
-                  <a:srgbClr val="FFFFFF"/>
-                </a:solidFill>
-              </a14:hiddenFill>
-            </a:ext>
-          </a:extLst>
-        </p:spPr>
-      </p:pic>
-    </p:spTree>
-    <p:extLst>
-      <p:ext uri="{BB962C8B-B14F-4D97-AF65-F5344CB8AC3E}">
-        <p14:creationId xmlns:p14="http://schemas.microsoft.com/office/powerpoint/2010/main" val="3081486000"/>
       </p:ext>
     </p:extLst>
   </p:cSld>
@@ -27440,6 +27585,206 @@
         <p:cNvPr id="1" name="">
           <a:extLst>
             <a:ext uri="{FF2B5EF4-FFF2-40B4-BE49-F238E27FC236}">
+              <a16:creationId xmlns:a16="http://schemas.microsoft.com/office/drawing/2014/main" id="{08109D6B-22D3-170D-BC86-E8C10173779C}"/>
+            </a:ext>
+          </a:extLst>
+        </p:cNvPr>
+        <p:cNvGrpSpPr/>
+        <p:nvPr/>
+      </p:nvGrpSpPr>
+      <p:grpSpPr>
+        <a:xfrm>
+          <a:off x="0" y="0"/>
+          <a:ext cx="0" cy="0"/>
+          <a:chOff x="0" y="0"/>
+          <a:chExt cx="0" cy="0"/>
+        </a:xfrm>
+      </p:grpSpPr>
+      <p:sp>
+        <p:nvSpPr>
+          <p:cNvPr id="2" name="제목 1">
+            <a:extLst>
+              <a:ext uri="{FF2B5EF4-FFF2-40B4-BE49-F238E27FC236}">
+                <a16:creationId xmlns:a16="http://schemas.microsoft.com/office/drawing/2014/main" id="{9B693180-A605-77E0-2C8B-16DA66CDCCB9}"/>
+              </a:ext>
+            </a:extLst>
+          </p:cNvPr>
+          <p:cNvSpPr>
+            <a:spLocks noGrp="1"/>
+          </p:cNvSpPr>
+          <p:nvPr>
+            <p:ph type="title"/>
+          </p:nvPr>
+        </p:nvSpPr>
+        <p:spPr/>
+        <p:txBody>
+          <a:bodyPr/>
+          <a:lstStyle/>
+          <a:p>
+            <a:r>
+              <a:rPr lang="ko-KR" altLang="en-US" dirty="0"/>
+              <a:t>조도 센서</a:t>
+            </a:r>
+          </a:p>
+        </p:txBody>
+      </p:sp>
+      <p:sp>
+        <p:nvSpPr>
+          <p:cNvPr id="8" name="TextBox 7">
+            <a:extLst>
+              <a:ext uri="{FF2B5EF4-FFF2-40B4-BE49-F238E27FC236}">
+                <a16:creationId xmlns:a16="http://schemas.microsoft.com/office/drawing/2014/main" id="{5C7BE079-378D-C4EE-D43F-9E152CD92A35}"/>
+              </a:ext>
+            </a:extLst>
+          </p:cNvPr>
+          <p:cNvSpPr txBox="1"/>
+          <p:nvPr/>
+        </p:nvSpPr>
+        <p:spPr>
+          <a:xfrm>
+            <a:off x="6096000" y="1730405"/>
+            <a:ext cx="4216474" cy="369332"/>
+          </a:xfrm>
+          <a:prstGeom prst="rect">
+            <a:avLst/>
+          </a:prstGeom>
+          <a:noFill/>
+        </p:spPr>
+        <p:txBody>
+          <a:bodyPr wrap="square" rtlCol="0">
+            <a:spAutoFit/>
+          </a:bodyPr>
+          <a:lstStyle/>
+          <a:p>
+            <a:endParaRPr lang="en-US" altLang="ko-KR" dirty="0">
+              <a:latin typeface="G마켓 산스 TTF Medium" panose="02000000000000000000" pitchFamily="2" charset="-127"/>
+              <a:ea typeface="G마켓 산스 TTF Medium" panose="02000000000000000000" pitchFamily="2" charset="-127"/>
+            </a:endParaRPr>
+          </a:p>
+        </p:txBody>
+      </p:sp>
+      <p:sp>
+        <p:nvSpPr>
+          <p:cNvPr id="10" name="내용 개체 틀 2">
+            <a:extLst>
+              <a:ext uri="{FF2B5EF4-FFF2-40B4-BE49-F238E27FC236}">
+                <a16:creationId xmlns:a16="http://schemas.microsoft.com/office/drawing/2014/main" id="{88B81D1A-E019-5082-DE63-F0B8CCC1F100}"/>
+              </a:ext>
+            </a:extLst>
+          </p:cNvPr>
+          <p:cNvSpPr>
+            <a:spLocks noGrp="1"/>
+          </p:cNvSpPr>
+          <p:nvPr>
+            <p:ph idx="1"/>
+          </p:nvPr>
+        </p:nvSpPr>
+        <p:spPr>
+          <a:xfrm>
+            <a:off x="5603760" y="1884556"/>
+            <a:ext cx="5861280" cy="4292406"/>
+          </a:xfrm>
+        </p:spPr>
+        <p:txBody>
+          <a:bodyPr>
+            <a:normAutofit/>
+          </a:bodyPr>
+          <a:lstStyle/>
+          <a:p>
+            <a:r>
+              <a:rPr lang="ko-KR" altLang="en-US" sz="2000" dirty="0"/>
+              <a:t>주변 밝기를 측정하여 측정된 빛의 세기에 따라 저항 값이 변하는 센서</a:t>
+            </a:r>
+            <a:endParaRPr lang="en-US" altLang="ko-KR" sz="2000" dirty="0"/>
+          </a:p>
+          <a:p>
+            <a:r>
+              <a:rPr lang="ko-KR" altLang="en-US" sz="2000" dirty="0"/>
+              <a:t>빛이 강하면 저항 값이 작아지고</a:t>
+            </a:r>
+            <a:r>
+              <a:rPr lang="en-US" altLang="ko-KR" sz="2000" dirty="0"/>
+              <a:t>, </a:t>
+            </a:r>
+            <a:r>
+              <a:rPr lang="ko-KR" altLang="en-US" sz="2000" dirty="0"/>
+              <a:t>빛이 약하면 저항 값이 커진다</a:t>
+            </a:r>
+            <a:r>
+              <a:rPr lang="en-US" altLang="ko-KR" sz="2000" dirty="0"/>
+              <a:t>.</a:t>
+            </a:r>
+          </a:p>
+        </p:txBody>
+      </p:sp>
+      <p:pic>
+        <p:nvPicPr>
+          <p:cNvPr id="48132" name="Picture 4" descr="조도센서 CDS 황화카드뮴셀 7파이 GM7537-1 / 인투피온">
+            <a:extLst>
+              <a:ext uri="{FF2B5EF4-FFF2-40B4-BE49-F238E27FC236}">
+                <a16:creationId xmlns:a16="http://schemas.microsoft.com/office/drawing/2014/main" id="{9876772E-0DDA-152E-BC2E-4F26380CBAEE}"/>
+              </a:ext>
+            </a:extLst>
+          </p:cNvPr>
+          <p:cNvPicPr>
+            <a:picLocks noChangeAspect="1" noChangeArrowheads="1"/>
+          </p:cNvPicPr>
+          <p:nvPr/>
+        </p:nvPicPr>
+        <p:blipFill rotWithShape="1">
+          <a:blip r:embed="rId3">
+            <a:extLst>
+              <a:ext uri="{28A0092B-C50C-407E-A947-70E740481C1C}">
+                <a14:useLocalDpi xmlns:a14="http://schemas.microsoft.com/office/drawing/2010/main" val="0"/>
+              </a:ext>
+            </a:extLst>
+          </a:blip>
+          <a:srcRect l="17222" t="30617" r="12037" b="24444"/>
+          <a:stretch>
+            <a:fillRect/>
+          </a:stretch>
+        </p:blipFill>
+        <p:spPr bwMode="auto">
+          <a:xfrm>
+            <a:off x="1069860" y="2129728"/>
+            <a:ext cx="4090569" cy="2598544"/>
+          </a:xfrm>
+          <a:prstGeom prst="rect">
+            <a:avLst/>
+          </a:prstGeom>
+          <a:noFill/>
+          <a:extLst>
+            <a:ext uri="{909E8E84-426E-40DD-AFC4-6F175D3DCCD1}">
+              <a14:hiddenFill xmlns:a14="http://schemas.microsoft.com/office/drawing/2010/main">
+                <a:solidFill>
+                  <a:srgbClr val="FFFFFF"/>
+                </a:solidFill>
+              </a14:hiddenFill>
+            </a:ext>
+          </a:extLst>
+        </p:spPr>
+      </p:pic>
+    </p:spTree>
+    <p:extLst>
+      <p:ext uri="{BB962C8B-B14F-4D97-AF65-F5344CB8AC3E}">
+        <p14:creationId xmlns:p14="http://schemas.microsoft.com/office/powerpoint/2010/main" val="3081486000"/>
+      </p:ext>
+    </p:extLst>
+  </p:cSld>
+  <p:clrMapOvr>
+    <a:masterClrMapping/>
+  </p:clrMapOvr>
+</p:sld>
+</file>
+
+<file path=ppt/slides/slide51.xml><?xml version="1.0" encoding="utf-8"?>
+<p:sld xmlns:a="http://schemas.openxmlformats.org/drawingml/2006/main" xmlns:r="http://schemas.openxmlformats.org/officeDocument/2006/relationships" xmlns:p="http://schemas.openxmlformats.org/presentationml/2006/main">
+  <p:cSld>
+    <p:spTree>
+      <p:nvGrpSpPr>
+        <p:cNvPr id="1" name="">
+          <a:extLst>
+            <a:ext uri="{FF2B5EF4-FFF2-40B4-BE49-F238E27FC236}">
               <a16:creationId xmlns:a16="http://schemas.microsoft.com/office/drawing/2014/main" id="{E85A0B26-6080-747C-DEF3-E7AAD8E6001E}"/>
             </a:ext>
           </a:extLst>
@@ -27586,7 +27931,7 @@
 </p:sld>
 </file>
 
-<file path=ppt/slides/slide51.xml><?xml version="1.0" encoding="utf-8"?>
+<file path=ppt/slides/slide52.xml><?xml version="1.0" encoding="utf-8"?>
 <p:sld xmlns:a="http://schemas.openxmlformats.org/drawingml/2006/main" xmlns:r="http://schemas.openxmlformats.org/officeDocument/2006/relationships" xmlns:p="http://schemas.openxmlformats.org/presentationml/2006/main">
   <p:cSld>
     <p:spTree>
@@ -27740,7 +28085,7 @@
 </p:sld>
 </file>
 
-<file path=ppt/slides/slide52.xml><?xml version="1.0" encoding="utf-8"?>
+<file path=ppt/slides/slide53.xml><?xml version="1.0" encoding="utf-8"?>
 <p:sld xmlns:a="http://schemas.openxmlformats.org/drawingml/2006/main" xmlns:r="http://schemas.openxmlformats.org/officeDocument/2006/relationships" xmlns:p="http://schemas.openxmlformats.org/presentationml/2006/main">
   <p:cSld>
     <p:spTree>
@@ -28523,7 +28868,7 @@
 </p:sld>
 </file>
 
-<file path=ppt/slides/slide53.xml><?xml version="1.0" encoding="utf-8"?>
+<file path=ppt/slides/slide54.xml><?xml version="1.0" encoding="utf-8"?>
 <p:sld xmlns:a="http://schemas.openxmlformats.org/drawingml/2006/main" xmlns:r="http://schemas.openxmlformats.org/officeDocument/2006/relationships" xmlns:p="http://schemas.openxmlformats.org/presentationml/2006/main">
   <p:cSld>
     <p:spTree>
@@ -28622,7 +28967,7 @@
 </p:sld>
 </file>
 
-<file path=ppt/slides/slide54.xml><?xml version="1.0" encoding="utf-8"?>
+<file path=ppt/slides/slide55.xml><?xml version="1.0" encoding="utf-8"?>
 <p:sld xmlns:a="http://schemas.openxmlformats.org/drawingml/2006/main" xmlns:r="http://schemas.openxmlformats.org/officeDocument/2006/relationships" xmlns:p="http://schemas.openxmlformats.org/presentationml/2006/main">
   <p:cSld>
     <p:spTree>
@@ -28704,7 +29049,7 @@
             <a:fld id="{083A2CE0-18CD-4102-B738-4ACFF9E68BA4}" type="slidenum">
               <a:rPr lang="ko-KR" altLang="en-US" smtClean="0"/>
               <a:pPr/>
-              <a:t>54</a:t>
+              <a:t>55</a:t>
             </a:fld>
             <a:endParaRPr lang="ko-KR" altLang="en-US" dirty="0"/>
           </a:p>
@@ -28800,7 +29145,7 @@
 </p:sld>
 </file>
 
-<file path=ppt/slides/slide55.xml><?xml version="1.0" encoding="utf-8"?>
+<file path=ppt/slides/slide56.xml><?xml version="1.0" encoding="utf-8"?>
 <p:sld xmlns:a="http://schemas.openxmlformats.org/drawingml/2006/main" xmlns:r="http://schemas.openxmlformats.org/officeDocument/2006/relationships" xmlns:p="http://schemas.openxmlformats.org/presentationml/2006/main">
   <p:cSld>
     <p:spTree>
@@ -28882,7 +29227,7 @@
             <a:fld id="{083A2CE0-18CD-4102-B738-4ACFF9E68BA4}" type="slidenum">
               <a:rPr lang="ko-KR" altLang="en-US" smtClean="0"/>
               <a:pPr/>
-              <a:t>55</a:t>
+              <a:t>56</a:t>
             </a:fld>
             <a:endParaRPr lang="ko-KR" altLang="en-US" dirty="0"/>
           </a:p>

</xml_diff>